<commit_message>
cap nhat bao cao
</commit_message>
<xml_diff>
--- a/nguyenb2306564-vib2306600.pptx
+++ b/nguyenb2306564-vib2306600.pptx
@@ -8612,7 +8612,7 @@
         </p:nvGraphicFramePr>
         <p:xfrm>
           <a:off x="304800" y="2057400"/>
-          <a:ext cx="8229600" cy="3656103"/>
+          <a:ext cx="8229600" cy="3930423"/>
         </p:xfrm>
         <a:graphic>
           <a:graphicData uri="http://schemas.openxmlformats.org/drawingml/2006/table">
@@ -9170,7 +9170,7 @@
                         <a:defRPr/>
                       </a:pPr>
                       <a:r>
-                        <a:rPr lang="en-US" sz="1800" b="0" kern="1200" err="1" smtClean="0">
+                        <a:rPr lang="vi-VN" sz="1800" b="0" kern="1200" smtClean="0">
                           <a:solidFill>
                             <a:schemeClr val="dk1"/>
                           </a:solidFill>
@@ -9179,7 +9179,7 @@
                           <a:ea typeface="+mn-ea"/>
                           <a:cs typeface="+mn-cs"/>
                         </a:rPr>
-                        <a:t>Xử</a:t>
+                        <a:t>Xây dựng hệ thống khung, </a:t>
                       </a:r>
                       <a:r>
                         <a:rPr lang="en-US" sz="1800" b="0" kern="1200" smtClean="0">
@@ -9191,7 +9191,7 @@
                           <a:ea typeface="+mn-ea"/>
                           <a:cs typeface="+mn-cs"/>
                         </a:rPr>
-                        <a:t> </a:t>
+                        <a:t>Xử </a:t>
                       </a:r>
                       <a:r>
                         <a:rPr lang="en-US" sz="1800" b="0" kern="1200" err="1" smtClean="0">

</xml_diff>

<commit_message>
fix lỗi đăng ký, hủy đăng ký, học lại
</commit_message>
<xml_diff>
--- a/nguyenb2306564-vib2306600.pptx
+++ b/nguyenb2306564-vib2306600.pptx
@@ -1,32 +1,32 @@
 
 <file path=ppt/presentation.xml><?xml version="1.0" encoding="utf-8"?>
-<p:presentation xmlns:a="http://schemas.openxmlformats.org/drawingml/2006/main" xmlns:r="http://schemas.openxmlformats.org/officeDocument/2006/relationships" xmlns:p="http://schemas.openxmlformats.org/presentationml/2006/main" saveSubsetFonts="1">
+<p:presentation xmlns:a="http://schemas.openxmlformats.org/drawingml/2006/main" xmlns:r="http://schemas.openxmlformats.org/officeDocument/2006/relationships" xmlns:p="http://schemas.openxmlformats.org/presentationml/2006/main">
   <p:sldMasterIdLst>
     <p:sldMasterId id="2147483648" r:id="rId1"/>
   </p:sldMasterIdLst>
   <p:sldIdLst>
-    <p:sldId id="256" r:id="rId2"/>
-    <p:sldId id="263" r:id="rId3"/>
-    <p:sldId id="265" r:id="rId4"/>
-    <p:sldId id="266" r:id="rId5"/>
-    <p:sldId id="267" r:id="rId6"/>
-    <p:sldId id="268" r:id="rId7"/>
-    <p:sldId id="269" r:id="rId8"/>
-    <p:sldId id="270" r:id="rId9"/>
-    <p:sldId id="271" r:id="rId10"/>
-    <p:sldId id="272" r:id="rId11"/>
-    <p:sldId id="273" r:id="rId12"/>
-    <p:sldId id="274" r:id="rId13"/>
-    <p:sldId id="275" r:id="rId14"/>
-    <p:sldId id="276" r:id="rId15"/>
-    <p:sldId id="277" r:id="rId16"/>
-    <p:sldId id="278" r:id="rId17"/>
-    <p:sldId id="279" r:id="rId18"/>
-    <p:sldId id="280" r:id="rId19"/>
-    <p:sldId id="281" r:id="rId20"/>
-    <p:sldId id="282" r:id="rId21"/>
-    <p:sldId id="262" r:id="rId22"/>
-    <p:sldId id="264" r:id="rId23"/>
+    <p:sldId id="256" r:id="rId3"/>
+    <p:sldId id="263" r:id="rId4"/>
+    <p:sldId id="265" r:id="rId5"/>
+    <p:sldId id="266" r:id="rId6"/>
+    <p:sldId id="267" r:id="rId7"/>
+    <p:sldId id="268" r:id="rId8"/>
+    <p:sldId id="269" r:id="rId9"/>
+    <p:sldId id="270" r:id="rId10"/>
+    <p:sldId id="271" r:id="rId11"/>
+    <p:sldId id="272" r:id="rId12"/>
+    <p:sldId id="273" r:id="rId13"/>
+    <p:sldId id="274" r:id="rId14"/>
+    <p:sldId id="275" r:id="rId15"/>
+    <p:sldId id="276" r:id="rId16"/>
+    <p:sldId id="277" r:id="rId17"/>
+    <p:sldId id="278" r:id="rId18"/>
+    <p:sldId id="279" r:id="rId19"/>
+    <p:sldId id="280" r:id="rId20"/>
+    <p:sldId id="281" r:id="rId21"/>
+    <p:sldId id="282" r:id="rId22"/>
+    <p:sldId id="262" r:id="rId23"/>
+    <p:sldId id="264" r:id="rId24"/>
   </p:sldIdLst>
   <p:sldSz cx="9144000" cy="6858000" type="screen4x3"/>
   <p:notesSz cx="6858000" cy="9144000"/>
@@ -158,12 +158,12 @@
   <p:extLst>
     <p:ext uri="{EFAFB233-063F-42B5-8137-9DF3F51BA10A}">
       <p15:sldGuideLst xmlns:p15="http://schemas.microsoft.com/office/powerpoint/2012/main">
-        <p15:guide id="1" orient="horz" pos="2160">
+        <p15:guide id="1" orient="horz" pos="2160" userDrawn="1">
           <p15:clr>
             <a:srgbClr val="A4A3A4"/>
           </p15:clr>
         </p15:guide>
-        <p15:guide id="2" pos="2880">
+        <p15:guide id="2" pos="2880" userDrawn="1">
           <p15:clr>
             <a:srgbClr val="A4A3A4"/>
           </p15:clr>
@@ -193,13 +193,7 @@
       </p:grpSpPr>
       <p:sp>
         <p:nvSpPr>
-          <p:cNvPr id="16386" name="Rectangle 2">
-            <a:extLst>
-              <a:ext uri="{FF2B5EF4-FFF2-40B4-BE49-F238E27FC236}">
-                <a16:creationId xmlns:a16="http://schemas.microsoft.com/office/drawing/2014/main" xmlns="" id="{12716CEC-4EB7-4AF5-B8B4-13A4AA74F184}"/>
-              </a:ext>
-            </a:extLst>
-          </p:cNvPr>
+          <p:cNvPr id="16386" name="Rectangle 2"/>
           <p:cNvSpPr>
             <a:spLocks noGrp="1" noChangeArrowheads="1"/>
           </p:cNvSpPr>
@@ -226,18 +220,13 @@
               <a:rPr lang="en-US" altLang="en-US" noProof="0"/>
               <a:t>Click to edit Master title style</a:t>
             </a:r>
-          </a:p>
-        </p:txBody>
-      </p:sp>
-      <p:sp>
-        <p:nvSpPr>
-          <p:cNvPr id="16387" name="Rectangle 3">
-            <a:extLst>
-              <a:ext uri="{FF2B5EF4-FFF2-40B4-BE49-F238E27FC236}">
-                <a16:creationId xmlns:a16="http://schemas.microsoft.com/office/drawing/2014/main" xmlns="" id="{7A8B1175-CAAE-4DE1-9BCE-EE12E1548589}"/>
-              </a:ext>
-            </a:extLst>
-          </p:cNvPr>
+            <a:endParaRPr lang="en-US" altLang="en-US" noProof="0"/>
+          </a:p>
+        </p:txBody>
+      </p:sp>
+      <p:sp>
+        <p:nvSpPr>
+          <p:cNvPr id="16387" name="Rectangle 3"/>
           <p:cNvSpPr>
             <a:spLocks noGrp="1" noChangeArrowheads="1"/>
           </p:cNvSpPr>
@@ -266,18 +255,13 @@
               <a:rPr lang="en-US" altLang="en-US" noProof="0"/>
               <a:t>Click to edit Master subtitle style</a:t>
             </a:r>
-          </a:p>
-        </p:txBody>
-      </p:sp>
-      <p:sp>
-        <p:nvSpPr>
-          <p:cNvPr id="16388" name="Rectangle 4">
-            <a:extLst>
-              <a:ext uri="{FF2B5EF4-FFF2-40B4-BE49-F238E27FC236}">
-                <a16:creationId xmlns:a16="http://schemas.microsoft.com/office/drawing/2014/main" xmlns="" id="{4EFCFD27-3C59-440E-9355-8E61DE9E9F61}"/>
-              </a:ext>
-            </a:extLst>
-          </p:cNvPr>
+            <a:endParaRPr lang="en-US" altLang="en-US" noProof="0"/>
+          </a:p>
+        </p:txBody>
+      </p:sp>
+      <p:sp>
+        <p:nvSpPr>
+          <p:cNvPr id="16388" name="Rectangle 4"/>
           <p:cNvSpPr>
             <a:spLocks noGrp="1" noChangeArrowheads="1"/>
           </p:cNvSpPr>
@@ -305,13 +289,7 @@
       </p:sp>
       <p:sp>
         <p:nvSpPr>
-          <p:cNvPr id="16389" name="Rectangle 5">
-            <a:extLst>
-              <a:ext uri="{FF2B5EF4-FFF2-40B4-BE49-F238E27FC236}">
-                <a16:creationId xmlns:a16="http://schemas.microsoft.com/office/drawing/2014/main" xmlns="" id="{18A37AE1-76EA-4F7C-89AE-6531C0C56B99}"/>
-              </a:ext>
-            </a:extLst>
-          </p:cNvPr>
+          <p:cNvPr id="16389" name="Rectangle 5"/>
           <p:cNvSpPr>
             <a:spLocks noGrp="1" noChangeArrowheads="1"/>
           </p:cNvSpPr>
@@ -339,13 +317,7 @@
       </p:sp>
       <p:sp>
         <p:nvSpPr>
-          <p:cNvPr id="16390" name="Rectangle 6">
-            <a:extLst>
-              <a:ext uri="{FF2B5EF4-FFF2-40B4-BE49-F238E27FC236}">
-                <a16:creationId xmlns:a16="http://schemas.microsoft.com/office/drawing/2014/main" xmlns="" id="{E348B9C2-253F-43BD-BBE7-0B49698116D7}"/>
-              </a:ext>
-            </a:extLst>
-          </p:cNvPr>
+          <p:cNvPr id="16390" name="Rectangle 6"/>
           <p:cNvSpPr>
             <a:spLocks noGrp="1" noChangeArrowheads="1"/>
           </p:cNvSpPr>
@@ -369,8 +341,6 @@
           <a:p>
             <a:fld id="{A15EAB53-327E-4220-A7C8-79A6407182B7}" type="slidenum">
               <a:rPr lang="en-US" altLang="en-US"/>
-              <a:pPr/>
-              <a:t>‹#›</a:t>
             </a:fld>
             <a:endParaRPr lang="en-US" altLang="en-US"/>
           </a:p>
@@ -403,13 +373,7 @@
       </p:grpSpPr>
       <p:sp>
         <p:nvSpPr>
-          <p:cNvPr id="2" name="Title 1">
-            <a:extLst>
-              <a:ext uri="{FF2B5EF4-FFF2-40B4-BE49-F238E27FC236}">
-                <a16:creationId xmlns:a16="http://schemas.microsoft.com/office/drawing/2014/main" xmlns="" id="{EE822BBF-5276-4192-BA57-B0752687F9A4}"/>
-              </a:ext>
-            </a:extLst>
-          </p:cNvPr>
+          <p:cNvPr id="2" name="Title 1"/>
           <p:cNvSpPr>
             <a:spLocks noGrp="1"/>
           </p:cNvSpPr>
@@ -426,18 +390,13 @@
               <a:rPr lang="en-US"/>
               <a:t>Click to edit Master title style</a:t>
             </a:r>
-          </a:p>
-        </p:txBody>
-      </p:sp>
-      <p:sp>
-        <p:nvSpPr>
-          <p:cNvPr id="3" name="Vertical Text Placeholder 2">
-            <a:extLst>
-              <a:ext uri="{FF2B5EF4-FFF2-40B4-BE49-F238E27FC236}">
-                <a16:creationId xmlns:a16="http://schemas.microsoft.com/office/drawing/2014/main" xmlns="" id="{EB8C078B-EB7B-44AD-A4C2-B8DC31D9B6F6}"/>
-              </a:ext>
-            </a:extLst>
-          </p:cNvPr>
+            <a:endParaRPr lang="en-US"/>
+          </a:p>
+        </p:txBody>
+      </p:sp>
+      <p:sp>
+        <p:nvSpPr>
+          <p:cNvPr id="3" name="Vertical Text Placeholder 2"/>
           <p:cNvSpPr>
             <a:spLocks noGrp="1"/>
           </p:cNvSpPr>
@@ -455,6 +414,7 @@
               <a:rPr lang="en-US"/>
               <a:t>Edit Master text styles</a:t>
             </a:r>
+            <a:endParaRPr lang="en-US"/>
           </a:p>
           <a:p>
             <a:pPr lvl="1"/>
@@ -462,6 +422,7 @@
               <a:rPr lang="en-US"/>
               <a:t>Second level</a:t>
             </a:r>
+            <a:endParaRPr lang="en-US"/>
           </a:p>
           <a:p>
             <a:pPr lvl="2"/>
@@ -469,6 +430,7 @@
               <a:rPr lang="en-US"/>
               <a:t>Third level</a:t>
             </a:r>
+            <a:endParaRPr lang="en-US"/>
           </a:p>
           <a:p>
             <a:pPr lvl="3"/>
@@ -476,6 +438,7 @@
               <a:rPr lang="en-US"/>
               <a:t>Fourth level</a:t>
             </a:r>
+            <a:endParaRPr lang="en-US"/>
           </a:p>
           <a:p>
             <a:pPr lvl="4"/>
@@ -483,18 +446,13 @@
               <a:rPr lang="en-US"/>
               <a:t>Fifth level</a:t>
             </a:r>
-          </a:p>
-        </p:txBody>
-      </p:sp>
-      <p:sp>
-        <p:nvSpPr>
-          <p:cNvPr id="4" name="Date Placeholder 3">
-            <a:extLst>
-              <a:ext uri="{FF2B5EF4-FFF2-40B4-BE49-F238E27FC236}">
-                <a16:creationId xmlns:a16="http://schemas.microsoft.com/office/drawing/2014/main" xmlns="" id="{BD07DE7E-9122-41D3-A66E-3CDCBCE9C20E}"/>
-              </a:ext>
-            </a:extLst>
-          </p:cNvPr>
+            <a:endParaRPr lang="en-US"/>
+          </a:p>
+        </p:txBody>
+      </p:sp>
+      <p:sp>
+        <p:nvSpPr>
+          <p:cNvPr id="4" name="Date Placeholder 3"/>
           <p:cNvSpPr>
             <a:spLocks noGrp="1"/>
           </p:cNvSpPr>
@@ -517,13 +475,7 @@
       </p:sp>
       <p:sp>
         <p:nvSpPr>
-          <p:cNvPr id="5" name="Footer Placeholder 4">
-            <a:extLst>
-              <a:ext uri="{FF2B5EF4-FFF2-40B4-BE49-F238E27FC236}">
-                <a16:creationId xmlns:a16="http://schemas.microsoft.com/office/drawing/2014/main" xmlns="" id="{6AF65EA4-62DF-493C-B19B-64550981D578}"/>
-              </a:ext>
-            </a:extLst>
-          </p:cNvPr>
+          <p:cNvPr id="5" name="Footer Placeholder 4"/>
           <p:cNvSpPr>
             <a:spLocks noGrp="1"/>
           </p:cNvSpPr>
@@ -546,13 +498,7 @@
       </p:sp>
       <p:sp>
         <p:nvSpPr>
-          <p:cNvPr id="6" name="Slide Number Placeholder 5">
-            <a:extLst>
-              <a:ext uri="{FF2B5EF4-FFF2-40B4-BE49-F238E27FC236}">
-                <a16:creationId xmlns:a16="http://schemas.microsoft.com/office/drawing/2014/main" xmlns="" id="{564301BB-D36E-4AE2-BE8A-E50EB27CA2B1}"/>
-              </a:ext>
-            </a:extLst>
-          </p:cNvPr>
+          <p:cNvPr id="6" name="Slide Number Placeholder 5"/>
           <p:cNvSpPr>
             <a:spLocks noGrp="1"/>
           </p:cNvSpPr>
@@ -571,19 +517,12 @@
           <a:p>
             <a:fld id="{8B4A5476-CA43-47FE-BA67-73FA2851AFC8}" type="slidenum">
               <a:rPr lang="en-US" altLang="en-US"/>
-              <a:pPr/>
-              <a:t>‹#›</a:t>
             </a:fld>
             <a:endParaRPr lang="en-US" altLang="en-US"/>
           </a:p>
         </p:txBody>
       </p:sp>
     </p:spTree>
-    <p:extLst>
-      <p:ext uri="{BB962C8B-B14F-4D97-AF65-F5344CB8AC3E}">
-        <p14:creationId xmlns:p14="http://schemas.microsoft.com/office/powerpoint/2010/main" val="520917542"/>
-      </p:ext>
-    </p:extLst>
   </p:cSld>
   <p:clrMapOvr>
     <a:masterClrMapping/>
@@ -610,13 +549,7 @@
       </p:grpSpPr>
       <p:sp>
         <p:nvSpPr>
-          <p:cNvPr id="2" name="Vertical Title 1">
-            <a:extLst>
-              <a:ext uri="{FF2B5EF4-FFF2-40B4-BE49-F238E27FC236}">
-                <a16:creationId xmlns:a16="http://schemas.microsoft.com/office/drawing/2014/main" xmlns="" id="{C55C4325-1A15-4599-B036-9FA60518A530}"/>
-              </a:ext>
-            </a:extLst>
-          </p:cNvPr>
+          <p:cNvPr id="2" name="Vertical Title 1"/>
           <p:cNvSpPr>
             <a:spLocks noGrp="1"/>
           </p:cNvSpPr>
@@ -638,18 +571,13 @@
               <a:rPr lang="en-US"/>
               <a:t>Click to edit Master title style</a:t>
             </a:r>
-          </a:p>
-        </p:txBody>
-      </p:sp>
-      <p:sp>
-        <p:nvSpPr>
-          <p:cNvPr id="3" name="Vertical Text Placeholder 2">
-            <a:extLst>
-              <a:ext uri="{FF2B5EF4-FFF2-40B4-BE49-F238E27FC236}">
-                <a16:creationId xmlns:a16="http://schemas.microsoft.com/office/drawing/2014/main" xmlns="" id="{5792199C-8BFD-4358-9055-518928EAE0B9}"/>
-              </a:ext>
-            </a:extLst>
-          </p:cNvPr>
+            <a:endParaRPr lang="en-US"/>
+          </a:p>
+        </p:txBody>
+      </p:sp>
+      <p:sp>
+        <p:nvSpPr>
+          <p:cNvPr id="3" name="Vertical Text Placeholder 2"/>
           <p:cNvSpPr>
             <a:spLocks noGrp="1"/>
           </p:cNvSpPr>
@@ -672,6 +600,7 @@
               <a:rPr lang="en-US"/>
               <a:t>Edit Master text styles</a:t>
             </a:r>
+            <a:endParaRPr lang="en-US"/>
           </a:p>
           <a:p>
             <a:pPr lvl="1"/>
@@ -679,6 +608,7 @@
               <a:rPr lang="en-US"/>
               <a:t>Second level</a:t>
             </a:r>
+            <a:endParaRPr lang="en-US"/>
           </a:p>
           <a:p>
             <a:pPr lvl="2"/>
@@ -686,6 +616,7 @@
               <a:rPr lang="en-US"/>
               <a:t>Third level</a:t>
             </a:r>
+            <a:endParaRPr lang="en-US"/>
           </a:p>
           <a:p>
             <a:pPr lvl="3"/>
@@ -693,6 +624,7 @@
               <a:rPr lang="en-US"/>
               <a:t>Fourth level</a:t>
             </a:r>
+            <a:endParaRPr lang="en-US"/>
           </a:p>
           <a:p>
             <a:pPr lvl="4"/>
@@ -700,18 +632,13 @@
               <a:rPr lang="en-US"/>
               <a:t>Fifth level</a:t>
             </a:r>
-          </a:p>
-        </p:txBody>
-      </p:sp>
-      <p:sp>
-        <p:nvSpPr>
-          <p:cNvPr id="4" name="Date Placeholder 3">
-            <a:extLst>
-              <a:ext uri="{FF2B5EF4-FFF2-40B4-BE49-F238E27FC236}">
-                <a16:creationId xmlns:a16="http://schemas.microsoft.com/office/drawing/2014/main" xmlns="" id="{5B64E68E-040F-4912-9B7B-725CFB7D6315}"/>
-              </a:ext>
-            </a:extLst>
-          </p:cNvPr>
+            <a:endParaRPr lang="en-US"/>
+          </a:p>
+        </p:txBody>
+      </p:sp>
+      <p:sp>
+        <p:nvSpPr>
+          <p:cNvPr id="4" name="Date Placeholder 3"/>
           <p:cNvSpPr>
             <a:spLocks noGrp="1"/>
           </p:cNvSpPr>
@@ -734,13 +661,7 @@
       </p:sp>
       <p:sp>
         <p:nvSpPr>
-          <p:cNvPr id="5" name="Footer Placeholder 4">
-            <a:extLst>
-              <a:ext uri="{FF2B5EF4-FFF2-40B4-BE49-F238E27FC236}">
-                <a16:creationId xmlns:a16="http://schemas.microsoft.com/office/drawing/2014/main" xmlns="" id="{0D139E95-5F5B-4E87-9B2F-A9A70957AB00}"/>
-              </a:ext>
-            </a:extLst>
-          </p:cNvPr>
+          <p:cNvPr id="5" name="Footer Placeholder 4"/>
           <p:cNvSpPr>
             <a:spLocks noGrp="1"/>
           </p:cNvSpPr>
@@ -763,13 +684,7 @@
       </p:sp>
       <p:sp>
         <p:nvSpPr>
-          <p:cNvPr id="6" name="Slide Number Placeholder 5">
-            <a:extLst>
-              <a:ext uri="{FF2B5EF4-FFF2-40B4-BE49-F238E27FC236}">
-                <a16:creationId xmlns:a16="http://schemas.microsoft.com/office/drawing/2014/main" xmlns="" id="{9C4FE7F3-EC17-415F-863D-DF17690ED1C0}"/>
-              </a:ext>
-            </a:extLst>
-          </p:cNvPr>
+          <p:cNvPr id="6" name="Slide Number Placeholder 5"/>
           <p:cNvSpPr>
             <a:spLocks noGrp="1"/>
           </p:cNvSpPr>
@@ -788,19 +703,12 @@
           <a:p>
             <a:fld id="{74DC5CE5-D93D-42E1-A365-D1BB034BB8AD}" type="slidenum">
               <a:rPr lang="en-US" altLang="en-US"/>
-              <a:pPr/>
-              <a:t>‹#›</a:t>
             </a:fld>
             <a:endParaRPr lang="en-US" altLang="en-US"/>
           </a:p>
         </p:txBody>
       </p:sp>
     </p:spTree>
-    <p:extLst>
-      <p:ext uri="{BB962C8B-B14F-4D97-AF65-F5344CB8AC3E}">
-        <p14:creationId xmlns:p14="http://schemas.microsoft.com/office/powerpoint/2010/main" val="43784081"/>
-      </p:ext>
-    </p:extLst>
   </p:cSld>
   <p:clrMapOvr>
     <a:masterClrMapping/>
@@ -827,13 +735,7 @@
       </p:grpSpPr>
       <p:sp>
         <p:nvSpPr>
-          <p:cNvPr id="2" name="Title 1">
-            <a:extLst>
-              <a:ext uri="{FF2B5EF4-FFF2-40B4-BE49-F238E27FC236}">
-                <a16:creationId xmlns:a16="http://schemas.microsoft.com/office/drawing/2014/main" xmlns="" id="{9AB7FED8-62E4-44F9-8635-073E7D21D9FD}"/>
-              </a:ext>
-            </a:extLst>
-          </p:cNvPr>
+          <p:cNvPr id="2" name="Title 1"/>
           <p:cNvSpPr>
             <a:spLocks noGrp="1"/>
           </p:cNvSpPr>
@@ -850,18 +752,13 @@
               <a:rPr lang="en-US" dirty="0"/>
               <a:t>Click to edit Master title style</a:t>
             </a:r>
-          </a:p>
-        </p:txBody>
-      </p:sp>
-      <p:sp>
-        <p:nvSpPr>
-          <p:cNvPr id="3" name="Content Placeholder 2">
-            <a:extLst>
-              <a:ext uri="{FF2B5EF4-FFF2-40B4-BE49-F238E27FC236}">
-                <a16:creationId xmlns:a16="http://schemas.microsoft.com/office/drawing/2014/main" xmlns="" id="{804BF88E-6176-40DB-A4F0-5F9D10D14F4A}"/>
-              </a:ext>
-            </a:extLst>
-          </p:cNvPr>
+            <a:endParaRPr lang="en-US" dirty="0"/>
+          </a:p>
+        </p:txBody>
+      </p:sp>
+      <p:sp>
+        <p:nvSpPr>
+          <p:cNvPr id="3" name="Content Placeholder 2"/>
           <p:cNvSpPr>
             <a:spLocks noGrp="1"/>
           </p:cNvSpPr>
@@ -879,6 +776,7 @@
               <a:rPr lang="en-US"/>
               <a:t>Edit Master text styles</a:t>
             </a:r>
+            <a:endParaRPr lang="en-US"/>
           </a:p>
           <a:p>
             <a:pPr lvl="1"/>
@@ -886,6 +784,7 @@
               <a:rPr lang="en-US"/>
               <a:t>Second level</a:t>
             </a:r>
+            <a:endParaRPr lang="en-US"/>
           </a:p>
           <a:p>
             <a:pPr lvl="2"/>
@@ -893,6 +792,7 @@
               <a:rPr lang="en-US"/>
               <a:t>Third level</a:t>
             </a:r>
+            <a:endParaRPr lang="en-US"/>
           </a:p>
           <a:p>
             <a:pPr lvl="3"/>
@@ -900,6 +800,7 @@
               <a:rPr lang="en-US"/>
               <a:t>Fourth level</a:t>
             </a:r>
+            <a:endParaRPr lang="en-US"/>
           </a:p>
           <a:p>
             <a:pPr lvl="4"/>
@@ -907,18 +808,13 @@
               <a:rPr lang="en-US"/>
               <a:t>Fifth level</a:t>
             </a:r>
-          </a:p>
-        </p:txBody>
-      </p:sp>
-      <p:sp>
-        <p:nvSpPr>
-          <p:cNvPr id="4" name="Date Placeholder 3">
-            <a:extLst>
-              <a:ext uri="{FF2B5EF4-FFF2-40B4-BE49-F238E27FC236}">
-                <a16:creationId xmlns:a16="http://schemas.microsoft.com/office/drawing/2014/main" xmlns="" id="{07CD7C81-1B47-4037-B98B-75A1F4012D7D}"/>
-              </a:ext>
-            </a:extLst>
-          </p:cNvPr>
+            <a:endParaRPr lang="en-US"/>
+          </a:p>
+        </p:txBody>
+      </p:sp>
+      <p:sp>
+        <p:nvSpPr>
+          <p:cNvPr id="4" name="Date Placeholder 3"/>
           <p:cNvSpPr>
             <a:spLocks noGrp="1"/>
           </p:cNvSpPr>
@@ -941,13 +837,7 @@
       </p:sp>
       <p:sp>
         <p:nvSpPr>
-          <p:cNvPr id="5" name="Footer Placeholder 4">
-            <a:extLst>
-              <a:ext uri="{FF2B5EF4-FFF2-40B4-BE49-F238E27FC236}">
-                <a16:creationId xmlns:a16="http://schemas.microsoft.com/office/drawing/2014/main" xmlns="" id="{615C4BD4-42E2-497A-AD54-B10928A49073}"/>
-              </a:ext>
-            </a:extLst>
-          </p:cNvPr>
+          <p:cNvPr id="5" name="Footer Placeholder 4"/>
           <p:cNvSpPr>
             <a:spLocks noGrp="1"/>
           </p:cNvSpPr>
@@ -970,13 +860,7 @@
       </p:sp>
       <p:sp>
         <p:nvSpPr>
-          <p:cNvPr id="6" name="Slide Number Placeholder 5">
-            <a:extLst>
-              <a:ext uri="{FF2B5EF4-FFF2-40B4-BE49-F238E27FC236}">
-                <a16:creationId xmlns:a16="http://schemas.microsoft.com/office/drawing/2014/main" xmlns="" id="{C2C080A8-4B04-4A76-AD9D-D3373B2CDFD7}"/>
-              </a:ext>
-            </a:extLst>
-          </p:cNvPr>
+          <p:cNvPr id="6" name="Slide Number Placeholder 5"/>
           <p:cNvSpPr>
             <a:spLocks noGrp="1"/>
           </p:cNvSpPr>
@@ -995,19 +879,12 @@
           <a:p>
             <a:fld id="{0F4F63AB-74FF-4D4D-9C96-7E67E70BF8FF}" type="slidenum">
               <a:rPr lang="en-US" altLang="en-US"/>
-              <a:pPr/>
-              <a:t>‹#›</a:t>
             </a:fld>
             <a:endParaRPr lang="en-US" altLang="en-US"/>
           </a:p>
         </p:txBody>
       </p:sp>
     </p:spTree>
-    <p:extLst>
-      <p:ext uri="{BB962C8B-B14F-4D97-AF65-F5344CB8AC3E}">
-        <p14:creationId xmlns:p14="http://schemas.microsoft.com/office/powerpoint/2010/main" val="2920515733"/>
-      </p:ext>
-    </p:extLst>
   </p:cSld>
   <p:clrMapOvr>
     <a:masterClrMapping/>
@@ -1034,13 +911,7 @@
       </p:grpSpPr>
       <p:sp>
         <p:nvSpPr>
-          <p:cNvPr id="2" name="Title 1">
-            <a:extLst>
-              <a:ext uri="{FF2B5EF4-FFF2-40B4-BE49-F238E27FC236}">
-                <a16:creationId xmlns:a16="http://schemas.microsoft.com/office/drawing/2014/main" xmlns="" id="{A09CE863-2F38-493E-AC5F-35F839ABEA4D}"/>
-              </a:ext>
-            </a:extLst>
-          </p:cNvPr>
+          <p:cNvPr id="2" name="Title 1"/>
           <p:cNvSpPr>
             <a:spLocks noGrp="1"/>
           </p:cNvSpPr>
@@ -1066,18 +937,13 @@
               <a:rPr lang="en-US"/>
               <a:t>Click to edit Master title style</a:t>
             </a:r>
-          </a:p>
-        </p:txBody>
-      </p:sp>
-      <p:sp>
-        <p:nvSpPr>
-          <p:cNvPr id="3" name="Text Placeholder 2">
-            <a:extLst>
-              <a:ext uri="{FF2B5EF4-FFF2-40B4-BE49-F238E27FC236}">
-                <a16:creationId xmlns:a16="http://schemas.microsoft.com/office/drawing/2014/main" xmlns="" id="{EE71EE57-4E33-4768-BDE6-1E42E78CC47E}"/>
-              </a:ext>
-            </a:extLst>
-          </p:cNvPr>
+            <a:endParaRPr lang="en-US"/>
+          </a:p>
+        </p:txBody>
+      </p:sp>
+      <p:sp>
+        <p:nvSpPr>
+          <p:cNvPr id="3" name="Text Placeholder 2"/>
           <p:cNvSpPr>
             <a:spLocks noGrp="1"/>
           </p:cNvSpPr>
@@ -1137,18 +1003,13 @@
               <a:rPr lang="en-US"/>
               <a:t>Edit Master text styles</a:t>
             </a:r>
-          </a:p>
-        </p:txBody>
-      </p:sp>
-      <p:sp>
-        <p:nvSpPr>
-          <p:cNvPr id="4" name="Date Placeholder 3">
-            <a:extLst>
-              <a:ext uri="{FF2B5EF4-FFF2-40B4-BE49-F238E27FC236}">
-                <a16:creationId xmlns:a16="http://schemas.microsoft.com/office/drawing/2014/main" xmlns="" id="{71F47056-25E1-4B67-85BD-73087B72E971}"/>
-              </a:ext>
-            </a:extLst>
-          </p:cNvPr>
+            <a:endParaRPr lang="en-US"/>
+          </a:p>
+        </p:txBody>
+      </p:sp>
+      <p:sp>
+        <p:nvSpPr>
+          <p:cNvPr id="4" name="Date Placeholder 3"/>
           <p:cNvSpPr>
             <a:spLocks noGrp="1"/>
           </p:cNvSpPr>
@@ -1171,13 +1032,7 @@
       </p:sp>
       <p:sp>
         <p:nvSpPr>
-          <p:cNvPr id="5" name="Footer Placeholder 4">
-            <a:extLst>
-              <a:ext uri="{FF2B5EF4-FFF2-40B4-BE49-F238E27FC236}">
-                <a16:creationId xmlns:a16="http://schemas.microsoft.com/office/drawing/2014/main" xmlns="" id="{F94B0AFD-04FE-4D58-8BBC-B3312F4708EF}"/>
-              </a:ext>
-            </a:extLst>
-          </p:cNvPr>
+          <p:cNvPr id="5" name="Footer Placeholder 4"/>
           <p:cNvSpPr>
             <a:spLocks noGrp="1"/>
           </p:cNvSpPr>
@@ -1200,13 +1055,7 @@
       </p:sp>
       <p:sp>
         <p:nvSpPr>
-          <p:cNvPr id="6" name="Slide Number Placeholder 5">
-            <a:extLst>
-              <a:ext uri="{FF2B5EF4-FFF2-40B4-BE49-F238E27FC236}">
-                <a16:creationId xmlns:a16="http://schemas.microsoft.com/office/drawing/2014/main" xmlns="" id="{8640AEAA-EABC-4389-89FD-1194EAE5C62C}"/>
-              </a:ext>
-            </a:extLst>
-          </p:cNvPr>
+          <p:cNvPr id="6" name="Slide Number Placeholder 5"/>
           <p:cNvSpPr>
             <a:spLocks noGrp="1"/>
           </p:cNvSpPr>
@@ -1225,19 +1074,12 @@
           <a:p>
             <a:fld id="{0FF88ED3-DC84-4DB0-B233-29AE8689A18E}" type="slidenum">
               <a:rPr lang="en-US" altLang="en-US"/>
-              <a:pPr/>
-              <a:t>‹#›</a:t>
             </a:fld>
             <a:endParaRPr lang="en-US" altLang="en-US"/>
           </a:p>
         </p:txBody>
       </p:sp>
     </p:spTree>
-    <p:extLst>
-      <p:ext uri="{BB962C8B-B14F-4D97-AF65-F5344CB8AC3E}">
-        <p14:creationId xmlns:p14="http://schemas.microsoft.com/office/powerpoint/2010/main" val="3751073900"/>
-      </p:ext>
-    </p:extLst>
   </p:cSld>
   <p:clrMapOvr>
     <a:masterClrMapping/>
@@ -1264,13 +1106,7 @@
       </p:grpSpPr>
       <p:sp>
         <p:nvSpPr>
-          <p:cNvPr id="2" name="Title 1">
-            <a:extLst>
-              <a:ext uri="{FF2B5EF4-FFF2-40B4-BE49-F238E27FC236}">
-                <a16:creationId xmlns:a16="http://schemas.microsoft.com/office/drawing/2014/main" xmlns="" id="{79BE3C47-6B83-4D40-8FFA-423CDED83F11}"/>
-              </a:ext>
-            </a:extLst>
-          </p:cNvPr>
+          <p:cNvPr id="2" name="Title 1"/>
           <p:cNvSpPr>
             <a:spLocks noGrp="1"/>
           </p:cNvSpPr>
@@ -1287,18 +1123,13 @@
               <a:rPr lang="en-US"/>
               <a:t>Click to edit Master title style</a:t>
             </a:r>
-          </a:p>
-        </p:txBody>
-      </p:sp>
-      <p:sp>
-        <p:nvSpPr>
-          <p:cNvPr id="3" name="Content Placeholder 2">
-            <a:extLst>
-              <a:ext uri="{FF2B5EF4-FFF2-40B4-BE49-F238E27FC236}">
-                <a16:creationId xmlns:a16="http://schemas.microsoft.com/office/drawing/2014/main" xmlns="" id="{455CE053-7F00-4D26-A49E-468074BDA09E}"/>
-              </a:ext>
-            </a:extLst>
-          </p:cNvPr>
+            <a:endParaRPr lang="en-US"/>
+          </a:p>
+        </p:txBody>
+      </p:sp>
+      <p:sp>
+        <p:nvSpPr>
+          <p:cNvPr id="3" name="Content Placeholder 2"/>
           <p:cNvSpPr>
             <a:spLocks noGrp="1"/>
           </p:cNvSpPr>
@@ -1321,6 +1152,7 @@
               <a:rPr lang="en-US"/>
               <a:t>Edit Master text styles</a:t>
             </a:r>
+            <a:endParaRPr lang="en-US"/>
           </a:p>
           <a:p>
             <a:pPr lvl="1"/>
@@ -1328,6 +1160,7 @@
               <a:rPr lang="en-US"/>
               <a:t>Second level</a:t>
             </a:r>
+            <a:endParaRPr lang="en-US"/>
           </a:p>
           <a:p>
             <a:pPr lvl="2"/>
@@ -1335,6 +1168,7 @@
               <a:rPr lang="en-US"/>
               <a:t>Third level</a:t>
             </a:r>
+            <a:endParaRPr lang="en-US"/>
           </a:p>
           <a:p>
             <a:pPr lvl="3"/>
@@ -1342,6 +1176,7 @@
               <a:rPr lang="en-US"/>
               <a:t>Fourth level</a:t>
             </a:r>
+            <a:endParaRPr lang="en-US"/>
           </a:p>
           <a:p>
             <a:pPr lvl="4"/>
@@ -1349,18 +1184,13 @@
               <a:rPr lang="en-US"/>
               <a:t>Fifth level</a:t>
             </a:r>
-          </a:p>
-        </p:txBody>
-      </p:sp>
-      <p:sp>
-        <p:nvSpPr>
-          <p:cNvPr id="4" name="Content Placeholder 3">
-            <a:extLst>
-              <a:ext uri="{FF2B5EF4-FFF2-40B4-BE49-F238E27FC236}">
-                <a16:creationId xmlns:a16="http://schemas.microsoft.com/office/drawing/2014/main" xmlns="" id="{C77BA0AC-734F-47AA-97FD-4DA7FEF918C4}"/>
-              </a:ext>
-            </a:extLst>
-          </p:cNvPr>
+            <a:endParaRPr lang="en-US"/>
+          </a:p>
+        </p:txBody>
+      </p:sp>
+      <p:sp>
+        <p:nvSpPr>
+          <p:cNvPr id="4" name="Content Placeholder 3"/>
           <p:cNvSpPr>
             <a:spLocks noGrp="1"/>
           </p:cNvSpPr>
@@ -1383,6 +1213,7 @@
               <a:rPr lang="en-US"/>
               <a:t>Edit Master text styles</a:t>
             </a:r>
+            <a:endParaRPr lang="en-US"/>
           </a:p>
           <a:p>
             <a:pPr lvl="1"/>
@@ -1390,6 +1221,7 @@
               <a:rPr lang="en-US"/>
               <a:t>Second level</a:t>
             </a:r>
+            <a:endParaRPr lang="en-US"/>
           </a:p>
           <a:p>
             <a:pPr lvl="2"/>
@@ -1397,6 +1229,7 @@
               <a:rPr lang="en-US"/>
               <a:t>Third level</a:t>
             </a:r>
+            <a:endParaRPr lang="en-US"/>
           </a:p>
           <a:p>
             <a:pPr lvl="3"/>
@@ -1404,6 +1237,7 @@
               <a:rPr lang="en-US"/>
               <a:t>Fourth level</a:t>
             </a:r>
+            <a:endParaRPr lang="en-US"/>
           </a:p>
           <a:p>
             <a:pPr lvl="4"/>
@@ -1411,18 +1245,13 @@
               <a:rPr lang="en-US"/>
               <a:t>Fifth level</a:t>
             </a:r>
-          </a:p>
-        </p:txBody>
-      </p:sp>
-      <p:sp>
-        <p:nvSpPr>
-          <p:cNvPr id="5" name="Date Placeholder 4">
-            <a:extLst>
-              <a:ext uri="{FF2B5EF4-FFF2-40B4-BE49-F238E27FC236}">
-                <a16:creationId xmlns:a16="http://schemas.microsoft.com/office/drawing/2014/main" xmlns="" id="{A4211179-6CFA-425B-9D7F-2BE02065447E}"/>
-              </a:ext>
-            </a:extLst>
-          </p:cNvPr>
+            <a:endParaRPr lang="en-US"/>
+          </a:p>
+        </p:txBody>
+      </p:sp>
+      <p:sp>
+        <p:nvSpPr>
+          <p:cNvPr id="5" name="Date Placeholder 4"/>
           <p:cNvSpPr>
             <a:spLocks noGrp="1"/>
           </p:cNvSpPr>
@@ -1445,13 +1274,7 @@
       </p:sp>
       <p:sp>
         <p:nvSpPr>
-          <p:cNvPr id="6" name="Footer Placeholder 5">
-            <a:extLst>
-              <a:ext uri="{FF2B5EF4-FFF2-40B4-BE49-F238E27FC236}">
-                <a16:creationId xmlns:a16="http://schemas.microsoft.com/office/drawing/2014/main" xmlns="" id="{AA6E626E-637B-499E-9E2C-ACC64C09C73D}"/>
-              </a:ext>
-            </a:extLst>
-          </p:cNvPr>
+          <p:cNvPr id="6" name="Footer Placeholder 5"/>
           <p:cNvSpPr>
             <a:spLocks noGrp="1"/>
           </p:cNvSpPr>
@@ -1474,13 +1297,7 @@
       </p:sp>
       <p:sp>
         <p:nvSpPr>
-          <p:cNvPr id="7" name="Slide Number Placeholder 6">
-            <a:extLst>
-              <a:ext uri="{FF2B5EF4-FFF2-40B4-BE49-F238E27FC236}">
-                <a16:creationId xmlns:a16="http://schemas.microsoft.com/office/drawing/2014/main" xmlns="" id="{8177475E-6A5C-42A5-8A22-584439427149}"/>
-              </a:ext>
-            </a:extLst>
-          </p:cNvPr>
+          <p:cNvPr id="7" name="Slide Number Placeholder 6"/>
           <p:cNvSpPr>
             <a:spLocks noGrp="1"/>
           </p:cNvSpPr>
@@ -1499,19 +1316,12 @@
           <a:p>
             <a:fld id="{3D79D017-4D2B-4917-98EC-EFDC1350D1A8}" type="slidenum">
               <a:rPr lang="en-US" altLang="en-US"/>
-              <a:pPr/>
-              <a:t>‹#›</a:t>
             </a:fld>
             <a:endParaRPr lang="en-US" altLang="en-US"/>
           </a:p>
         </p:txBody>
       </p:sp>
     </p:spTree>
-    <p:extLst>
-      <p:ext uri="{BB962C8B-B14F-4D97-AF65-F5344CB8AC3E}">
-        <p14:creationId xmlns:p14="http://schemas.microsoft.com/office/powerpoint/2010/main" val="1373398859"/>
-      </p:ext>
-    </p:extLst>
   </p:cSld>
   <p:clrMapOvr>
     <a:masterClrMapping/>
@@ -1538,13 +1348,7 @@
       </p:grpSpPr>
       <p:sp>
         <p:nvSpPr>
-          <p:cNvPr id="2" name="Title 1">
-            <a:extLst>
-              <a:ext uri="{FF2B5EF4-FFF2-40B4-BE49-F238E27FC236}">
-                <a16:creationId xmlns:a16="http://schemas.microsoft.com/office/drawing/2014/main" xmlns="" id="{26D1F325-80E3-4F90-BD69-5037DB90DF26}"/>
-              </a:ext>
-            </a:extLst>
-          </p:cNvPr>
+          <p:cNvPr id="2" name="Title 1"/>
           <p:cNvSpPr>
             <a:spLocks noGrp="1"/>
           </p:cNvSpPr>
@@ -1566,18 +1370,13 @@
               <a:rPr lang="en-US"/>
               <a:t>Click to edit Master title style</a:t>
             </a:r>
-          </a:p>
-        </p:txBody>
-      </p:sp>
-      <p:sp>
-        <p:nvSpPr>
-          <p:cNvPr id="3" name="Text Placeholder 2">
-            <a:extLst>
-              <a:ext uri="{FF2B5EF4-FFF2-40B4-BE49-F238E27FC236}">
-                <a16:creationId xmlns:a16="http://schemas.microsoft.com/office/drawing/2014/main" xmlns="" id="{16DC193B-2F0E-4826-9109-B6307A9C06F1}"/>
-              </a:ext>
-            </a:extLst>
-          </p:cNvPr>
+            <a:endParaRPr lang="en-US"/>
+          </a:p>
+        </p:txBody>
+      </p:sp>
+      <p:sp>
+        <p:nvSpPr>
+          <p:cNvPr id="3" name="Text Placeholder 2"/>
           <p:cNvSpPr>
             <a:spLocks noGrp="1"/>
           </p:cNvSpPr>
@@ -1637,18 +1436,13 @@
               <a:rPr lang="en-US"/>
               <a:t>Edit Master text styles</a:t>
             </a:r>
-          </a:p>
-        </p:txBody>
-      </p:sp>
-      <p:sp>
-        <p:nvSpPr>
-          <p:cNvPr id="4" name="Content Placeholder 3">
-            <a:extLst>
-              <a:ext uri="{FF2B5EF4-FFF2-40B4-BE49-F238E27FC236}">
-                <a16:creationId xmlns:a16="http://schemas.microsoft.com/office/drawing/2014/main" xmlns="" id="{E4A24B64-B380-470F-9CDE-73C0D43F6775}"/>
-              </a:ext>
-            </a:extLst>
-          </p:cNvPr>
+            <a:endParaRPr lang="en-US"/>
+          </a:p>
+        </p:txBody>
+      </p:sp>
+      <p:sp>
+        <p:nvSpPr>
+          <p:cNvPr id="4" name="Content Placeholder 3"/>
           <p:cNvSpPr>
             <a:spLocks noGrp="1"/>
           </p:cNvSpPr>
@@ -1671,6 +1465,7 @@
               <a:rPr lang="en-US"/>
               <a:t>Edit Master text styles</a:t>
             </a:r>
+            <a:endParaRPr lang="en-US"/>
           </a:p>
           <a:p>
             <a:pPr lvl="1"/>
@@ -1678,6 +1473,7 @@
               <a:rPr lang="en-US"/>
               <a:t>Second level</a:t>
             </a:r>
+            <a:endParaRPr lang="en-US"/>
           </a:p>
           <a:p>
             <a:pPr lvl="2"/>
@@ -1685,6 +1481,7 @@
               <a:rPr lang="en-US"/>
               <a:t>Third level</a:t>
             </a:r>
+            <a:endParaRPr lang="en-US"/>
           </a:p>
           <a:p>
             <a:pPr lvl="3"/>
@@ -1692,6 +1489,7 @@
               <a:rPr lang="en-US"/>
               <a:t>Fourth level</a:t>
             </a:r>
+            <a:endParaRPr lang="en-US"/>
           </a:p>
           <a:p>
             <a:pPr lvl="4"/>
@@ -1699,18 +1497,13 @@
               <a:rPr lang="en-US"/>
               <a:t>Fifth level</a:t>
             </a:r>
-          </a:p>
-        </p:txBody>
-      </p:sp>
-      <p:sp>
-        <p:nvSpPr>
-          <p:cNvPr id="5" name="Text Placeholder 4">
-            <a:extLst>
-              <a:ext uri="{FF2B5EF4-FFF2-40B4-BE49-F238E27FC236}">
-                <a16:creationId xmlns:a16="http://schemas.microsoft.com/office/drawing/2014/main" xmlns="" id="{8890F4E0-0F61-4F55-8A7A-765984DF7865}"/>
-              </a:ext>
-            </a:extLst>
-          </p:cNvPr>
+            <a:endParaRPr lang="en-US"/>
+          </a:p>
+        </p:txBody>
+      </p:sp>
+      <p:sp>
+        <p:nvSpPr>
+          <p:cNvPr id="5" name="Text Placeholder 4"/>
           <p:cNvSpPr>
             <a:spLocks noGrp="1"/>
           </p:cNvSpPr>
@@ -1770,18 +1563,13 @@
               <a:rPr lang="en-US"/>
               <a:t>Edit Master text styles</a:t>
             </a:r>
-          </a:p>
-        </p:txBody>
-      </p:sp>
-      <p:sp>
-        <p:nvSpPr>
-          <p:cNvPr id="6" name="Content Placeholder 5">
-            <a:extLst>
-              <a:ext uri="{FF2B5EF4-FFF2-40B4-BE49-F238E27FC236}">
-                <a16:creationId xmlns:a16="http://schemas.microsoft.com/office/drawing/2014/main" xmlns="" id="{9895C38B-8A04-4272-A3E6-393D95555544}"/>
-              </a:ext>
-            </a:extLst>
-          </p:cNvPr>
+            <a:endParaRPr lang="en-US"/>
+          </a:p>
+        </p:txBody>
+      </p:sp>
+      <p:sp>
+        <p:nvSpPr>
+          <p:cNvPr id="6" name="Content Placeholder 5"/>
           <p:cNvSpPr>
             <a:spLocks noGrp="1"/>
           </p:cNvSpPr>
@@ -1804,6 +1592,7 @@
               <a:rPr lang="en-US"/>
               <a:t>Edit Master text styles</a:t>
             </a:r>
+            <a:endParaRPr lang="en-US"/>
           </a:p>
           <a:p>
             <a:pPr lvl="1"/>
@@ -1811,6 +1600,7 @@
               <a:rPr lang="en-US"/>
               <a:t>Second level</a:t>
             </a:r>
+            <a:endParaRPr lang="en-US"/>
           </a:p>
           <a:p>
             <a:pPr lvl="2"/>
@@ -1818,6 +1608,7 @@
               <a:rPr lang="en-US"/>
               <a:t>Third level</a:t>
             </a:r>
+            <a:endParaRPr lang="en-US"/>
           </a:p>
           <a:p>
             <a:pPr lvl="3"/>
@@ -1825,6 +1616,7 @@
               <a:rPr lang="en-US"/>
               <a:t>Fourth level</a:t>
             </a:r>
+            <a:endParaRPr lang="en-US"/>
           </a:p>
           <a:p>
             <a:pPr lvl="4"/>
@@ -1832,18 +1624,13 @@
               <a:rPr lang="en-US"/>
               <a:t>Fifth level</a:t>
             </a:r>
-          </a:p>
-        </p:txBody>
-      </p:sp>
-      <p:sp>
-        <p:nvSpPr>
-          <p:cNvPr id="7" name="Date Placeholder 6">
-            <a:extLst>
-              <a:ext uri="{FF2B5EF4-FFF2-40B4-BE49-F238E27FC236}">
-                <a16:creationId xmlns:a16="http://schemas.microsoft.com/office/drawing/2014/main" xmlns="" id="{B46373DA-5867-4829-AD43-C6FCC79A803E}"/>
-              </a:ext>
-            </a:extLst>
-          </p:cNvPr>
+            <a:endParaRPr lang="en-US"/>
+          </a:p>
+        </p:txBody>
+      </p:sp>
+      <p:sp>
+        <p:nvSpPr>
+          <p:cNvPr id="7" name="Date Placeholder 6"/>
           <p:cNvSpPr>
             <a:spLocks noGrp="1"/>
           </p:cNvSpPr>
@@ -1866,13 +1653,7 @@
       </p:sp>
       <p:sp>
         <p:nvSpPr>
-          <p:cNvPr id="8" name="Footer Placeholder 7">
-            <a:extLst>
-              <a:ext uri="{FF2B5EF4-FFF2-40B4-BE49-F238E27FC236}">
-                <a16:creationId xmlns:a16="http://schemas.microsoft.com/office/drawing/2014/main" xmlns="" id="{021764FC-FDFA-416E-997C-F691587D4AF2}"/>
-              </a:ext>
-            </a:extLst>
-          </p:cNvPr>
+          <p:cNvPr id="8" name="Footer Placeholder 7"/>
           <p:cNvSpPr>
             <a:spLocks noGrp="1"/>
           </p:cNvSpPr>
@@ -1895,13 +1676,7 @@
       </p:sp>
       <p:sp>
         <p:nvSpPr>
-          <p:cNvPr id="9" name="Slide Number Placeholder 8">
-            <a:extLst>
-              <a:ext uri="{FF2B5EF4-FFF2-40B4-BE49-F238E27FC236}">
-                <a16:creationId xmlns:a16="http://schemas.microsoft.com/office/drawing/2014/main" xmlns="" id="{27E741E6-72FD-4F69-97E8-CAC734DCE79A}"/>
-              </a:ext>
-            </a:extLst>
-          </p:cNvPr>
+          <p:cNvPr id="9" name="Slide Number Placeholder 8"/>
           <p:cNvSpPr>
             <a:spLocks noGrp="1"/>
           </p:cNvSpPr>
@@ -1920,19 +1695,12 @@
           <a:p>
             <a:fld id="{D3F7F60C-663B-45B5-8BAA-0CD5F56CC8F6}" type="slidenum">
               <a:rPr lang="en-US" altLang="en-US"/>
-              <a:pPr/>
-              <a:t>‹#›</a:t>
             </a:fld>
             <a:endParaRPr lang="en-US" altLang="en-US"/>
           </a:p>
         </p:txBody>
       </p:sp>
     </p:spTree>
-    <p:extLst>
-      <p:ext uri="{BB962C8B-B14F-4D97-AF65-F5344CB8AC3E}">
-        <p14:creationId xmlns:p14="http://schemas.microsoft.com/office/powerpoint/2010/main" val="2262112047"/>
-      </p:ext>
-    </p:extLst>
   </p:cSld>
   <p:clrMapOvr>
     <a:masterClrMapping/>
@@ -1959,13 +1727,7 @@
       </p:grpSpPr>
       <p:sp>
         <p:nvSpPr>
-          <p:cNvPr id="2" name="Title 1">
-            <a:extLst>
-              <a:ext uri="{FF2B5EF4-FFF2-40B4-BE49-F238E27FC236}">
-                <a16:creationId xmlns:a16="http://schemas.microsoft.com/office/drawing/2014/main" xmlns="" id="{0E52B71A-EE87-467A-AD67-4ECCFB0E52E9}"/>
-              </a:ext>
-            </a:extLst>
-          </p:cNvPr>
+          <p:cNvPr id="2" name="Title 1"/>
           <p:cNvSpPr>
             <a:spLocks noGrp="1"/>
           </p:cNvSpPr>
@@ -1982,18 +1744,13 @@
               <a:rPr lang="en-US"/>
               <a:t>Click to edit Master title style</a:t>
             </a:r>
-          </a:p>
-        </p:txBody>
-      </p:sp>
-      <p:sp>
-        <p:nvSpPr>
-          <p:cNvPr id="3" name="Date Placeholder 2">
-            <a:extLst>
-              <a:ext uri="{FF2B5EF4-FFF2-40B4-BE49-F238E27FC236}">
-                <a16:creationId xmlns:a16="http://schemas.microsoft.com/office/drawing/2014/main" xmlns="" id="{5D6EB2EF-2DBC-41CB-8232-B6E49BCBA6FA}"/>
-              </a:ext>
-            </a:extLst>
-          </p:cNvPr>
+            <a:endParaRPr lang="en-US"/>
+          </a:p>
+        </p:txBody>
+      </p:sp>
+      <p:sp>
+        <p:nvSpPr>
+          <p:cNvPr id="3" name="Date Placeholder 2"/>
           <p:cNvSpPr>
             <a:spLocks noGrp="1"/>
           </p:cNvSpPr>
@@ -2016,13 +1773,7 @@
       </p:sp>
       <p:sp>
         <p:nvSpPr>
-          <p:cNvPr id="4" name="Footer Placeholder 3">
-            <a:extLst>
-              <a:ext uri="{FF2B5EF4-FFF2-40B4-BE49-F238E27FC236}">
-                <a16:creationId xmlns:a16="http://schemas.microsoft.com/office/drawing/2014/main" xmlns="" id="{EA583847-6C7C-4715-98B9-D40636DA2722}"/>
-              </a:ext>
-            </a:extLst>
-          </p:cNvPr>
+          <p:cNvPr id="4" name="Footer Placeholder 3"/>
           <p:cNvSpPr>
             <a:spLocks noGrp="1"/>
           </p:cNvSpPr>
@@ -2045,13 +1796,7 @@
       </p:sp>
       <p:sp>
         <p:nvSpPr>
-          <p:cNvPr id="5" name="Slide Number Placeholder 4">
-            <a:extLst>
-              <a:ext uri="{FF2B5EF4-FFF2-40B4-BE49-F238E27FC236}">
-                <a16:creationId xmlns:a16="http://schemas.microsoft.com/office/drawing/2014/main" xmlns="" id="{5F0D5148-3F8F-464B-A3E1-5F680B454153}"/>
-              </a:ext>
-            </a:extLst>
-          </p:cNvPr>
+          <p:cNvPr id="5" name="Slide Number Placeholder 4"/>
           <p:cNvSpPr>
             <a:spLocks noGrp="1"/>
           </p:cNvSpPr>
@@ -2070,19 +1815,12 @@
           <a:p>
             <a:fld id="{C49BD403-5F74-427A-8423-78614D45D9C1}" type="slidenum">
               <a:rPr lang="en-US" altLang="en-US"/>
-              <a:pPr/>
-              <a:t>‹#›</a:t>
             </a:fld>
             <a:endParaRPr lang="en-US" altLang="en-US"/>
           </a:p>
         </p:txBody>
       </p:sp>
     </p:spTree>
-    <p:extLst>
-      <p:ext uri="{BB962C8B-B14F-4D97-AF65-F5344CB8AC3E}">
-        <p14:creationId xmlns:p14="http://schemas.microsoft.com/office/powerpoint/2010/main" val="129020842"/>
-      </p:ext>
-    </p:extLst>
   </p:cSld>
   <p:clrMapOvr>
     <a:masterClrMapping/>
@@ -2109,13 +1847,7 @@
       </p:grpSpPr>
       <p:sp>
         <p:nvSpPr>
-          <p:cNvPr id="2" name="Date Placeholder 1">
-            <a:extLst>
-              <a:ext uri="{FF2B5EF4-FFF2-40B4-BE49-F238E27FC236}">
-                <a16:creationId xmlns:a16="http://schemas.microsoft.com/office/drawing/2014/main" xmlns="" id="{B70D4DB3-3677-453C-AD63-255313C4E429}"/>
-              </a:ext>
-            </a:extLst>
-          </p:cNvPr>
+          <p:cNvPr id="2" name="Date Placeholder 1"/>
           <p:cNvSpPr>
             <a:spLocks noGrp="1"/>
           </p:cNvSpPr>
@@ -2138,13 +1870,7 @@
       </p:sp>
       <p:sp>
         <p:nvSpPr>
-          <p:cNvPr id="3" name="Footer Placeholder 2">
-            <a:extLst>
-              <a:ext uri="{FF2B5EF4-FFF2-40B4-BE49-F238E27FC236}">
-                <a16:creationId xmlns:a16="http://schemas.microsoft.com/office/drawing/2014/main" xmlns="" id="{991E578C-2E20-4473-943A-093C5C3141E8}"/>
-              </a:ext>
-            </a:extLst>
-          </p:cNvPr>
+          <p:cNvPr id="3" name="Footer Placeholder 2"/>
           <p:cNvSpPr>
             <a:spLocks noGrp="1"/>
           </p:cNvSpPr>
@@ -2167,13 +1893,7 @@
       </p:sp>
       <p:sp>
         <p:nvSpPr>
-          <p:cNvPr id="4" name="Slide Number Placeholder 3">
-            <a:extLst>
-              <a:ext uri="{FF2B5EF4-FFF2-40B4-BE49-F238E27FC236}">
-                <a16:creationId xmlns:a16="http://schemas.microsoft.com/office/drawing/2014/main" xmlns="" id="{FA3681F5-37CC-4FFE-98C1-BDE69E1382C8}"/>
-              </a:ext>
-            </a:extLst>
-          </p:cNvPr>
+          <p:cNvPr id="4" name="Slide Number Placeholder 3"/>
           <p:cNvSpPr>
             <a:spLocks noGrp="1"/>
           </p:cNvSpPr>
@@ -2192,19 +1912,12 @@
           <a:p>
             <a:fld id="{A8445B6F-8FF7-4085-BE97-4B03885D15AA}" type="slidenum">
               <a:rPr lang="en-US" altLang="en-US"/>
-              <a:pPr/>
-              <a:t>‹#›</a:t>
             </a:fld>
             <a:endParaRPr lang="en-US" altLang="en-US"/>
           </a:p>
         </p:txBody>
       </p:sp>
     </p:spTree>
-    <p:extLst>
-      <p:ext uri="{BB962C8B-B14F-4D97-AF65-F5344CB8AC3E}">
-        <p14:creationId xmlns:p14="http://schemas.microsoft.com/office/powerpoint/2010/main" val="3035274606"/>
-      </p:ext>
-    </p:extLst>
   </p:cSld>
   <p:clrMapOvr>
     <a:masterClrMapping/>
@@ -2231,13 +1944,7 @@
       </p:grpSpPr>
       <p:sp>
         <p:nvSpPr>
-          <p:cNvPr id="2" name="Title 1">
-            <a:extLst>
-              <a:ext uri="{FF2B5EF4-FFF2-40B4-BE49-F238E27FC236}">
-                <a16:creationId xmlns:a16="http://schemas.microsoft.com/office/drawing/2014/main" xmlns="" id="{27E10611-3704-4861-BD88-F503F43FAF86}"/>
-              </a:ext>
-            </a:extLst>
-          </p:cNvPr>
+          <p:cNvPr id="2" name="Title 1"/>
           <p:cNvSpPr>
             <a:spLocks noGrp="1"/>
           </p:cNvSpPr>
@@ -2263,18 +1970,13 @@
               <a:rPr lang="en-US"/>
               <a:t>Click to edit Master title style</a:t>
             </a:r>
-          </a:p>
-        </p:txBody>
-      </p:sp>
-      <p:sp>
-        <p:nvSpPr>
-          <p:cNvPr id="3" name="Content Placeholder 2">
-            <a:extLst>
-              <a:ext uri="{FF2B5EF4-FFF2-40B4-BE49-F238E27FC236}">
-                <a16:creationId xmlns:a16="http://schemas.microsoft.com/office/drawing/2014/main" xmlns="" id="{B9DB25AB-F178-4E56-A78A-D3E5D8B2D9E0}"/>
-              </a:ext>
-            </a:extLst>
-          </p:cNvPr>
+            <a:endParaRPr lang="en-US"/>
+          </a:p>
+        </p:txBody>
+      </p:sp>
+      <p:sp>
+        <p:nvSpPr>
+          <p:cNvPr id="3" name="Content Placeholder 2"/>
           <p:cNvSpPr>
             <a:spLocks noGrp="1"/>
           </p:cNvSpPr>
@@ -2325,6 +2027,7 @@
               <a:rPr lang="en-US"/>
               <a:t>Edit Master text styles</a:t>
             </a:r>
+            <a:endParaRPr lang="en-US"/>
           </a:p>
           <a:p>
             <a:pPr lvl="1"/>
@@ -2332,6 +2035,7 @@
               <a:rPr lang="en-US"/>
               <a:t>Second level</a:t>
             </a:r>
+            <a:endParaRPr lang="en-US"/>
           </a:p>
           <a:p>
             <a:pPr lvl="2"/>
@@ -2339,6 +2043,7 @@
               <a:rPr lang="en-US"/>
               <a:t>Third level</a:t>
             </a:r>
+            <a:endParaRPr lang="en-US"/>
           </a:p>
           <a:p>
             <a:pPr lvl="3"/>
@@ -2346,6 +2051,7 @@
               <a:rPr lang="en-US"/>
               <a:t>Fourth level</a:t>
             </a:r>
+            <a:endParaRPr lang="en-US"/>
           </a:p>
           <a:p>
             <a:pPr lvl="4"/>
@@ -2353,18 +2059,13 @@
               <a:rPr lang="en-US"/>
               <a:t>Fifth level</a:t>
             </a:r>
-          </a:p>
-        </p:txBody>
-      </p:sp>
-      <p:sp>
-        <p:nvSpPr>
-          <p:cNvPr id="4" name="Text Placeholder 3">
-            <a:extLst>
-              <a:ext uri="{FF2B5EF4-FFF2-40B4-BE49-F238E27FC236}">
-                <a16:creationId xmlns:a16="http://schemas.microsoft.com/office/drawing/2014/main" xmlns="" id="{2D8C3404-B5CD-41A1-BD0C-CEB1CDB87330}"/>
-              </a:ext>
-            </a:extLst>
-          </p:cNvPr>
+            <a:endParaRPr lang="en-US"/>
+          </a:p>
+        </p:txBody>
+      </p:sp>
+      <p:sp>
+        <p:nvSpPr>
+          <p:cNvPr id="4" name="Text Placeholder 3"/>
           <p:cNvSpPr>
             <a:spLocks noGrp="1"/>
           </p:cNvSpPr>
@@ -2424,18 +2125,13 @@
               <a:rPr lang="en-US"/>
               <a:t>Edit Master text styles</a:t>
             </a:r>
-          </a:p>
-        </p:txBody>
-      </p:sp>
-      <p:sp>
-        <p:nvSpPr>
-          <p:cNvPr id="5" name="Date Placeholder 4">
-            <a:extLst>
-              <a:ext uri="{FF2B5EF4-FFF2-40B4-BE49-F238E27FC236}">
-                <a16:creationId xmlns:a16="http://schemas.microsoft.com/office/drawing/2014/main" xmlns="" id="{18903B3B-2157-4986-A6D1-D21E38C81562}"/>
-              </a:ext>
-            </a:extLst>
-          </p:cNvPr>
+            <a:endParaRPr lang="en-US"/>
+          </a:p>
+        </p:txBody>
+      </p:sp>
+      <p:sp>
+        <p:nvSpPr>
+          <p:cNvPr id="5" name="Date Placeholder 4"/>
           <p:cNvSpPr>
             <a:spLocks noGrp="1"/>
           </p:cNvSpPr>
@@ -2458,13 +2154,7 @@
       </p:sp>
       <p:sp>
         <p:nvSpPr>
-          <p:cNvPr id="6" name="Footer Placeholder 5">
-            <a:extLst>
-              <a:ext uri="{FF2B5EF4-FFF2-40B4-BE49-F238E27FC236}">
-                <a16:creationId xmlns:a16="http://schemas.microsoft.com/office/drawing/2014/main" xmlns="" id="{9A6720C0-253D-4EFB-8A0E-096A4FC7527B}"/>
-              </a:ext>
-            </a:extLst>
-          </p:cNvPr>
+          <p:cNvPr id="6" name="Footer Placeholder 5"/>
           <p:cNvSpPr>
             <a:spLocks noGrp="1"/>
           </p:cNvSpPr>
@@ -2487,13 +2177,7 @@
       </p:sp>
       <p:sp>
         <p:nvSpPr>
-          <p:cNvPr id="7" name="Slide Number Placeholder 6">
-            <a:extLst>
-              <a:ext uri="{FF2B5EF4-FFF2-40B4-BE49-F238E27FC236}">
-                <a16:creationId xmlns:a16="http://schemas.microsoft.com/office/drawing/2014/main" xmlns="" id="{7B78D71A-2EC3-4B1C-AE98-CEF4BA88B48C}"/>
-              </a:ext>
-            </a:extLst>
-          </p:cNvPr>
+          <p:cNvPr id="7" name="Slide Number Placeholder 6"/>
           <p:cNvSpPr>
             <a:spLocks noGrp="1"/>
           </p:cNvSpPr>
@@ -2512,19 +2196,12 @@
           <a:p>
             <a:fld id="{75A644C7-8C57-4BC2-BD31-5EE7CB8540FD}" type="slidenum">
               <a:rPr lang="en-US" altLang="en-US"/>
-              <a:pPr/>
-              <a:t>‹#›</a:t>
             </a:fld>
             <a:endParaRPr lang="en-US" altLang="en-US"/>
           </a:p>
         </p:txBody>
       </p:sp>
     </p:spTree>
-    <p:extLst>
-      <p:ext uri="{BB962C8B-B14F-4D97-AF65-F5344CB8AC3E}">
-        <p14:creationId xmlns:p14="http://schemas.microsoft.com/office/powerpoint/2010/main" val="2324875350"/>
-      </p:ext>
-    </p:extLst>
   </p:cSld>
   <p:clrMapOvr>
     <a:masterClrMapping/>
@@ -2551,13 +2228,7 @@
       </p:grpSpPr>
       <p:sp>
         <p:nvSpPr>
-          <p:cNvPr id="2" name="Title 1">
-            <a:extLst>
-              <a:ext uri="{FF2B5EF4-FFF2-40B4-BE49-F238E27FC236}">
-                <a16:creationId xmlns:a16="http://schemas.microsoft.com/office/drawing/2014/main" xmlns="" id="{42B4A99F-9EE0-4942-BCEE-A1E732C0F4E1}"/>
-              </a:ext>
-            </a:extLst>
-          </p:cNvPr>
+          <p:cNvPr id="2" name="Title 1"/>
           <p:cNvSpPr>
             <a:spLocks noGrp="1"/>
           </p:cNvSpPr>
@@ -2583,18 +2254,13 @@
               <a:rPr lang="en-US"/>
               <a:t>Click to edit Master title style</a:t>
             </a:r>
-          </a:p>
-        </p:txBody>
-      </p:sp>
-      <p:sp>
-        <p:nvSpPr>
-          <p:cNvPr id="3" name="Picture Placeholder 2">
-            <a:extLst>
-              <a:ext uri="{FF2B5EF4-FFF2-40B4-BE49-F238E27FC236}">
-                <a16:creationId xmlns:a16="http://schemas.microsoft.com/office/drawing/2014/main" xmlns="" id="{4BA78B66-2785-4358-A99C-30D13EE9AD34}"/>
-              </a:ext>
-            </a:extLst>
-          </p:cNvPr>
+            <a:endParaRPr lang="en-US"/>
+          </a:p>
+        </p:txBody>
+      </p:sp>
+      <p:sp>
+        <p:nvSpPr>
+          <p:cNvPr id="3" name="Picture Placeholder 2"/>
           <p:cNvSpPr>
             <a:spLocks noGrp="1"/>
           </p:cNvSpPr>
@@ -2655,13 +2321,7 @@
       </p:sp>
       <p:sp>
         <p:nvSpPr>
-          <p:cNvPr id="4" name="Text Placeholder 3">
-            <a:extLst>
-              <a:ext uri="{FF2B5EF4-FFF2-40B4-BE49-F238E27FC236}">
-                <a16:creationId xmlns:a16="http://schemas.microsoft.com/office/drawing/2014/main" xmlns="" id="{AA38E7B7-693B-436C-ACFB-D578D6C8538B}"/>
-              </a:ext>
-            </a:extLst>
-          </p:cNvPr>
+          <p:cNvPr id="4" name="Text Placeholder 3"/>
           <p:cNvSpPr>
             <a:spLocks noGrp="1"/>
           </p:cNvSpPr>
@@ -2721,18 +2381,13 @@
               <a:rPr lang="en-US"/>
               <a:t>Edit Master text styles</a:t>
             </a:r>
-          </a:p>
-        </p:txBody>
-      </p:sp>
-      <p:sp>
-        <p:nvSpPr>
-          <p:cNvPr id="5" name="Date Placeholder 4">
-            <a:extLst>
-              <a:ext uri="{FF2B5EF4-FFF2-40B4-BE49-F238E27FC236}">
-                <a16:creationId xmlns:a16="http://schemas.microsoft.com/office/drawing/2014/main" xmlns="" id="{1D59676D-A17F-46ED-B322-996E92CC669D}"/>
-              </a:ext>
-            </a:extLst>
-          </p:cNvPr>
+            <a:endParaRPr lang="en-US"/>
+          </a:p>
+        </p:txBody>
+      </p:sp>
+      <p:sp>
+        <p:nvSpPr>
+          <p:cNvPr id="5" name="Date Placeholder 4"/>
           <p:cNvSpPr>
             <a:spLocks noGrp="1"/>
           </p:cNvSpPr>
@@ -2755,13 +2410,7 @@
       </p:sp>
       <p:sp>
         <p:nvSpPr>
-          <p:cNvPr id="6" name="Footer Placeholder 5">
-            <a:extLst>
-              <a:ext uri="{FF2B5EF4-FFF2-40B4-BE49-F238E27FC236}">
-                <a16:creationId xmlns:a16="http://schemas.microsoft.com/office/drawing/2014/main" xmlns="" id="{6398B656-A461-4B3F-8ECD-A1C58EEC5D5D}"/>
-              </a:ext>
-            </a:extLst>
-          </p:cNvPr>
+          <p:cNvPr id="6" name="Footer Placeholder 5"/>
           <p:cNvSpPr>
             <a:spLocks noGrp="1"/>
           </p:cNvSpPr>
@@ -2784,13 +2433,7 @@
       </p:sp>
       <p:sp>
         <p:nvSpPr>
-          <p:cNvPr id="7" name="Slide Number Placeholder 6">
-            <a:extLst>
-              <a:ext uri="{FF2B5EF4-FFF2-40B4-BE49-F238E27FC236}">
-                <a16:creationId xmlns:a16="http://schemas.microsoft.com/office/drawing/2014/main" xmlns="" id="{F705B36D-F955-462B-899C-F46A6F9E5B53}"/>
-              </a:ext>
-            </a:extLst>
-          </p:cNvPr>
+          <p:cNvPr id="7" name="Slide Number Placeholder 6"/>
           <p:cNvSpPr>
             <a:spLocks noGrp="1"/>
           </p:cNvSpPr>
@@ -2809,19 +2452,12 @@
           <a:p>
             <a:fld id="{2B64E658-6E24-430E-B2BE-9BADE501346F}" type="slidenum">
               <a:rPr lang="en-US" altLang="en-US"/>
-              <a:pPr/>
-              <a:t>‹#›</a:t>
             </a:fld>
             <a:endParaRPr lang="en-US" altLang="en-US"/>
           </a:p>
         </p:txBody>
       </p:sp>
     </p:spTree>
-    <p:extLst>
-      <p:ext uri="{BB962C8B-B14F-4D97-AF65-F5344CB8AC3E}">
-        <p14:creationId xmlns:p14="http://schemas.microsoft.com/office/powerpoint/2010/main" val="1459652453"/>
-      </p:ext>
-    </p:extLst>
   </p:cSld>
   <p:clrMapOvr>
     <a:masterClrMapping/>
@@ -2835,7 +2471,7 @@
     <p:bg>
       <p:bgPr>
         <a:blipFill dpi="0" rotWithShape="0">
-          <a:blip r:embed="rId13"/>
+          <a:blip r:embed="rId12"/>
           <a:srcRect/>
           <a:stretch>
             <a:fillRect/>
@@ -2860,13 +2496,7 @@
       </p:grpSpPr>
       <p:sp>
         <p:nvSpPr>
-          <p:cNvPr id="1026" name="Rectangle 2">
-            <a:extLst>
-              <a:ext uri="{FF2B5EF4-FFF2-40B4-BE49-F238E27FC236}">
-                <a16:creationId xmlns:a16="http://schemas.microsoft.com/office/drawing/2014/main" xmlns="" id="{01405D41-0CC5-41DF-A29F-0509945FC107}"/>
-              </a:ext>
-            </a:extLst>
-          </p:cNvPr>
+          <p:cNvPr id="1026" name="Rectangle 2"/>
           <p:cNvSpPr>
             <a:spLocks noGrp="1" noChangeArrowheads="1"/>
           </p:cNvSpPr>
@@ -2917,11 +2547,7 @@
           </a:extLst>
         </p:spPr>
         <p:txBody>
-          <a:bodyPr vert="horz" wrap="square" lIns="91440" tIns="45720" rIns="91440" bIns="45720" numCol="1" anchor="ctr" anchorCtr="0" compatLnSpc="1">
-            <a:prstTxWarp prst="textNoShape">
-              <a:avLst/>
-            </a:prstTxWarp>
-          </a:bodyPr>
+          <a:bodyPr vert="horz" wrap="square" lIns="91440" tIns="45720" rIns="91440" bIns="45720" numCol="1" anchor="ctr" anchorCtr="0" compatLnSpc="1"/>
           <a:lstStyle/>
           <a:p>
             <a:pPr lvl="0"/>
@@ -2929,18 +2555,13 @@
               <a:rPr lang="en-US" altLang="en-US"/>
               <a:t>Click to edit Master title style</a:t>
             </a:r>
-          </a:p>
-        </p:txBody>
-      </p:sp>
-      <p:sp>
-        <p:nvSpPr>
-          <p:cNvPr id="1027" name="Rectangle 3">
-            <a:extLst>
-              <a:ext uri="{FF2B5EF4-FFF2-40B4-BE49-F238E27FC236}">
-                <a16:creationId xmlns:a16="http://schemas.microsoft.com/office/drawing/2014/main" xmlns="" id="{8E07D3DA-2B85-42CC-8062-8B65F67586B0}"/>
-              </a:ext>
-            </a:extLst>
-          </p:cNvPr>
+            <a:endParaRPr lang="en-US" altLang="en-US"/>
+          </a:p>
+        </p:txBody>
+      </p:sp>
+      <p:sp>
+        <p:nvSpPr>
+          <p:cNvPr id="1027" name="Rectangle 3"/>
           <p:cNvSpPr>
             <a:spLocks noGrp="1" noChangeArrowheads="1"/>
           </p:cNvSpPr>
@@ -2991,11 +2612,7 @@
           </a:extLst>
         </p:spPr>
         <p:txBody>
-          <a:bodyPr vert="horz" wrap="square" lIns="91440" tIns="45720" rIns="91440" bIns="45720" numCol="1" anchor="t" anchorCtr="0" compatLnSpc="1">
-            <a:prstTxWarp prst="textNoShape">
-              <a:avLst/>
-            </a:prstTxWarp>
-          </a:bodyPr>
+          <a:bodyPr vert="horz" wrap="square" lIns="91440" tIns="45720" rIns="91440" bIns="45720" numCol="1" anchor="t" anchorCtr="0" compatLnSpc="1"/>
           <a:lstStyle/>
           <a:p>
             <a:pPr lvl="0"/>
@@ -3003,6 +2620,7 @@
               <a:rPr lang="en-US" altLang="en-US"/>
               <a:t>Click to edit Master text styles</a:t>
             </a:r>
+            <a:endParaRPr lang="en-US" altLang="en-US"/>
           </a:p>
           <a:p>
             <a:pPr lvl="1"/>
@@ -3010,6 +2628,7 @@
               <a:rPr lang="en-US" altLang="en-US"/>
               <a:t>Second level</a:t>
             </a:r>
+            <a:endParaRPr lang="en-US" altLang="en-US"/>
           </a:p>
           <a:p>
             <a:pPr lvl="2"/>
@@ -3017,6 +2636,7 @@
               <a:rPr lang="en-US" altLang="en-US"/>
               <a:t>Third level</a:t>
             </a:r>
+            <a:endParaRPr lang="en-US" altLang="en-US"/>
           </a:p>
           <a:p>
             <a:pPr lvl="3"/>
@@ -3024,6 +2644,7 @@
               <a:rPr lang="en-US" altLang="en-US"/>
               <a:t>Fourth level</a:t>
             </a:r>
+            <a:endParaRPr lang="en-US" altLang="en-US"/>
           </a:p>
           <a:p>
             <a:pPr lvl="4"/>
@@ -3031,18 +2652,13 @@
               <a:rPr lang="en-US" altLang="en-US"/>
               <a:t>Fifth level</a:t>
             </a:r>
-          </a:p>
-        </p:txBody>
-      </p:sp>
-      <p:sp>
-        <p:nvSpPr>
-          <p:cNvPr id="1028" name="Rectangle 4">
-            <a:extLst>
-              <a:ext uri="{FF2B5EF4-FFF2-40B4-BE49-F238E27FC236}">
-                <a16:creationId xmlns:a16="http://schemas.microsoft.com/office/drawing/2014/main" xmlns="" id="{E07E20C1-4C65-4624-AA2D-747E84F1D3CB}"/>
-              </a:ext>
-            </a:extLst>
-          </p:cNvPr>
+            <a:endParaRPr lang="en-US" altLang="en-US"/>
+          </a:p>
+        </p:txBody>
+      </p:sp>
+      <p:sp>
+        <p:nvSpPr>
+          <p:cNvPr id="1028" name="Rectangle 4"/>
           <p:cNvSpPr>
             <a:spLocks noGrp="1" noChangeArrowheads="1"/>
           </p:cNvSpPr>
@@ -3093,11 +2709,7 @@
           </a:extLst>
         </p:spPr>
         <p:txBody>
-          <a:bodyPr vert="horz" wrap="square" lIns="91440" tIns="45720" rIns="91440" bIns="45720" numCol="1" anchor="t" anchorCtr="0" compatLnSpc="1">
-            <a:prstTxWarp prst="textNoShape">
-              <a:avLst/>
-            </a:prstTxWarp>
-          </a:bodyPr>
+          <a:bodyPr vert="horz" wrap="square" lIns="91440" tIns="45720" rIns="91440" bIns="45720" numCol="1" anchor="t" anchorCtr="0" compatLnSpc="1"/>
           <a:lstStyle>
             <a:lvl1pPr>
               <a:defRPr sz="1400"/>
@@ -3110,13 +2722,7 @@
       </p:sp>
       <p:sp>
         <p:nvSpPr>
-          <p:cNvPr id="1029" name="Rectangle 5">
-            <a:extLst>
-              <a:ext uri="{FF2B5EF4-FFF2-40B4-BE49-F238E27FC236}">
-                <a16:creationId xmlns:a16="http://schemas.microsoft.com/office/drawing/2014/main" xmlns="" id="{DF6370B7-BED3-4B38-A932-BD0A5880CB44}"/>
-              </a:ext>
-            </a:extLst>
-          </p:cNvPr>
+          <p:cNvPr id="1029" name="Rectangle 5"/>
           <p:cNvSpPr>
             <a:spLocks noGrp="1" noChangeArrowheads="1"/>
           </p:cNvSpPr>
@@ -3167,11 +2773,7 @@
           </a:extLst>
         </p:spPr>
         <p:txBody>
-          <a:bodyPr vert="horz" wrap="square" lIns="91440" tIns="45720" rIns="91440" bIns="45720" numCol="1" anchor="t" anchorCtr="0" compatLnSpc="1">
-            <a:prstTxWarp prst="textNoShape">
-              <a:avLst/>
-            </a:prstTxWarp>
-          </a:bodyPr>
+          <a:bodyPr vert="horz" wrap="square" lIns="91440" tIns="45720" rIns="91440" bIns="45720" numCol="1" anchor="t" anchorCtr="0" compatLnSpc="1"/>
           <a:lstStyle>
             <a:lvl1pPr algn="ctr">
               <a:defRPr sz="1400"/>
@@ -3184,13 +2786,7 @@
       </p:sp>
       <p:sp>
         <p:nvSpPr>
-          <p:cNvPr id="1030" name="Rectangle 6">
-            <a:extLst>
-              <a:ext uri="{FF2B5EF4-FFF2-40B4-BE49-F238E27FC236}">
-                <a16:creationId xmlns:a16="http://schemas.microsoft.com/office/drawing/2014/main" xmlns="" id="{848F6441-6898-4A31-A185-8673B9B54ACB}"/>
-              </a:ext>
-            </a:extLst>
-          </p:cNvPr>
+          <p:cNvPr id="1030" name="Rectangle 6"/>
           <p:cNvSpPr>
             <a:spLocks noGrp="1" noChangeArrowheads="1"/>
           </p:cNvSpPr>
@@ -3241,11 +2837,7 @@
           </a:extLst>
         </p:spPr>
         <p:txBody>
-          <a:bodyPr vert="horz" wrap="square" lIns="91440" tIns="45720" rIns="91440" bIns="45720" numCol="1" anchor="t" anchorCtr="0" compatLnSpc="1">
-            <a:prstTxWarp prst="textNoShape">
-              <a:avLst/>
-            </a:prstTxWarp>
-          </a:bodyPr>
+          <a:bodyPr vert="horz" wrap="square" lIns="91440" tIns="45720" rIns="91440" bIns="45720" numCol="1" anchor="t" anchorCtr="0" compatLnSpc="1"/>
           <a:lstStyle>
             <a:lvl1pPr algn="r">
               <a:defRPr sz="1400"/>
@@ -3254,8 +2846,6 @@
           <a:p>
             <a:fld id="{306FFC55-A7E0-43C6-B48A-D297196E04B7}" type="slidenum">
               <a:rPr lang="en-US" altLang="en-US"/>
-              <a:pPr/>
-              <a:t>‹#›</a:t>
             </a:fld>
             <a:endParaRPr lang="en-US" altLang="en-US"/>
           </a:p>
@@ -3672,7 +3262,7 @@
     <p:bg>
       <p:bgPr>
         <a:blipFill dpi="0" rotWithShape="0">
-          <a:blip r:embed="rId2"/>
+          <a:blip r:embed="rId1"/>
           <a:srcRect/>
           <a:stretch>
             <a:fillRect/>
@@ -3697,13 +3287,7 @@
       </p:grpSpPr>
       <p:sp>
         <p:nvSpPr>
-          <p:cNvPr id="2050" name="Rectangle 2">
-            <a:extLst>
-              <a:ext uri="{FF2B5EF4-FFF2-40B4-BE49-F238E27FC236}">
-                <a16:creationId xmlns:a16="http://schemas.microsoft.com/office/drawing/2014/main" xmlns="" id="{1CDA1651-B184-4C83-9729-35D701BE495A}"/>
-              </a:ext>
-            </a:extLst>
-          </p:cNvPr>
+          <p:cNvPr id="2050" name="Rectangle 2"/>
           <p:cNvSpPr>
             <a:spLocks noGrp="1" noChangeArrowheads="1"/>
           </p:cNvSpPr>
@@ -3732,13 +3316,7 @@
       </p:sp>
       <p:sp>
         <p:nvSpPr>
-          <p:cNvPr id="2051" name="Rectangle 3">
-            <a:extLst>
-              <a:ext uri="{FF2B5EF4-FFF2-40B4-BE49-F238E27FC236}">
-                <a16:creationId xmlns:a16="http://schemas.microsoft.com/office/drawing/2014/main" xmlns="" id="{80E355BD-3478-446D-BADE-5B579DF2FF15}"/>
-              </a:ext>
-            </a:extLst>
-          </p:cNvPr>
+          <p:cNvPr id="2051" name="Rectangle 3"/>
           <p:cNvSpPr>
             <a:spLocks noGrp="1" noChangeArrowheads="1"/>
           </p:cNvSpPr>
@@ -3770,13 +3348,7 @@
       </p:sp>
       <p:sp>
         <p:nvSpPr>
-          <p:cNvPr id="2053" name="Text Box 5">
-            <a:extLst>
-              <a:ext uri="{FF2B5EF4-FFF2-40B4-BE49-F238E27FC236}">
-                <a16:creationId xmlns:a16="http://schemas.microsoft.com/office/drawing/2014/main" xmlns="" id="{3D1CE68C-65F7-4C8C-AB01-78D31225A9F1}"/>
-              </a:ext>
-            </a:extLst>
-          </p:cNvPr>
+          <p:cNvPr id="2053" name="Text Box 5"/>
           <p:cNvSpPr txBox="1">
             <a:spLocks noChangeArrowheads="1"/>
           </p:cNvSpPr>
@@ -3853,13 +3425,7 @@
       </p:sp>
       <p:sp>
         <p:nvSpPr>
-          <p:cNvPr id="5" name="Rectangle 3">
-            <a:extLst>
-              <a:ext uri="{FF2B5EF4-FFF2-40B4-BE49-F238E27FC236}">
-                <a16:creationId xmlns:a16="http://schemas.microsoft.com/office/drawing/2014/main" xmlns="" id="{80E355BD-3478-446D-BADE-5B579DF2FF15}"/>
-              </a:ext>
-            </a:extLst>
-          </p:cNvPr>
+          <p:cNvPr id="5" name="Rectangle 3"/>
           <p:cNvSpPr txBox="1">
             <a:spLocks noChangeArrowheads="1"/>
           </p:cNvSpPr>
@@ -3908,11 +3474,7 @@
           </a:extLst>
         </p:spPr>
         <p:txBody>
-          <a:bodyPr vert="horz" wrap="square" lIns="91440" tIns="45720" rIns="91440" bIns="45720" numCol="1" anchor="t" anchorCtr="0" compatLnSpc="1">
-            <a:prstTxWarp prst="textNoShape">
-              <a:avLst/>
-            </a:prstTxWarp>
-          </a:bodyPr>
+          <a:bodyPr vert="horz" wrap="square" lIns="91440" tIns="45720" rIns="91440" bIns="45720" numCol="1" anchor="t" anchorCtr="0" compatLnSpc="1"/>
           <a:lstStyle>
             <a:lvl1pPr marL="0" indent="0" algn="ctr" rtl="0" fontAlgn="base">
               <a:spcBef>
@@ -4079,6 +3641,7 @@
               <a:rPr lang="en-US" altLang="en-US" sz="2400" b="1" smtClean="0"/>
               <a:t>Thành viên nhóm:</a:t>
             </a:r>
+            <a:endParaRPr lang="en-US" altLang="en-US" sz="2400" b="1" smtClean="0"/>
           </a:p>
           <a:p>
             <a:pPr algn="l"/>
@@ -4086,6 +3649,7 @@
               <a:rPr lang="en-US" altLang="en-US" sz="2000" smtClean="0"/>
               <a:t>Lê Hoàng Nguyên – B2306564</a:t>
             </a:r>
+            <a:endParaRPr lang="en-US" altLang="en-US" sz="2000" smtClean="0"/>
           </a:p>
           <a:p>
             <a:pPr algn="l"/>
@@ -4099,13 +3663,7 @@
       </p:sp>
       <p:sp>
         <p:nvSpPr>
-          <p:cNvPr id="6" name="Rectangle 3">
-            <a:extLst>
-              <a:ext uri="{FF2B5EF4-FFF2-40B4-BE49-F238E27FC236}">
-                <a16:creationId xmlns:a16="http://schemas.microsoft.com/office/drawing/2014/main" xmlns="" id="{80E355BD-3478-446D-BADE-5B579DF2FF15}"/>
-              </a:ext>
-            </a:extLst>
-          </p:cNvPr>
+          <p:cNvPr id="6" name="Rectangle 3"/>
           <p:cNvSpPr txBox="1">
             <a:spLocks noChangeArrowheads="1"/>
           </p:cNvSpPr>
@@ -4154,11 +3712,7 @@
           </a:extLst>
         </p:spPr>
         <p:txBody>
-          <a:bodyPr vert="horz" wrap="square" lIns="91440" tIns="45720" rIns="91440" bIns="45720" numCol="1" anchor="t" anchorCtr="0" compatLnSpc="1">
-            <a:prstTxWarp prst="textNoShape">
-              <a:avLst/>
-            </a:prstTxWarp>
-          </a:bodyPr>
+          <a:bodyPr vert="horz" wrap="square" lIns="91440" tIns="45720" rIns="91440" bIns="45720" numCol="1" anchor="t" anchorCtr="0" compatLnSpc="1"/>
           <a:lstStyle>
             <a:lvl1pPr marL="0" indent="0" algn="ctr" rtl="0" fontAlgn="base">
               <a:spcBef>
@@ -4325,6 +3879,7 @@
               <a:rPr lang="en-US" altLang="en-US" sz="2400" b="1" smtClean="0"/>
               <a:t>Giáo viên hướng dẫn:</a:t>
             </a:r>
+            <a:endParaRPr lang="en-US" altLang="en-US" sz="2400" b="1" smtClean="0"/>
           </a:p>
           <a:p>
             <a:pPr algn="r"/>
@@ -4370,13 +3925,7 @@
       </p:grpSpPr>
       <p:sp>
         <p:nvSpPr>
-          <p:cNvPr id="25602" name="Rectangle 2">
-            <a:extLst>
-              <a:ext uri="{FF2B5EF4-FFF2-40B4-BE49-F238E27FC236}">
-                <a16:creationId xmlns:a16="http://schemas.microsoft.com/office/drawing/2014/main" xmlns="" id="{D09A8D8C-80F7-440C-BEF1-9EFA4CBAAA33}"/>
-              </a:ext>
-            </a:extLst>
-          </p:cNvPr>
+          <p:cNvPr id="25602" name="Rectangle 2"/>
           <p:cNvSpPr>
             <a:spLocks noGrp="1" noChangeArrowheads="1"/>
           </p:cNvSpPr>
@@ -4399,13 +3948,7 @@
       </p:sp>
       <p:sp>
         <p:nvSpPr>
-          <p:cNvPr id="25603" name="Rectangle 3">
-            <a:extLst>
-              <a:ext uri="{FF2B5EF4-FFF2-40B4-BE49-F238E27FC236}">
-                <a16:creationId xmlns:a16="http://schemas.microsoft.com/office/drawing/2014/main" xmlns="" id="{2EE127BF-401A-4C36-A14A-872ADB44AB18}"/>
-              </a:ext>
-            </a:extLst>
-          </p:cNvPr>
+          <p:cNvPr id="25603" name="Rectangle 3"/>
           <p:cNvSpPr>
             <a:spLocks noGrp="1" noChangeArrowheads="1"/>
           </p:cNvSpPr>
@@ -4439,6 +3982,7 @@
               <a:rPr lang="vi-VN"/>
               <a:t>sp_BaoCaoDoanhThuHocPhi`: Sử dụng `SUM`, `JOIN` và `GROUP BY` để thống kê tiền học phí thực thu theo từng Khoa.</a:t>
             </a:r>
+            <a:endParaRPr lang="vi-VN"/>
           </a:p>
           <a:p>
             <a:pPr lvl="1"/>
@@ -4450,6 +3994,7 @@
               <a:rPr lang="vi-VN"/>
               <a:t>sp_BaoCaoChatLuong_LHP`: Tính toán tỷ lệ phần trăm Đậu/Rớt và tìm điểm cao nhất của một lớp.</a:t>
             </a:r>
+            <a:endParaRPr lang="vi-VN"/>
           </a:p>
           <a:p>
             <a:pPr lvl="1"/>
@@ -4461,6 +4006,7 @@
               <a:rPr lang="vi-VN"/>
               <a:t>sp_ThongKeSVNoHocPhi`: Lọc danh sách sinh viên chưa hoàn thành học phí trong kỳ để gửi thông báo.</a:t>
             </a:r>
+            <a:endParaRPr lang="vi-VN"/>
           </a:p>
           <a:p>
             <a:endParaRPr lang="en-US" altLang="en-US"/>
@@ -4469,13 +4015,7 @@
       </p:sp>
       <p:sp>
         <p:nvSpPr>
-          <p:cNvPr id="4" name="Text Box 5">
-            <a:extLst>
-              <a:ext uri="{FF2B5EF4-FFF2-40B4-BE49-F238E27FC236}">
-                <a16:creationId xmlns:a16="http://schemas.microsoft.com/office/drawing/2014/main" xmlns="" id="{3D1CE68C-65F7-4C8C-AB01-78D31225A9F1}"/>
-              </a:ext>
-            </a:extLst>
-          </p:cNvPr>
+          <p:cNvPr id="4" name="Text Box 5"/>
           <p:cNvSpPr txBox="1">
             <a:spLocks noChangeArrowheads="1"/>
           </p:cNvSpPr>
@@ -4551,11 +4091,6 @@
         </p:txBody>
       </p:sp>
     </p:spTree>
-    <p:extLst>
-      <p:ext uri="{BB962C8B-B14F-4D97-AF65-F5344CB8AC3E}">
-        <p14:creationId xmlns:p14="http://schemas.microsoft.com/office/powerpoint/2010/main" val="2481661360"/>
-      </p:ext>
-    </p:extLst>
   </p:cSld>
   <p:clrMapOvr>
     <a:masterClrMapping/>
@@ -4589,13 +4124,7 @@
       </p:grpSpPr>
       <p:sp>
         <p:nvSpPr>
-          <p:cNvPr id="25602" name="Rectangle 2">
-            <a:extLst>
-              <a:ext uri="{FF2B5EF4-FFF2-40B4-BE49-F238E27FC236}">
-                <a16:creationId xmlns:a16="http://schemas.microsoft.com/office/drawing/2014/main" xmlns="" id="{D09A8D8C-80F7-440C-BEF1-9EFA4CBAAA33}"/>
-              </a:ext>
-            </a:extLst>
-          </p:cNvPr>
+          <p:cNvPr id="25602" name="Rectangle 2"/>
           <p:cNvSpPr>
             <a:spLocks noGrp="1" noChangeArrowheads="1"/>
           </p:cNvSpPr>
@@ -4623,13 +4152,7 @@
       </p:sp>
       <p:sp>
         <p:nvSpPr>
-          <p:cNvPr id="25603" name="Rectangle 3">
-            <a:extLst>
-              <a:ext uri="{FF2B5EF4-FFF2-40B4-BE49-F238E27FC236}">
-                <a16:creationId xmlns:a16="http://schemas.microsoft.com/office/drawing/2014/main" xmlns="" id="{2EE127BF-401A-4C36-A14A-872ADB44AB18}"/>
-              </a:ext>
-            </a:extLst>
-          </p:cNvPr>
+          <p:cNvPr id="25603" name="Rectangle 3"/>
           <p:cNvSpPr>
             <a:spLocks noGrp="1" noChangeArrowheads="1"/>
           </p:cNvSpPr>
@@ -4663,6 +4186,7 @@
               <a:rPr lang="en-US"/>
               <a:t>func_TinhGPA(mssv)`: Duyệt qua bảng điểm, tính trung bình có trọng số theo số tín chỉ của từng môn học.</a:t>
             </a:r>
+            <a:endParaRPr lang="en-US"/>
           </a:p>
           <a:p>
             <a:pPr lvl="1"/>
@@ -4674,6 +4198,7 @@
               <a:rPr lang="en-US"/>
               <a:t>, maHK)`: Trả về kết quả (Tổng phải nộp - Tổng đã đóng) cho một sinh viên cụ thể.</a:t>
             </a:r>
+            <a:endParaRPr lang="en-US"/>
           </a:p>
           <a:p>
             <a:endParaRPr lang="en-US" altLang="en-US"/>
@@ -4682,13 +4207,7 @@
       </p:sp>
       <p:sp>
         <p:nvSpPr>
-          <p:cNvPr id="4" name="Text Box 5">
-            <a:extLst>
-              <a:ext uri="{FF2B5EF4-FFF2-40B4-BE49-F238E27FC236}">
-                <a16:creationId xmlns:a16="http://schemas.microsoft.com/office/drawing/2014/main" xmlns="" id="{3D1CE68C-65F7-4C8C-AB01-78D31225A9F1}"/>
-              </a:ext>
-            </a:extLst>
-          </p:cNvPr>
+          <p:cNvPr id="4" name="Text Box 5"/>
           <p:cNvSpPr txBox="1">
             <a:spLocks noChangeArrowheads="1"/>
           </p:cNvSpPr>
@@ -4764,11 +4283,6 @@
         </p:txBody>
       </p:sp>
     </p:spTree>
-    <p:extLst>
-      <p:ext uri="{BB962C8B-B14F-4D97-AF65-F5344CB8AC3E}">
-        <p14:creationId xmlns:p14="http://schemas.microsoft.com/office/powerpoint/2010/main" val="4134988937"/>
-      </p:ext>
-    </p:extLst>
   </p:cSld>
   <p:clrMapOvr>
     <a:masterClrMapping/>
@@ -4802,13 +4316,7 @@
       </p:grpSpPr>
       <p:sp>
         <p:nvSpPr>
-          <p:cNvPr id="25602" name="Rectangle 2">
-            <a:extLst>
-              <a:ext uri="{FF2B5EF4-FFF2-40B4-BE49-F238E27FC236}">
-                <a16:creationId xmlns:a16="http://schemas.microsoft.com/office/drawing/2014/main" xmlns="" id="{D09A8D8C-80F7-440C-BEF1-9EFA4CBAAA33}"/>
-              </a:ext>
-            </a:extLst>
-          </p:cNvPr>
+          <p:cNvPr id="25602" name="Rectangle 2"/>
           <p:cNvSpPr>
             <a:spLocks noGrp="1" noChangeArrowheads="1"/>
           </p:cNvSpPr>
@@ -4831,13 +4339,7 @@
       </p:sp>
       <p:sp>
         <p:nvSpPr>
-          <p:cNvPr id="25603" name="Rectangle 3">
-            <a:extLst>
-              <a:ext uri="{FF2B5EF4-FFF2-40B4-BE49-F238E27FC236}">
-                <a16:creationId xmlns:a16="http://schemas.microsoft.com/office/drawing/2014/main" xmlns="" id="{2EE127BF-401A-4C36-A14A-872ADB44AB18}"/>
-              </a:ext>
-            </a:extLst>
-          </p:cNvPr>
+          <p:cNvPr id="25603" name="Rectangle 3"/>
           <p:cNvSpPr>
             <a:spLocks noGrp="1" noChangeArrowheads="1"/>
           </p:cNvSpPr>
@@ -4871,6 +4373,7 @@
               <a:rPr lang="vi-VN"/>
               <a:t>trg_CapNhatHocPhi`: Tự động tính toán số tiền học phí phát sinh ngay khi sinh viên đăng ký môn học (Số tín chỉ * Đơn giá) và cộng vào bảng `HOC_PHI`</a:t>
             </a:r>
+            <a:endParaRPr lang="vi-VN"/>
           </a:p>
           <a:p>
             <a:endParaRPr lang="en-US" altLang="en-US"/>
@@ -4879,13 +4382,7 @@
       </p:sp>
       <p:sp>
         <p:nvSpPr>
-          <p:cNvPr id="4" name="Text Box 5">
-            <a:extLst>
-              <a:ext uri="{FF2B5EF4-FFF2-40B4-BE49-F238E27FC236}">
-                <a16:creationId xmlns:a16="http://schemas.microsoft.com/office/drawing/2014/main" xmlns="" id="{3D1CE68C-65F7-4C8C-AB01-78D31225A9F1}"/>
-              </a:ext>
-            </a:extLst>
-          </p:cNvPr>
+          <p:cNvPr id="4" name="Text Box 5"/>
           <p:cNvSpPr txBox="1">
             <a:spLocks noChangeArrowheads="1"/>
           </p:cNvSpPr>
@@ -4961,11 +4458,6 @@
         </p:txBody>
       </p:sp>
     </p:spTree>
-    <p:extLst>
-      <p:ext uri="{BB962C8B-B14F-4D97-AF65-F5344CB8AC3E}">
-        <p14:creationId xmlns:p14="http://schemas.microsoft.com/office/powerpoint/2010/main" val="507489143"/>
-      </p:ext>
-    </p:extLst>
   </p:cSld>
   <p:clrMapOvr>
     <a:masterClrMapping/>
@@ -4999,13 +4491,7 @@
       </p:grpSpPr>
       <p:sp>
         <p:nvSpPr>
-          <p:cNvPr id="25602" name="Rectangle 2">
-            <a:extLst>
-              <a:ext uri="{FF2B5EF4-FFF2-40B4-BE49-F238E27FC236}">
-                <a16:creationId xmlns:a16="http://schemas.microsoft.com/office/drawing/2014/main" xmlns="" id="{D09A8D8C-80F7-440C-BEF1-9EFA4CBAAA33}"/>
-              </a:ext>
-            </a:extLst>
-          </p:cNvPr>
+          <p:cNvPr id="25602" name="Rectangle 2"/>
           <p:cNvSpPr>
             <a:spLocks noGrp="1" noChangeArrowheads="1"/>
           </p:cNvSpPr>
@@ -5024,13 +4510,7 @@
       </p:sp>
       <p:sp>
         <p:nvSpPr>
-          <p:cNvPr id="25603" name="Rectangle 3">
-            <a:extLst>
-              <a:ext uri="{FF2B5EF4-FFF2-40B4-BE49-F238E27FC236}">
-                <a16:creationId xmlns:a16="http://schemas.microsoft.com/office/drawing/2014/main" xmlns="" id="{2EE127BF-401A-4C36-A14A-872ADB44AB18}"/>
-              </a:ext>
-            </a:extLst>
-          </p:cNvPr>
+          <p:cNvPr id="25603" name="Rectangle 3"/>
           <p:cNvSpPr>
             <a:spLocks noGrp="1" noChangeArrowheads="1"/>
           </p:cNvSpPr>
@@ -5054,13 +4534,7 @@
       </p:sp>
       <p:sp>
         <p:nvSpPr>
-          <p:cNvPr id="4" name="Text Box 5">
-            <a:extLst>
-              <a:ext uri="{FF2B5EF4-FFF2-40B4-BE49-F238E27FC236}">
-                <a16:creationId xmlns:a16="http://schemas.microsoft.com/office/drawing/2014/main" xmlns="" id="{3D1CE68C-65F7-4C8C-AB01-78D31225A9F1}"/>
-              </a:ext>
-            </a:extLst>
-          </p:cNvPr>
+          <p:cNvPr id="4" name="Text Box 5"/>
           <p:cNvSpPr txBox="1">
             <a:spLocks noChangeArrowheads="1"/>
           </p:cNvSpPr>
@@ -5136,11 +4610,6 @@
         </p:txBody>
       </p:sp>
     </p:spTree>
-    <p:extLst>
-      <p:ext uri="{BB962C8B-B14F-4D97-AF65-F5344CB8AC3E}">
-        <p14:creationId xmlns:p14="http://schemas.microsoft.com/office/powerpoint/2010/main" val="678512199"/>
-      </p:ext>
-    </p:extLst>
   </p:cSld>
   <p:clrMapOvr>
     <a:masterClrMapping/>
@@ -5174,13 +4643,7 @@
       </p:grpSpPr>
       <p:sp>
         <p:nvSpPr>
-          <p:cNvPr id="25602" name="Rectangle 2">
-            <a:extLst>
-              <a:ext uri="{FF2B5EF4-FFF2-40B4-BE49-F238E27FC236}">
-                <a16:creationId xmlns:a16="http://schemas.microsoft.com/office/drawing/2014/main" xmlns="" id="{D09A8D8C-80F7-440C-BEF1-9EFA4CBAAA33}"/>
-              </a:ext>
-            </a:extLst>
-          </p:cNvPr>
+          <p:cNvPr id="25602" name="Rectangle 2"/>
           <p:cNvSpPr>
             <a:spLocks noGrp="1" noChangeArrowheads="1"/>
           </p:cNvSpPr>
@@ -5199,13 +4662,7 @@
       </p:sp>
       <p:sp>
         <p:nvSpPr>
-          <p:cNvPr id="25603" name="Rectangle 3">
-            <a:extLst>
-              <a:ext uri="{FF2B5EF4-FFF2-40B4-BE49-F238E27FC236}">
-                <a16:creationId xmlns:a16="http://schemas.microsoft.com/office/drawing/2014/main" xmlns="" id="{2EE127BF-401A-4C36-A14A-872ADB44AB18}"/>
-              </a:ext>
-            </a:extLst>
-          </p:cNvPr>
+          <p:cNvPr id="25603" name="Rectangle 3"/>
           <p:cNvSpPr>
             <a:spLocks noGrp="1" noChangeArrowheads="1"/>
           </p:cNvSpPr>
@@ -5229,13 +4686,7 @@
       </p:sp>
       <p:sp>
         <p:nvSpPr>
-          <p:cNvPr id="4" name="Text Box 5">
-            <a:extLst>
-              <a:ext uri="{FF2B5EF4-FFF2-40B4-BE49-F238E27FC236}">
-                <a16:creationId xmlns:a16="http://schemas.microsoft.com/office/drawing/2014/main" xmlns="" id="{3D1CE68C-65F7-4C8C-AB01-78D31225A9F1}"/>
-              </a:ext>
-            </a:extLst>
-          </p:cNvPr>
+          <p:cNvPr id="4" name="Text Box 5"/>
           <p:cNvSpPr txBox="1">
             <a:spLocks noChangeArrowheads="1"/>
           </p:cNvSpPr>
@@ -5311,11 +4762,6 @@
         </p:txBody>
       </p:sp>
     </p:spTree>
-    <p:extLst>
-      <p:ext uri="{BB962C8B-B14F-4D97-AF65-F5344CB8AC3E}">
-        <p14:creationId xmlns:p14="http://schemas.microsoft.com/office/powerpoint/2010/main" val="228116295"/>
-      </p:ext>
-    </p:extLst>
   </p:cSld>
   <p:clrMapOvr>
     <a:masterClrMapping/>
@@ -5349,13 +4795,7 @@
       </p:grpSpPr>
       <p:sp>
         <p:nvSpPr>
-          <p:cNvPr id="25602" name="Rectangle 2">
-            <a:extLst>
-              <a:ext uri="{FF2B5EF4-FFF2-40B4-BE49-F238E27FC236}">
-                <a16:creationId xmlns:a16="http://schemas.microsoft.com/office/drawing/2014/main" xmlns="" id="{D09A8D8C-80F7-440C-BEF1-9EFA4CBAAA33}"/>
-              </a:ext>
-            </a:extLst>
-          </p:cNvPr>
+          <p:cNvPr id="25602" name="Rectangle 2"/>
           <p:cNvSpPr>
             <a:spLocks noGrp="1" noChangeArrowheads="1"/>
           </p:cNvSpPr>
@@ -5374,13 +4814,7 @@
       </p:sp>
       <p:sp>
         <p:nvSpPr>
-          <p:cNvPr id="25603" name="Rectangle 3">
-            <a:extLst>
-              <a:ext uri="{FF2B5EF4-FFF2-40B4-BE49-F238E27FC236}">
-                <a16:creationId xmlns:a16="http://schemas.microsoft.com/office/drawing/2014/main" xmlns="" id="{2EE127BF-401A-4C36-A14A-872ADB44AB18}"/>
-              </a:ext>
-            </a:extLst>
-          </p:cNvPr>
+          <p:cNvPr id="25603" name="Rectangle 3"/>
           <p:cNvSpPr>
             <a:spLocks noGrp="1" noChangeArrowheads="1"/>
           </p:cNvSpPr>
@@ -5404,13 +4838,7 @@
       </p:sp>
       <p:sp>
         <p:nvSpPr>
-          <p:cNvPr id="4" name="Text Box 5">
-            <a:extLst>
-              <a:ext uri="{FF2B5EF4-FFF2-40B4-BE49-F238E27FC236}">
-                <a16:creationId xmlns:a16="http://schemas.microsoft.com/office/drawing/2014/main" xmlns="" id="{3D1CE68C-65F7-4C8C-AB01-78D31225A9F1}"/>
-              </a:ext>
-            </a:extLst>
-          </p:cNvPr>
+          <p:cNvPr id="4" name="Text Box 5"/>
           <p:cNvSpPr txBox="1">
             <a:spLocks noChangeArrowheads="1"/>
           </p:cNvSpPr>
@@ -5486,11 +4914,6 @@
         </p:txBody>
       </p:sp>
     </p:spTree>
-    <p:extLst>
-      <p:ext uri="{BB962C8B-B14F-4D97-AF65-F5344CB8AC3E}">
-        <p14:creationId xmlns:p14="http://schemas.microsoft.com/office/powerpoint/2010/main" val="2637040012"/>
-      </p:ext>
-    </p:extLst>
   </p:cSld>
   <p:clrMapOvr>
     <a:masterClrMapping/>
@@ -5524,13 +4947,7 @@
       </p:grpSpPr>
       <p:sp>
         <p:nvSpPr>
-          <p:cNvPr id="25602" name="Rectangle 2">
-            <a:extLst>
-              <a:ext uri="{FF2B5EF4-FFF2-40B4-BE49-F238E27FC236}">
-                <a16:creationId xmlns:a16="http://schemas.microsoft.com/office/drawing/2014/main" xmlns="" id="{D09A8D8C-80F7-440C-BEF1-9EFA4CBAAA33}"/>
-              </a:ext>
-            </a:extLst>
-          </p:cNvPr>
+          <p:cNvPr id="25602" name="Rectangle 2"/>
           <p:cNvSpPr>
             <a:spLocks noGrp="1" noChangeArrowheads="1"/>
           </p:cNvSpPr>
@@ -5549,13 +4966,7 @@
       </p:sp>
       <p:sp>
         <p:nvSpPr>
-          <p:cNvPr id="25603" name="Rectangle 3">
-            <a:extLst>
-              <a:ext uri="{FF2B5EF4-FFF2-40B4-BE49-F238E27FC236}">
-                <a16:creationId xmlns:a16="http://schemas.microsoft.com/office/drawing/2014/main" xmlns="" id="{2EE127BF-401A-4C36-A14A-872ADB44AB18}"/>
-              </a:ext>
-            </a:extLst>
-          </p:cNvPr>
+          <p:cNvPr id="25603" name="Rectangle 3"/>
           <p:cNvSpPr>
             <a:spLocks noGrp="1" noChangeArrowheads="1"/>
           </p:cNvSpPr>
@@ -5579,13 +4990,7 @@
       </p:sp>
       <p:sp>
         <p:nvSpPr>
-          <p:cNvPr id="4" name="Text Box 5">
-            <a:extLst>
-              <a:ext uri="{FF2B5EF4-FFF2-40B4-BE49-F238E27FC236}">
-                <a16:creationId xmlns:a16="http://schemas.microsoft.com/office/drawing/2014/main" xmlns="" id="{3D1CE68C-65F7-4C8C-AB01-78D31225A9F1}"/>
-              </a:ext>
-            </a:extLst>
-          </p:cNvPr>
+          <p:cNvPr id="4" name="Text Box 5"/>
           <p:cNvSpPr txBox="1">
             <a:spLocks noChangeArrowheads="1"/>
           </p:cNvSpPr>
@@ -5661,11 +5066,6 @@
         </p:txBody>
       </p:sp>
     </p:spTree>
-    <p:extLst>
-      <p:ext uri="{BB962C8B-B14F-4D97-AF65-F5344CB8AC3E}">
-        <p14:creationId xmlns:p14="http://schemas.microsoft.com/office/powerpoint/2010/main" val="2576528765"/>
-      </p:ext>
-    </p:extLst>
   </p:cSld>
   <p:clrMapOvr>
     <a:masterClrMapping/>
@@ -5699,13 +5099,7 @@
       </p:grpSpPr>
       <p:sp>
         <p:nvSpPr>
-          <p:cNvPr id="25602" name="Rectangle 2">
-            <a:extLst>
-              <a:ext uri="{FF2B5EF4-FFF2-40B4-BE49-F238E27FC236}">
-                <a16:creationId xmlns:a16="http://schemas.microsoft.com/office/drawing/2014/main" xmlns="" id="{D09A8D8C-80F7-440C-BEF1-9EFA4CBAAA33}"/>
-              </a:ext>
-            </a:extLst>
-          </p:cNvPr>
+          <p:cNvPr id="25602" name="Rectangle 2"/>
           <p:cNvSpPr>
             <a:spLocks noGrp="1" noChangeArrowheads="1"/>
           </p:cNvSpPr>
@@ -5724,13 +5118,7 @@
       </p:sp>
       <p:sp>
         <p:nvSpPr>
-          <p:cNvPr id="25603" name="Rectangle 3">
-            <a:extLst>
-              <a:ext uri="{FF2B5EF4-FFF2-40B4-BE49-F238E27FC236}">
-                <a16:creationId xmlns:a16="http://schemas.microsoft.com/office/drawing/2014/main" xmlns="" id="{2EE127BF-401A-4C36-A14A-872ADB44AB18}"/>
-              </a:ext>
-            </a:extLst>
-          </p:cNvPr>
+          <p:cNvPr id="25603" name="Rectangle 3"/>
           <p:cNvSpPr>
             <a:spLocks noGrp="1" noChangeArrowheads="1"/>
           </p:cNvSpPr>
@@ -5754,13 +5142,7 @@
       </p:sp>
       <p:sp>
         <p:nvSpPr>
-          <p:cNvPr id="4" name="Text Box 5">
-            <a:extLst>
-              <a:ext uri="{FF2B5EF4-FFF2-40B4-BE49-F238E27FC236}">
-                <a16:creationId xmlns:a16="http://schemas.microsoft.com/office/drawing/2014/main" xmlns="" id="{3D1CE68C-65F7-4C8C-AB01-78D31225A9F1}"/>
-              </a:ext>
-            </a:extLst>
-          </p:cNvPr>
+          <p:cNvPr id="4" name="Text Box 5"/>
           <p:cNvSpPr txBox="1">
             <a:spLocks noChangeArrowheads="1"/>
           </p:cNvSpPr>
@@ -5836,11 +5218,6 @@
         </p:txBody>
       </p:sp>
     </p:spTree>
-    <p:extLst>
-      <p:ext uri="{BB962C8B-B14F-4D97-AF65-F5344CB8AC3E}">
-        <p14:creationId xmlns:p14="http://schemas.microsoft.com/office/powerpoint/2010/main" val="437413625"/>
-      </p:ext>
-    </p:extLst>
   </p:cSld>
   <p:clrMapOvr>
     <a:masterClrMapping/>
@@ -5874,13 +5251,7 @@
       </p:grpSpPr>
       <p:sp>
         <p:nvSpPr>
-          <p:cNvPr id="25602" name="Rectangle 2">
-            <a:extLst>
-              <a:ext uri="{FF2B5EF4-FFF2-40B4-BE49-F238E27FC236}">
-                <a16:creationId xmlns:a16="http://schemas.microsoft.com/office/drawing/2014/main" xmlns="" id="{D09A8D8C-80F7-440C-BEF1-9EFA4CBAAA33}"/>
-              </a:ext>
-            </a:extLst>
-          </p:cNvPr>
+          <p:cNvPr id="25602" name="Rectangle 2"/>
           <p:cNvSpPr>
             <a:spLocks noGrp="1" noChangeArrowheads="1"/>
           </p:cNvSpPr>
@@ -5899,13 +5270,7 @@
       </p:sp>
       <p:sp>
         <p:nvSpPr>
-          <p:cNvPr id="25603" name="Rectangle 3">
-            <a:extLst>
-              <a:ext uri="{FF2B5EF4-FFF2-40B4-BE49-F238E27FC236}">
-                <a16:creationId xmlns:a16="http://schemas.microsoft.com/office/drawing/2014/main" xmlns="" id="{2EE127BF-401A-4C36-A14A-872ADB44AB18}"/>
-              </a:ext>
-            </a:extLst>
-          </p:cNvPr>
+          <p:cNvPr id="25603" name="Rectangle 3"/>
           <p:cNvSpPr>
             <a:spLocks noGrp="1" noChangeArrowheads="1"/>
           </p:cNvSpPr>
@@ -5929,13 +5294,7 @@
       </p:sp>
       <p:sp>
         <p:nvSpPr>
-          <p:cNvPr id="4" name="Text Box 5">
-            <a:extLst>
-              <a:ext uri="{FF2B5EF4-FFF2-40B4-BE49-F238E27FC236}">
-                <a16:creationId xmlns:a16="http://schemas.microsoft.com/office/drawing/2014/main" xmlns="" id="{3D1CE68C-65F7-4C8C-AB01-78D31225A9F1}"/>
-              </a:ext>
-            </a:extLst>
-          </p:cNvPr>
+          <p:cNvPr id="4" name="Text Box 5"/>
           <p:cNvSpPr txBox="1">
             <a:spLocks noChangeArrowheads="1"/>
           </p:cNvSpPr>
@@ -6011,11 +5370,6 @@
         </p:txBody>
       </p:sp>
     </p:spTree>
-    <p:extLst>
-      <p:ext uri="{BB962C8B-B14F-4D97-AF65-F5344CB8AC3E}">
-        <p14:creationId xmlns:p14="http://schemas.microsoft.com/office/powerpoint/2010/main" val="2774216663"/>
-      </p:ext>
-    </p:extLst>
   </p:cSld>
   <p:clrMapOvr>
     <a:masterClrMapping/>
@@ -6049,13 +5403,7 @@
       </p:grpSpPr>
       <p:sp>
         <p:nvSpPr>
-          <p:cNvPr id="25602" name="Rectangle 2">
-            <a:extLst>
-              <a:ext uri="{FF2B5EF4-FFF2-40B4-BE49-F238E27FC236}">
-                <a16:creationId xmlns:a16="http://schemas.microsoft.com/office/drawing/2014/main" xmlns="" id="{D09A8D8C-80F7-440C-BEF1-9EFA4CBAAA33}"/>
-              </a:ext>
-            </a:extLst>
-          </p:cNvPr>
+          <p:cNvPr id="25602" name="Rectangle 2"/>
           <p:cNvSpPr>
             <a:spLocks noGrp="1" noChangeArrowheads="1"/>
           </p:cNvSpPr>
@@ -6074,13 +5422,7 @@
       </p:sp>
       <p:sp>
         <p:nvSpPr>
-          <p:cNvPr id="25603" name="Rectangle 3">
-            <a:extLst>
-              <a:ext uri="{FF2B5EF4-FFF2-40B4-BE49-F238E27FC236}">
-                <a16:creationId xmlns:a16="http://schemas.microsoft.com/office/drawing/2014/main" xmlns="" id="{2EE127BF-401A-4C36-A14A-872ADB44AB18}"/>
-              </a:ext>
-            </a:extLst>
-          </p:cNvPr>
+          <p:cNvPr id="25603" name="Rectangle 3"/>
           <p:cNvSpPr>
             <a:spLocks noGrp="1" noChangeArrowheads="1"/>
           </p:cNvSpPr>
@@ -6104,13 +5446,7 @@
       </p:sp>
       <p:sp>
         <p:nvSpPr>
-          <p:cNvPr id="4" name="Text Box 5">
-            <a:extLst>
-              <a:ext uri="{FF2B5EF4-FFF2-40B4-BE49-F238E27FC236}">
-                <a16:creationId xmlns:a16="http://schemas.microsoft.com/office/drawing/2014/main" xmlns="" id="{3D1CE68C-65F7-4C8C-AB01-78D31225A9F1}"/>
-              </a:ext>
-            </a:extLst>
-          </p:cNvPr>
+          <p:cNvPr id="4" name="Text Box 5"/>
           <p:cNvSpPr txBox="1">
             <a:spLocks noChangeArrowheads="1"/>
           </p:cNvSpPr>
@@ -6186,11 +5522,6 @@
         </p:txBody>
       </p:sp>
     </p:spTree>
-    <p:extLst>
-      <p:ext uri="{BB962C8B-B14F-4D97-AF65-F5344CB8AC3E}">
-        <p14:creationId xmlns:p14="http://schemas.microsoft.com/office/powerpoint/2010/main" val="236440452"/>
-      </p:ext>
-    </p:extLst>
   </p:cSld>
   <p:clrMapOvr>
     <a:masterClrMapping/>
@@ -6224,13 +5555,7 @@
       </p:grpSpPr>
       <p:sp>
         <p:nvSpPr>
-          <p:cNvPr id="25602" name="Rectangle 2">
-            <a:extLst>
-              <a:ext uri="{FF2B5EF4-FFF2-40B4-BE49-F238E27FC236}">
-                <a16:creationId xmlns:a16="http://schemas.microsoft.com/office/drawing/2014/main" xmlns="" id="{D09A8D8C-80F7-440C-BEF1-9EFA4CBAAA33}"/>
-              </a:ext>
-            </a:extLst>
-          </p:cNvPr>
+          <p:cNvPr id="25602" name="Rectangle 2"/>
           <p:cNvSpPr>
             <a:spLocks noGrp="1" noChangeArrowheads="1"/>
           </p:cNvSpPr>
@@ -6257,13 +5582,7 @@
       </p:sp>
       <p:sp>
         <p:nvSpPr>
-          <p:cNvPr id="25603" name="Rectangle 3">
-            <a:extLst>
-              <a:ext uri="{FF2B5EF4-FFF2-40B4-BE49-F238E27FC236}">
-                <a16:creationId xmlns:a16="http://schemas.microsoft.com/office/drawing/2014/main" xmlns="" id="{2EE127BF-401A-4C36-A14A-872ADB44AB18}"/>
-              </a:ext>
-            </a:extLst>
-          </p:cNvPr>
+          <p:cNvPr id="25603" name="Rectangle 3"/>
           <p:cNvSpPr>
             <a:spLocks noGrp="1" noChangeArrowheads="1"/>
           </p:cNvSpPr>
@@ -6287,13 +5606,7 @@
       </p:sp>
       <p:sp>
         <p:nvSpPr>
-          <p:cNvPr id="4" name="Text Box 5">
-            <a:extLst>
-              <a:ext uri="{FF2B5EF4-FFF2-40B4-BE49-F238E27FC236}">
-                <a16:creationId xmlns:a16="http://schemas.microsoft.com/office/drawing/2014/main" xmlns="" id="{3D1CE68C-65F7-4C8C-AB01-78D31225A9F1}"/>
-              </a:ext>
-            </a:extLst>
-          </p:cNvPr>
+          <p:cNvPr id="4" name="Text Box 5"/>
           <p:cNvSpPr txBox="1">
             <a:spLocks noChangeArrowheads="1"/>
           </p:cNvSpPr>
@@ -6402,13 +5715,7 @@
       </p:grpSpPr>
       <p:sp>
         <p:nvSpPr>
-          <p:cNvPr id="25602" name="Rectangle 2">
-            <a:extLst>
-              <a:ext uri="{FF2B5EF4-FFF2-40B4-BE49-F238E27FC236}">
-                <a16:creationId xmlns:a16="http://schemas.microsoft.com/office/drawing/2014/main" xmlns="" id="{D09A8D8C-80F7-440C-BEF1-9EFA4CBAAA33}"/>
-              </a:ext>
-            </a:extLst>
-          </p:cNvPr>
+          <p:cNvPr id="25602" name="Rectangle 2"/>
           <p:cNvSpPr>
             <a:spLocks noGrp="1" noChangeArrowheads="1"/>
           </p:cNvSpPr>
@@ -6427,13 +5734,7 @@
       </p:sp>
       <p:sp>
         <p:nvSpPr>
-          <p:cNvPr id="25603" name="Rectangle 3">
-            <a:extLst>
-              <a:ext uri="{FF2B5EF4-FFF2-40B4-BE49-F238E27FC236}">
-                <a16:creationId xmlns:a16="http://schemas.microsoft.com/office/drawing/2014/main" xmlns="" id="{2EE127BF-401A-4C36-A14A-872ADB44AB18}"/>
-              </a:ext>
-            </a:extLst>
-          </p:cNvPr>
+          <p:cNvPr id="25603" name="Rectangle 3"/>
           <p:cNvSpPr>
             <a:spLocks noGrp="1" noChangeArrowheads="1"/>
           </p:cNvSpPr>
@@ -6457,13 +5758,7 @@
       </p:sp>
       <p:sp>
         <p:nvSpPr>
-          <p:cNvPr id="4" name="Text Box 5">
-            <a:extLst>
-              <a:ext uri="{FF2B5EF4-FFF2-40B4-BE49-F238E27FC236}">
-                <a16:creationId xmlns:a16="http://schemas.microsoft.com/office/drawing/2014/main" xmlns="" id="{3D1CE68C-65F7-4C8C-AB01-78D31225A9F1}"/>
-              </a:ext>
-            </a:extLst>
-          </p:cNvPr>
+          <p:cNvPr id="4" name="Text Box 5"/>
           <p:cNvSpPr txBox="1">
             <a:spLocks noChangeArrowheads="1"/>
           </p:cNvSpPr>
@@ -6539,11 +5834,6 @@
         </p:txBody>
       </p:sp>
     </p:spTree>
-    <p:extLst>
-      <p:ext uri="{BB962C8B-B14F-4D97-AF65-F5344CB8AC3E}">
-        <p14:creationId xmlns:p14="http://schemas.microsoft.com/office/powerpoint/2010/main" val="1239684215"/>
-      </p:ext>
-    </p:extLst>
   </p:cSld>
   <p:clrMapOvr>
     <a:masterClrMapping/>
@@ -6564,7 +5854,7 @@
     <p:bg>
       <p:bgPr>
         <a:blipFill dpi="0" rotWithShape="0">
-          <a:blip r:embed="rId2"/>
+          <a:blip r:embed="rId1"/>
           <a:srcRect/>
           <a:stretch>
             <a:fillRect/>
@@ -6589,13 +5879,7 @@
       </p:grpSpPr>
       <p:sp>
         <p:nvSpPr>
-          <p:cNvPr id="14339" name="Rectangle 3">
-            <a:extLst>
-              <a:ext uri="{FF2B5EF4-FFF2-40B4-BE49-F238E27FC236}">
-                <a16:creationId xmlns:a16="http://schemas.microsoft.com/office/drawing/2014/main" xmlns="" id="{56E01181-FA81-4C6D-9E62-C7D65FDA831E}"/>
-              </a:ext>
-            </a:extLst>
-          </p:cNvPr>
+          <p:cNvPr id="14339" name="Rectangle 3"/>
           <p:cNvSpPr>
             <a:spLocks noGrp="1" noChangeArrowheads="1"/>
           </p:cNvSpPr>
@@ -6623,13 +5907,7 @@
       </p:sp>
       <p:sp>
         <p:nvSpPr>
-          <p:cNvPr id="3" name="Text Box 5">
-            <a:extLst>
-              <a:ext uri="{FF2B5EF4-FFF2-40B4-BE49-F238E27FC236}">
-                <a16:creationId xmlns:a16="http://schemas.microsoft.com/office/drawing/2014/main" xmlns="" id="{3D1CE68C-65F7-4C8C-AB01-78D31225A9F1}"/>
-              </a:ext>
-            </a:extLst>
-          </p:cNvPr>
+          <p:cNvPr id="3" name="Text Box 5"/>
           <p:cNvSpPr txBox="1">
             <a:spLocks noChangeArrowheads="1"/>
           </p:cNvSpPr>
@@ -6756,6 +6034,7 @@
               <a:rPr lang="en-US" sz="2000" b="1" smtClean="0"/>
               <a:t>NHÓM GIAO LƯU SINH VIÊN, CỰU SINH VIÊN</a:t>
             </a:r>
+            <a:endParaRPr lang="en-US" sz="2000" b="1" smtClean="0"/>
           </a:p>
           <a:p>
             <a:pPr algn="ctr"/>
@@ -6771,6 +6050,11 @@
               </a:rPr>
               <a:t>CTU – CỘNG ĐỒNG SINH VIÊN TRƯỜNG ĐẠI HỌC CẦN THƠ</a:t>
             </a:r>
+            <a:endParaRPr lang="en-US" sz="2200" b="1" smtClean="0">
+              <a:solidFill>
+                <a:srgbClr val="FF0000"/>
+              </a:solidFill>
+            </a:endParaRPr>
           </a:p>
           <a:p>
             <a:pPr algn="ctr"/>
@@ -6803,7 +6087,7 @@
                 <a:solidFill>
                   <a:srgbClr val="FF0000"/>
                 </a:solidFill>
-                <a:hlinkClick r:id="rId2"/>
+                <a:hlinkClick r:id="rId1"/>
               </a:rPr>
               <a:t>www.facebook.com/groups/daihoccantho.ctu</a:t>
             </a:r>
@@ -6817,13 +6101,7 @@
       </p:sp>
       <p:sp>
         <p:nvSpPr>
-          <p:cNvPr id="82" name="Text Box 5">
-            <a:extLst>
-              <a:ext uri="{FF2B5EF4-FFF2-40B4-BE49-F238E27FC236}">
-                <a16:creationId xmlns:a16="http://schemas.microsoft.com/office/drawing/2014/main" xmlns="" id="{3D1CE68C-65F7-4C8C-AB01-78D31225A9F1}"/>
-              </a:ext>
-            </a:extLst>
-          </p:cNvPr>
+          <p:cNvPr id="82" name="Text Box 5"/>
           <p:cNvSpPr txBox="1">
             <a:spLocks noChangeArrowheads="1"/>
           </p:cNvSpPr>
@@ -6937,11 +6215,6 @@
         </p:txBody>
       </p:sp>
     </p:spTree>
-    <p:extLst>
-      <p:ext uri="{BB962C8B-B14F-4D97-AF65-F5344CB8AC3E}">
-        <p14:creationId xmlns:p14="http://schemas.microsoft.com/office/powerpoint/2010/main" val="2122735314"/>
-      </p:ext>
-    </p:extLst>
   </p:cSld>
   <p:clrMapOvr>
     <a:masterClrMapping/>
@@ -6968,13 +6241,7 @@
       </p:grpSpPr>
       <p:sp>
         <p:nvSpPr>
-          <p:cNvPr id="25602" name="Rectangle 2">
-            <a:extLst>
-              <a:ext uri="{FF2B5EF4-FFF2-40B4-BE49-F238E27FC236}">
-                <a16:creationId xmlns:a16="http://schemas.microsoft.com/office/drawing/2014/main" xmlns="" id="{D09A8D8C-80F7-440C-BEF1-9EFA4CBAAA33}"/>
-              </a:ext>
-            </a:extLst>
-          </p:cNvPr>
+          <p:cNvPr id="25602" name="Rectangle 2"/>
           <p:cNvSpPr>
             <a:spLocks noGrp="1" noChangeArrowheads="1"/>
           </p:cNvSpPr>
@@ -7001,13 +6268,7 @@
       </p:sp>
       <p:sp>
         <p:nvSpPr>
-          <p:cNvPr id="25603" name="Rectangle 3">
-            <a:extLst>
-              <a:ext uri="{FF2B5EF4-FFF2-40B4-BE49-F238E27FC236}">
-                <a16:creationId xmlns:a16="http://schemas.microsoft.com/office/drawing/2014/main" xmlns="" id="{2EE127BF-401A-4C36-A14A-872ADB44AB18}"/>
-              </a:ext>
-            </a:extLst>
-          </p:cNvPr>
+          <p:cNvPr id="25603" name="Rectangle 3"/>
           <p:cNvSpPr>
             <a:spLocks noGrp="1" noChangeArrowheads="1"/>
           </p:cNvSpPr>
@@ -7029,6 +6290,7 @@
               <a:rPr lang="vi-VN"/>
               <a:t>Hệ thống được thiết kế theo 3 phân hệ chính dựa trên vai trò người dùng:</a:t>
             </a:r>
+            <a:endParaRPr lang="vi-VN"/>
           </a:p>
           <a:p>
             <a:pPr lvl="1"/>
@@ -7122,13 +6384,7 @@
       </p:sp>
       <p:sp>
         <p:nvSpPr>
-          <p:cNvPr id="4" name="Text Box 5">
-            <a:extLst>
-              <a:ext uri="{FF2B5EF4-FFF2-40B4-BE49-F238E27FC236}">
-                <a16:creationId xmlns:a16="http://schemas.microsoft.com/office/drawing/2014/main" xmlns="" id="{3D1CE68C-65F7-4C8C-AB01-78D31225A9F1}"/>
-              </a:ext>
-            </a:extLst>
-          </p:cNvPr>
+          <p:cNvPr id="4" name="Text Box 5"/>
           <p:cNvSpPr txBox="1">
             <a:spLocks noChangeArrowheads="1"/>
           </p:cNvSpPr>
@@ -7204,11 +6460,6 @@
         </p:txBody>
       </p:sp>
     </p:spTree>
-    <p:extLst>
-      <p:ext uri="{BB962C8B-B14F-4D97-AF65-F5344CB8AC3E}">
-        <p14:creationId xmlns:p14="http://schemas.microsoft.com/office/powerpoint/2010/main" val="1720358581"/>
-      </p:ext>
-    </p:extLst>
   </p:cSld>
   <p:clrMapOvr>
     <a:masterClrMapping/>
@@ -7242,13 +6493,7 @@
       </p:grpSpPr>
       <p:sp>
         <p:nvSpPr>
-          <p:cNvPr id="25602" name="Rectangle 2">
-            <a:extLst>
-              <a:ext uri="{FF2B5EF4-FFF2-40B4-BE49-F238E27FC236}">
-                <a16:creationId xmlns:a16="http://schemas.microsoft.com/office/drawing/2014/main" xmlns="" id="{D09A8D8C-80F7-440C-BEF1-9EFA4CBAAA33}"/>
-              </a:ext>
-            </a:extLst>
-          </p:cNvPr>
+          <p:cNvPr id="25602" name="Rectangle 2"/>
           <p:cNvSpPr>
             <a:spLocks noGrp="1" noChangeArrowheads="1"/>
           </p:cNvSpPr>
@@ -7271,13 +6516,7 @@
       </p:sp>
       <p:sp>
         <p:nvSpPr>
-          <p:cNvPr id="25603" name="Rectangle 3">
-            <a:extLst>
-              <a:ext uri="{FF2B5EF4-FFF2-40B4-BE49-F238E27FC236}">
-                <a16:creationId xmlns:a16="http://schemas.microsoft.com/office/drawing/2014/main" xmlns="" id="{2EE127BF-401A-4C36-A14A-872ADB44AB18}"/>
-              </a:ext>
-            </a:extLst>
-          </p:cNvPr>
+          <p:cNvPr id="25603" name="Rectangle 3"/>
           <p:cNvSpPr>
             <a:spLocks noGrp="1" noChangeArrowheads="1"/>
           </p:cNvSpPr>
@@ -7335,6 +6574,7 @@
               <a:rPr lang="vi-VN" sz="2400"/>
               <a:t>CRUD Khoa, Ngành, Lớp hành chính.</a:t>
             </a:r>
+            <a:endParaRPr lang="vi-VN" sz="2400"/>
           </a:p>
           <a:p>
             <a:pPr lvl="1"/>
@@ -7358,6 +6598,7 @@
               <a:rPr lang="vi-VN" sz="2400"/>
               <a:t>Quản lý danh mục Môn học, số tín chỉ.</a:t>
             </a:r>
+            <a:endParaRPr lang="vi-VN" sz="2400"/>
           </a:p>
           <a:p>
             <a:pPr lvl="1"/>
@@ -7385,6 +6626,7 @@
               <a:rPr lang="vi-VN" sz="2400"/>
               <a:t>lý Học kỳ, thiết lập đơn giá tín chỉ theo năm học.</a:t>
             </a:r>
+            <a:endParaRPr lang="vi-VN" sz="2400"/>
           </a:p>
           <a:p>
             <a:pPr lvl="1"/>
@@ -7408,6 +6650,7 @@
               <a:rPr lang="vi-VN" sz="2400"/>
               <a:t>Quản lý thông tin Giảng viên, Sinh viên; tự động cấp tài khoản.</a:t>
             </a:r>
+            <a:endParaRPr lang="vi-VN" sz="2400"/>
           </a:p>
           <a:p>
             <a:pPr lvl="1"/>
@@ -7431,6 +6674,7 @@
               <a:rPr lang="vi-VN" sz="2400"/>
               <a:t>Xem báo cáo doanh thu học phí, danh sách nợ phí.</a:t>
             </a:r>
+            <a:endParaRPr lang="vi-VN" sz="2400"/>
           </a:p>
           <a:p>
             <a:endParaRPr lang="en-US" altLang="en-US"/>
@@ -7439,13 +6683,7 @@
       </p:sp>
       <p:sp>
         <p:nvSpPr>
-          <p:cNvPr id="4" name="Text Box 5">
-            <a:extLst>
-              <a:ext uri="{FF2B5EF4-FFF2-40B4-BE49-F238E27FC236}">
-                <a16:creationId xmlns:a16="http://schemas.microsoft.com/office/drawing/2014/main" xmlns="" id="{3D1CE68C-65F7-4C8C-AB01-78D31225A9F1}"/>
-              </a:ext>
-            </a:extLst>
-          </p:cNvPr>
+          <p:cNvPr id="4" name="Text Box 5"/>
           <p:cNvSpPr txBox="1">
             <a:spLocks noChangeArrowheads="1"/>
           </p:cNvSpPr>
@@ -7521,11 +6759,6 @@
         </p:txBody>
       </p:sp>
     </p:spTree>
-    <p:extLst>
-      <p:ext uri="{BB962C8B-B14F-4D97-AF65-F5344CB8AC3E}">
-        <p14:creationId xmlns:p14="http://schemas.microsoft.com/office/powerpoint/2010/main" val="1394045574"/>
-      </p:ext>
-    </p:extLst>
   </p:cSld>
   <p:clrMapOvr>
     <a:masterClrMapping/>
@@ -7559,13 +6792,7 @@
       </p:grpSpPr>
       <p:sp>
         <p:nvSpPr>
-          <p:cNvPr id="25602" name="Rectangle 2">
-            <a:extLst>
-              <a:ext uri="{FF2B5EF4-FFF2-40B4-BE49-F238E27FC236}">
-                <a16:creationId xmlns:a16="http://schemas.microsoft.com/office/drawing/2014/main" xmlns="" id="{D09A8D8C-80F7-440C-BEF1-9EFA4CBAAA33}"/>
-              </a:ext>
-            </a:extLst>
-          </p:cNvPr>
+          <p:cNvPr id="25602" name="Rectangle 2"/>
           <p:cNvSpPr>
             <a:spLocks noGrp="1" noChangeArrowheads="1"/>
           </p:cNvSpPr>
@@ -7588,13 +6815,7 @@
       </p:sp>
       <p:sp>
         <p:nvSpPr>
-          <p:cNvPr id="25603" name="Rectangle 3">
-            <a:extLst>
-              <a:ext uri="{FF2B5EF4-FFF2-40B4-BE49-F238E27FC236}">
-                <a16:creationId xmlns:a16="http://schemas.microsoft.com/office/drawing/2014/main" xmlns="" id="{2EE127BF-401A-4C36-A14A-872ADB44AB18}"/>
-              </a:ext>
-            </a:extLst>
-          </p:cNvPr>
+          <p:cNvPr id="25603" name="Rectangle 3"/>
           <p:cNvSpPr>
             <a:spLocks noGrp="1" noChangeArrowheads="1"/>
           </p:cNvSpPr>
@@ -7696,6 +6917,7 @@
               <a:rPr lang="vi-VN"/>
               <a:t>danh sách các lớp học phần được phân công trong kỳ.</a:t>
             </a:r>
+            <a:endParaRPr lang="vi-VN"/>
           </a:p>
           <a:p>
             <a:pPr lvl="1"/>
@@ -7719,6 +6941,7 @@
               <a:rPr lang="vi-VN"/>
               <a:t>Nhập điểm và cập nhật điểm số cho sinh viên trong lớp.</a:t>
             </a:r>
+            <a:endParaRPr lang="vi-VN"/>
           </a:p>
           <a:p>
             <a:pPr lvl="1"/>
@@ -7742,6 +6965,7 @@
               <a:rPr lang="vi-VN"/>
               <a:t>Xem thống kê tỷ lệ Đậu/Rớt của lớp phụ trách.</a:t>
             </a:r>
+            <a:endParaRPr lang="vi-VN"/>
           </a:p>
           <a:p>
             <a:endParaRPr lang="en-US" altLang="en-US"/>
@@ -7750,13 +6974,7 @@
       </p:sp>
       <p:sp>
         <p:nvSpPr>
-          <p:cNvPr id="4" name="Text Box 5">
-            <a:extLst>
-              <a:ext uri="{FF2B5EF4-FFF2-40B4-BE49-F238E27FC236}">
-                <a16:creationId xmlns:a16="http://schemas.microsoft.com/office/drawing/2014/main" xmlns="" id="{3D1CE68C-65F7-4C8C-AB01-78D31225A9F1}"/>
-              </a:ext>
-            </a:extLst>
-          </p:cNvPr>
+          <p:cNvPr id="4" name="Text Box 5"/>
           <p:cNvSpPr txBox="1">
             <a:spLocks noChangeArrowheads="1"/>
           </p:cNvSpPr>
@@ -7832,11 +7050,6 @@
         </p:txBody>
       </p:sp>
     </p:spTree>
-    <p:extLst>
-      <p:ext uri="{BB962C8B-B14F-4D97-AF65-F5344CB8AC3E}">
-        <p14:creationId xmlns:p14="http://schemas.microsoft.com/office/powerpoint/2010/main" val="3957730918"/>
-      </p:ext>
-    </p:extLst>
   </p:cSld>
   <p:clrMapOvr>
     <a:masterClrMapping/>
@@ -7870,13 +7083,7 @@
       </p:grpSpPr>
       <p:sp>
         <p:nvSpPr>
-          <p:cNvPr id="25602" name="Rectangle 2">
-            <a:extLst>
-              <a:ext uri="{FF2B5EF4-FFF2-40B4-BE49-F238E27FC236}">
-                <a16:creationId xmlns:a16="http://schemas.microsoft.com/office/drawing/2014/main" xmlns="" id="{D09A8D8C-80F7-440C-BEF1-9EFA4CBAAA33}"/>
-              </a:ext>
-            </a:extLst>
-          </p:cNvPr>
+          <p:cNvPr id="25602" name="Rectangle 2"/>
           <p:cNvSpPr>
             <a:spLocks noGrp="1" noChangeArrowheads="1"/>
           </p:cNvSpPr>
@@ -7899,13 +7106,7 @@
       </p:sp>
       <p:sp>
         <p:nvSpPr>
-          <p:cNvPr id="25603" name="Rectangle 3">
-            <a:extLst>
-              <a:ext uri="{FF2B5EF4-FFF2-40B4-BE49-F238E27FC236}">
-                <a16:creationId xmlns:a16="http://schemas.microsoft.com/office/drawing/2014/main" xmlns="" id="{2EE127BF-401A-4C36-A14A-872ADB44AB18}"/>
-              </a:ext>
-            </a:extLst>
-          </p:cNvPr>
+          <p:cNvPr id="25603" name="Rectangle 3"/>
           <p:cNvSpPr>
             <a:spLocks noGrp="1" noChangeArrowheads="1"/>
           </p:cNvSpPr>
@@ -8067,6 +7268,7 @@
               <a:rPr lang="en-US"/>
               <a:t>.</a:t>
             </a:r>
+            <a:endParaRPr lang="en-US"/>
           </a:p>
           <a:p>
             <a:pPr lvl="1"/>
@@ -8186,6 +7388,7 @@
               <a:rPr lang="en-US"/>
               <a:t>.</a:t>
             </a:r>
+            <a:endParaRPr lang="en-US"/>
           </a:p>
           <a:p>
             <a:pPr lvl="1"/>
@@ -8345,6 +7548,7 @@
               <a:rPr lang="en-US"/>
               <a:t>.</a:t>
             </a:r>
+            <a:endParaRPr lang="en-US"/>
           </a:p>
           <a:p>
             <a:pPr lvl="1"/>
@@ -8354,13 +7558,7 @@
       </p:sp>
       <p:sp>
         <p:nvSpPr>
-          <p:cNvPr id="4" name="Text Box 5">
-            <a:extLst>
-              <a:ext uri="{FF2B5EF4-FFF2-40B4-BE49-F238E27FC236}">
-                <a16:creationId xmlns:a16="http://schemas.microsoft.com/office/drawing/2014/main" xmlns="" id="{3D1CE68C-65F7-4C8C-AB01-78D31225A9F1}"/>
-              </a:ext>
-            </a:extLst>
-          </p:cNvPr>
+          <p:cNvPr id="4" name="Text Box 5"/>
           <p:cNvSpPr txBox="1">
             <a:spLocks noChangeArrowheads="1"/>
           </p:cNvSpPr>
@@ -8436,11 +7634,6 @@
         </p:txBody>
       </p:sp>
     </p:spTree>
-    <p:extLst>
-      <p:ext uri="{BB962C8B-B14F-4D97-AF65-F5344CB8AC3E}">
-        <p14:creationId xmlns:p14="http://schemas.microsoft.com/office/powerpoint/2010/main" val="765444086"/>
-      </p:ext>
-    </p:extLst>
   </p:cSld>
   <p:clrMapOvr>
     <a:masterClrMapping/>
@@ -8474,13 +7667,7 @@
       </p:grpSpPr>
       <p:sp>
         <p:nvSpPr>
-          <p:cNvPr id="25602" name="Rectangle 2">
-            <a:extLst>
-              <a:ext uri="{FF2B5EF4-FFF2-40B4-BE49-F238E27FC236}">
-                <a16:creationId xmlns:a16="http://schemas.microsoft.com/office/drawing/2014/main" xmlns="" id="{D09A8D8C-80F7-440C-BEF1-9EFA4CBAAA33}"/>
-              </a:ext>
-            </a:extLst>
-          </p:cNvPr>
+          <p:cNvPr id="25602" name="Rectangle 2"/>
           <p:cNvSpPr>
             <a:spLocks noGrp="1" noChangeArrowheads="1"/>
           </p:cNvSpPr>
@@ -8515,13 +7702,7 @@
       </p:sp>
       <p:sp>
         <p:nvSpPr>
-          <p:cNvPr id="4" name="Text Box 5">
-            <a:extLst>
-              <a:ext uri="{FF2B5EF4-FFF2-40B4-BE49-F238E27FC236}">
-                <a16:creationId xmlns:a16="http://schemas.microsoft.com/office/drawing/2014/main" xmlns="" id="{3D1CE68C-65F7-4C8C-AB01-78D31225A9F1}"/>
-              </a:ext>
-            </a:extLst>
-          </p:cNvPr>
+          <p:cNvPr id="4" name="Text Box 5"/>
           <p:cNvSpPr txBox="1">
             <a:spLocks noChangeArrowheads="1"/>
           </p:cNvSpPr>
@@ -8602,13 +7783,7 @@
           <p:cNvGraphicFramePr>
             <a:graphicFrameLocks noGrp="1"/>
           </p:cNvGraphicFramePr>
-          <p:nvPr>
-            <p:extLst>
-              <p:ext uri="{D42A27DB-BD31-4B8C-83A1-F6EECF244321}">
-                <p14:modId xmlns:p14="http://schemas.microsoft.com/office/powerpoint/2010/main" val="3877884494"/>
-              </p:ext>
-            </p:extLst>
-          </p:nvPr>
+          <p:nvPr/>
         </p:nvGraphicFramePr>
         <p:xfrm>
           <a:off x="304800" y="2057400"/>
@@ -8645,7 +7820,6 @@
                         <a:buSzTx/>
                         <a:buFontTx/>
                         <a:buNone/>
-                        <a:tabLst/>
                         <a:defRPr/>
                       </a:pPr>
                       <a:r>
@@ -8716,7 +7890,6 @@
                         <a:buSzTx/>
                         <a:buFontTx/>
                         <a:buNone/>
-                        <a:tabLst/>
                         <a:defRPr/>
                       </a:pPr>
                       <a:r>
@@ -8791,6 +7964,15 @@
                         </a:rPr>
                         <a:t> </a:t>
                       </a:r>
+                      <a:endParaRPr lang="en-US" sz="2000" b="1" kern="1200" smtClean="0">
+                        <a:solidFill>
+                          <a:schemeClr val="tx1"/>
+                        </a:solidFill>
+                        <a:effectLst/>
+                        <a:latin typeface="+mn-lt"/>
+                        <a:ea typeface="+mn-ea"/>
+                        <a:cs typeface="+mn-cs"/>
+                      </a:endParaRPr>
                     </a:p>
                   </a:txBody>
                   <a:tcPr/>
@@ -8814,7 +7996,6 @@
                         <a:buSzTx/>
                         <a:buFontTx/>
                         <a:buNone/>
-                        <a:tabLst/>
                         <a:defRPr/>
                       </a:pPr>
                       <a:r>
@@ -8935,7 +8116,6 @@
                         <a:buSzTx/>
                         <a:buFontTx/>
                         <a:buNone/>
-                        <a:tabLst/>
                         <a:defRPr/>
                       </a:pPr>
                       <a:r>
@@ -8986,6 +8166,15 @@
                         </a:rPr>
                         <a:t> Nguyên</a:t>
                       </a:r>
+                      <a:endParaRPr lang="en-US" sz="2000" b="0" i="0" kern="1200" smtClean="0">
+                        <a:solidFill>
+                          <a:schemeClr val="dk1"/>
+                        </a:solidFill>
+                        <a:effectLst/>
+                        <a:latin typeface="+mn-lt"/>
+                        <a:ea typeface="+mn-ea"/>
+                        <a:cs typeface="+mn-cs"/>
+                      </a:endParaRPr>
                     </a:p>
                     <a:p>
                       <a:pPr algn="l"/>
@@ -9013,7 +8202,6 @@
                         <a:buSzTx/>
                         <a:buFontTx/>
                         <a:buNone/>
-                        <a:tabLst/>
                         <a:defRPr/>
                       </a:pPr>
                       <a:r>
@@ -9028,6 +8216,15 @@
                         </a:rPr>
                         <a:t>Xây dựng hệ thống khung, Quản lý danh mục, Hồ sơ nhân sự và nghiệp vụ Giảng viên.</a:t>
                       </a:r>
+                      <a:endParaRPr lang="vi-VN" sz="1800" b="0" kern="1200" smtClean="0">
+                        <a:solidFill>
+                          <a:schemeClr val="dk1"/>
+                        </a:solidFill>
+                        <a:effectLst/>
+                        <a:latin typeface="+mn-lt"/>
+                        <a:ea typeface="+mn-ea"/>
+                        <a:cs typeface="+mn-cs"/>
+                      </a:endParaRPr>
                     </a:p>
                   </a:txBody>
                   <a:tcPr/>
@@ -9051,7 +8248,6 @@
                         <a:buSzTx/>
                         <a:buFontTx/>
                         <a:buNone/>
-                        <a:tabLst/>
                         <a:defRPr/>
                       </a:pPr>
                       <a:r>
@@ -9066,6 +8262,15 @@
                         </a:rPr>
                         <a:t>CRUD, Stored Procedure báo cáo đào tạo, Hệ thống Menu điều hướng, Bảo mật đăng nhập.</a:t>
                       </a:r>
+                      <a:endParaRPr lang="vi-VN" sz="1800" b="0" kern="1200" smtClean="0">
+                        <a:solidFill>
+                          <a:schemeClr val="dk1"/>
+                        </a:solidFill>
+                        <a:effectLst/>
+                        <a:latin typeface="+mn-lt"/>
+                        <a:ea typeface="+mn-ea"/>
+                        <a:cs typeface="+mn-cs"/>
+                      </a:endParaRPr>
                     </a:p>
                   </a:txBody>
                   <a:tcPr/>
@@ -9091,7 +8296,6 @@
                         <a:buSzTx/>
                         <a:buFontTx/>
                         <a:buNone/>
-                        <a:tabLst/>
                         <a:defRPr/>
                       </a:pPr>
                       <a:r>
@@ -9166,7 +8370,6 @@
                         <a:buSzTx/>
                         <a:buFontTx/>
                         <a:buNone/>
-                        <a:tabLst/>
                         <a:defRPr/>
                       </a:pPr>
                       <a:r>
@@ -9577,6 +8780,15 @@
                         </a:rPr>
                         <a:t>.</a:t>
                       </a:r>
+                      <a:endParaRPr lang="en-US" sz="1800" b="0" kern="1200" smtClean="0">
+                        <a:solidFill>
+                          <a:schemeClr val="dk1"/>
+                        </a:solidFill>
+                        <a:effectLst/>
+                        <a:latin typeface="+mn-lt"/>
+                        <a:ea typeface="+mn-ea"/>
+                        <a:cs typeface="+mn-cs"/>
+                      </a:endParaRPr>
                     </a:p>
                     <a:p>
                       <a:endParaRPr lang="en-US"/>
@@ -9603,7 +8815,6 @@
                         <a:buSzTx/>
                         <a:buFontTx/>
                         <a:buNone/>
-                        <a:tabLst/>
                         <a:defRPr/>
                       </a:pPr>
                       <a:r>
@@ -9618,6 +8829,15 @@
                         </a:rPr>
                         <a:t>Transaction (Đăng ký, Đóng tiền), Stored Function (GPA, Công nợ), Procedure tài chính.</a:t>
                       </a:r>
+                      <a:endParaRPr lang="en-US" sz="1800" b="0" kern="1200" smtClean="0">
+                        <a:solidFill>
+                          <a:schemeClr val="dk1"/>
+                        </a:solidFill>
+                        <a:effectLst/>
+                        <a:latin typeface="+mn-lt"/>
+                        <a:ea typeface="+mn-ea"/>
+                        <a:cs typeface="+mn-cs"/>
+                      </a:endParaRPr>
                     </a:p>
                   </a:txBody>
                   <a:tcPr/>
@@ -9628,11 +8848,6 @@
         </a:graphic>
       </p:graphicFrame>
     </p:spTree>
-    <p:extLst>
-      <p:ext uri="{BB962C8B-B14F-4D97-AF65-F5344CB8AC3E}">
-        <p14:creationId xmlns:p14="http://schemas.microsoft.com/office/powerpoint/2010/main" val="3237865534"/>
-      </p:ext>
-    </p:extLst>
   </p:cSld>
   <p:clrMapOvr>
     <a:masterClrMapping/>
@@ -9666,13 +8881,7 @@
       </p:grpSpPr>
       <p:sp>
         <p:nvSpPr>
-          <p:cNvPr id="25602" name="Rectangle 2">
-            <a:extLst>
-              <a:ext uri="{FF2B5EF4-FFF2-40B4-BE49-F238E27FC236}">
-                <a16:creationId xmlns:a16="http://schemas.microsoft.com/office/drawing/2014/main" xmlns="" id="{D09A8D8C-80F7-440C-BEF1-9EFA4CBAAA33}"/>
-              </a:ext>
-            </a:extLst>
-          </p:cNvPr>
+          <p:cNvPr id="25602" name="Rectangle 2"/>
           <p:cNvSpPr>
             <a:spLocks noGrp="1" noChangeArrowheads="1"/>
           </p:cNvSpPr>
@@ -9703,13 +8912,7 @@
       </p:sp>
       <p:sp>
         <p:nvSpPr>
-          <p:cNvPr id="25603" name="Rectangle 3">
-            <a:extLst>
-              <a:ext uri="{FF2B5EF4-FFF2-40B4-BE49-F238E27FC236}">
-                <a16:creationId xmlns:a16="http://schemas.microsoft.com/office/drawing/2014/main" xmlns="" id="{2EE127BF-401A-4C36-A14A-872ADB44AB18}"/>
-              </a:ext>
-            </a:extLst>
-          </p:cNvPr>
+          <p:cNvPr id="25603" name="Rectangle 3"/>
           <p:cNvSpPr>
             <a:spLocks noGrp="1" noChangeArrowheads="1"/>
           </p:cNvSpPr>
@@ -9733,13 +8936,7 @@
       </p:sp>
       <p:sp>
         <p:nvSpPr>
-          <p:cNvPr id="4" name="Text Box 5">
-            <a:extLst>
-              <a:ext uri="{FF2B5EF4-FFF2-40B4-BE49-F238E27FC236}">
-                <a16:creationId xmlns:a16="http://schemas.microsoft.com/office/drawing/2014/main" xmlns="" id="{3D1CE68C-65F7-4C8C-AB01-78D31225A9F1}"/>
-              </a:ext>
-            </a:extLst>
-          </p:cNvPr>
+          <p:cNvPr id="4" name="Text Box 5"/>
           <p:cNvSpPr txBox="1">
             <a:spLocks noChangeArrowheads="1"/>
           </p:cNvSpPr>
@@ -9815,11 +9012,6 @@
         </p:txBody>
       </p:sp>
     </p:spTree>
-    <p:extLst>
-      <p:ext uri="{BB962C8B-B14F-4D97-AF65-F5344CB8AC3E}">
-        <p14:creationId xmlns:p14="http://schemas.microsoft.com/office/powerpoint/2010/main" val="2073602183"/>
-      </p:ext>
-    </p:extLst>
   </p:cSld>
   <p:clrMapOvr>
     <a:masterClrMapping/>
@@ -9853,13 +9045,7 @@
       </p:grpSpPr>
       <p:sp>
         <p:nvSpPr>
-          <p:cNvPr id="25602" name="Rectangle 2">
-            <a:extLst>
-              <a:ext uri="{FF2B5EF4-FFF2-40B4-BE49-F238E27FC236}">
-                <a16:creationId xmlns:a16="http://schemas.microsoft.com/office/drawing/2014/main" xmlns="" id="{D09A8D8C-80F7-440C-BEF1-9EFA4CBAAA33}"/>
-              </a:ext>
-            </a:extLst>
-          </p:cNvPr>
+          <p:cNvPr id="25602" name="Rectangle 2"/>
           <p:cNvSpPr>
             <a:spLocks noGrp="1" noChangeArrowheads="1"/>
           </p:cNvSpPr>
@@ -9886,13 +9072,7 @@
       </p:sp>
       <p:sp>
         <p:nvSpPr>
-          <p:cNvPr id="25603" name="Rectangle 3">
-            <a:extLst>
-              <a:ext uri="{FF2B5EF4-FFF2-40B4-BE49-F238E27FC236}">
-                <a16:creationId xmlns:a16="http://schemas.microsoft.com/office/drawing/2014/main" xmlns="" id="{2EE127BF-401A-4C36-A14A-872ADB44AB18}"/>
-              </a:ext>
-            </a:extLst>
-          </p:cNvPr>
+          <p:cNvPr id="25603" name="Rectangle 3"/>
           <p:cNvSpPr>
             <a:spLocks noGrp="1" noChangeArrowheads="1"/>
           </p:cNvSpPr>
@@ -9942,6 +9122,7 @@
               <a:rPr lang="vi-VN"/>
               <a:t>Thực hiện kiểm tra sĩ số lớp -&gt; INSERT bảng DIEM -&gt; Cập nhật tiền nợ. Nếu một bước lỗi, hệ thống sẽ `Rollback` để tránh dữ liệu ảo.</a:t>
             </a:r>
+            <a:endParaRPr lang="vi-VN"/>
           </a:p>
           <a:p>
             <a:pPr lvl="1"/>
@@ -9969,6 +9150,7 @@
               <a:rPr lang="vi-VN"/>
               <a:t>Ghi dữ liệu vào bảng `PHIEU_THU` -&gt; Cập nhật số tiền `DaDong` trong bảng `HOC_PHI`. Đảm bảo tính nhất quán của số dư.</a:t>
             </a:r>
+            <a:endParaRPr lang="vi-VN"/>
           </a:p>
           <a:p>
             <a:endParaRPr lang="en-US" altLang="en-US"/>
@@ -9977,13 +9159,7 @@
       </p:sp>
       <p:sp>
         <p:nvSpPr>
-          <p:cNvPr id="4" name="Text Box 5">
-            <a:extLst>
-              <a:ext uri="{FF2B5EF4-FFF2-40B4-BE49-F238E27FC236}">
-                <a16:creationId xmlns:a16="http://schemas.microsoft.com/office/drawing/2014/main" xmlns="" id="{3D1CE68C-65F7-4C8C-AB01-78D31225A9F1}"/>
-              </a:ext>
-            </a:extLst>
-          </p:cNvPr>
+          <p:cNvPr id="4" name="Text Box 5"/>
           <p:cNvSpPr txBox="1">
             <a:spLocks noChangeArrowheads="1"/>
           </p:cNvSpPr>
@@ -10059,11 +9235,6 @@
         </p:txBody>
       </p:sp>
     </p:spTree>
-    <p:extLst>
-      <p:ext uri="{BB962C8B-B14F-4D97-AF65-F5344CB8AC3E}">
-        <p14:creationId xmlns:p14="http://schemas.microsoft.com/office/powerpoint/2010/main" val="1398364281"/>
-      </p:ext>
-    </p:extLst>
   </p:cSld>
   <p:clrMapOvr>
     <a:masterClrMapping/>
@@ -10269,7 +9440,6 @@
       </a:bgFillStyleLst>
     </a:fmtScheme>
   </a:themeElements>
-  <a:objectDefaults/>
   <a:extraClrSchemeLst>
     <a:extraClrScheme>
       <a:clrScheme name="Default Design 1">

</xml_diff>

<commit_message>
chức năng sinh viên pptx
</commit_message>
<xml_diff>
--- a/nguyenb2306564-vib2306600.pptx
+++ b/nguyenb2306564-vib2306600.pptx
@@ -7262,7 +7262,7 @@
             </a:r>
             <a:r>
               <a:rPr lang="en-US" err="1"/>
-              <a:t>mở</a:t>
+              <a:t>mở, hủy đăng ký môn học</a:t>
             </a:r>
             <a:r>
               <a:rPr lang="en-US"/>
@@ -7382,7 +7382,7 @@
             </a:r>
             <a:r>
               <a:rPr lang="en-US" err="1"/>
-              <a:t>lũy</a:t>
+              <a:t>lũy, quản lí các môn không đạt</a:t>
             </a:r>
             <a:r>
               <a:rPr lang="en-US"/>

</xml_diff>

<commit_message>
cập nhật pptx transaction
</commit_message>
<xml_diff>
--- a/nguyenb2306564-vib2306600.pptx
+++ b/nguyenb2306564-vib2306600.pptx
@@ -14,19 +14,21 @@
     <p:sldId id="269" r:id="rId9"/>
     <p:sldId id="270" r:id="rId10"/>
     <p:sldId id="271" r:id="rId11"/>
-    <p:sldId id="272" r:id="rId12"/>
-    <p:sldId id="273" r:id="rId13"/>
-    <p:sldId id="274" r:id="rId14"/>
-    <p:sldId id="275" r:id="rId15"/>
-    <p:sldId id="276" r:id="rId16"/>
-    <p:sldId id="277" r:id="rId17"/>
-    <p:sldId id="278" r:id="rId18"/>
-    <p:sldId id="279" r:id="rId19"/>
-    <p:sldId id="280" r:id="rId20"/>
-    <p:sldId id="281" r:id="rId21"/>
-    <p:sldId id="282" r:id="rId22"/>
-    <p:sldId id="262" r:id="rId23"/>
-    <p:sldId id="264" r:id="rId24"/>
+    <p:sldId id="284" r:id="rId12"/>
+    <p:sldId id="285" r:id="rId13"/>
+    <p:sldId id="272" r:id="rId14"/>
+    <p:sldId id="273" r:id="rId15"/>
+    <p:sldId id="274" r:id="rId16"/>
+    <p:sldId id="275" r:id="rId17"/>
+    <p:sldId id="276" r:id="rId18"/>
+    <p:sldId id="277" r:id="rId19"/>
+    <p:sldId id="278" r:id="rId20"/>
+    <p:sldId id="279" r:id="rId21"/>
+    <p:sldId id="280" r:id="rId22"/>
+    <p:sldId id="281" r:id="rId23"/>
+    <p:sldId id="282" r:id="rId24"/>
+    <p:sldId id="262" r:id="rId25"/>
+    <p:sldId id="264" r:id="rId26"/>
   </p:sldIdLst>
   <p:sldSz cx="9144000" cy="6858000" type="screen4x3"/>
   <p:notesSz cx="6858000" cy="9144000"/>
@@ -716,6 +718,170 @@
 </p:sldLayout>
 </file>
 
+<file path=ppt/slideLayouts/slideLayout12.xml><?xml version="1.0" encoding="utf-8"?>
+<p:sldLayout xmlns:a="http://schemas.openxmlformats.org/drawingml/2006/main" xmlns:r="http://schemas.openxmlformats.org/officeDocument/2006/relationships" xmlns:p="http://schemas.openxmlformats.org/presentationml/2006/main" type="tx" preserve="1">
+  <p:cSld name="Title and Text">
+    <p:spTree>
+      <p:nvGrpSpPr>
+        <p:cNvPr id="1" name=""/>
+        <p:cNvGrpSpPr/>
+        <p:nvPr/>
+      </p:nvGrpSpPr>
+      <p:grpSpPr>
+        <a:xfrm>
+          <a:off x="0" y="0"/>
+          <a:ext cx="0" cy="0"/>
+          <a:chOff x="0" y="0"/>
+          <a:chExt cx="0" cy="0"/>
+        </a:xfrm>
+      </p:grpSpPr>
+      <p:sp>
+        <p:nvSpPr>
+          <p:cNvPr id="2" name="Title 1"/>
+          <p:cNvSpPr>
+            <a:spLocks noGrp="1"/>
+          </p:cNvSpPr>
+          <p:nvPr>
+            <p:ph type="title"/>
+          </p:nvPr>
+        </p:nvSpPr>
+        <p:spPr/>
+        <p:txBody>
+          <a:bodyPr/>
+          <a:lstStyle/>
+          <a:p>
+            <a:r>
+              <a:rPr lang="en-US" smtClean="0"/>
+              <a:t>Click to edit Master title style</a:t>
+            </a:r>
+            <a:endParaRPr lang="en-US"/>
+          </a:p>
+        </p:txBody>
+      </p:sp>
+      <p:sp>
+        <p:nvSpPr>
+          <p:cNvPr id="3" name="Text Placeholder 2"/>
+          <p:cNvSpPr>
+            <a:spLocks noGrp="1"/>
+          </p:cNvSpPr>
+          <p:nvPr>
+            <p:ph type="body" idx="1"/>
+          </p:nvPr>
+        </p:nvSpPr>
+        <p:spPr/>
+        <p:txBody>
+          <a:bodyPr/>
+          <a:lstStyle/>
+          <a:p>
+            <a:pPr lvl="0"/>
+            <a:r>
+              <a:rPr lang="en-US" smtClean="0"/>
+              <a:t>Click to edit Master text styles</a:t>
+            </a:r>
+            <a:endParaRPr lang="en-US" smtClean="0"/>
+          </a:p>
+          <a:p>
+            <a:pPr lvl="1"/>
+            <a:r>
+              <a:rPr lang="en-US" smtClean="0"/>
+              <a:t>Second level</a:t>
+            </a:r>
+            <a:endParaRPr lang="en-US" smtClean="0"/>
+          </a:p>
+          <a:p>
+            <a:pPr lvl="2"/>
+            <a:r>
+              <a:rPr lang="en-US" smtClean="0"/>
+              <a:t>Third level</a:t>
+            </a:r>
+            <a:endParaRPr lang="en-US" smtClean="0"/>
+          </a:p>
+          <a:p>
+            <a:pPr lvl="3"/>
+            <a:r>
+              <a:rPr lang="en-US" smtClean="0"/>
+              <a:t>Fourth level</a:t>
+            </a:r>
+            <a:endParaRPr lang="en-US" smtClean="0"/>
+          </a:p>
+          <a:p>
+            <a:pPr lvl="4"/>
+            <a:r>
+              <a:rPr lang="en-US" smtClean="0"/>
+              <a:t>Fifth level</a:t>
+            </a:r>
+            <a:endParaRPr lang="en-US"/>
+          </a:p>
+        </p:txBody>
+      </p:sp>
+      <p:sp>
+        <p:nvSpPr>
+          <p:cNvPr id="4" name="Date Placeholder 3"/>
+          <p:cNvSpPr>
+            <a:spLocks noGrp="1"/>
+          </p:cNvSpPr>
+          <p:nvPr>
+            <p:ph type="dt" sz="half" idx="10"/>
+          </p:nvPr>
+        </p:nvSpPr>
+        <p:spPr/>
+        <p:txBody>
+          <a:bodyPr/>
+          <a:lstStyle/>
+          <a:p>
+            <a:endParaRPr lang="en-US" altLang="en-US"/>
+          </a:p>
+        </p:txBody>
+      </p:sp>
+      <p:sp>
+        <p:nvSpPr>
+          <p:cNvPr id="5" name="Footer Placeholder 4"/>
+          <p:cNvSpPr>
+            <a:spLocks noGrp="1"/>
+          </p:cNvSpPr>
+          <p:nvPr>
+            <p:ph type="ftr" sz="quarter" idx="11"/>
+          </p:nvPr>
+        </p:nvSpPr>
+        <p:spPr/>
+        <p:txBody>
+          <a:bodyPr/>
+          <a:lstStyle/>
+          <a:p>
+            <a:endParaRPr lang="en-US" altLang="en-US"/>
+          </a:p>
+        </p:txBody>
+      </p:sp>
+      <p:sp>
+        <p:nvSpPr>
+          <p:cNvPr id="6" name="Slide Number Placeholder 5"/>
+          <p:cNvSpPr>
+            <a:spLocks noGrp="1"/>
+          </p:cNvSpPr>
+          <p:nvPr>
+            <p:ph type="sldNum" sz="quarter" idx="12"/>
+          </p:nvPr>
+        </p:nvSpPr>
+        <p:spPr/>
+        <p:txBody>
+          <a:bodyPr/>
+          <a:lstStyle/>
+          <a:p>
+            <a:fld id="{306FFC55-A7E0-43C6-B48A-D297196E04B7}" type="slidenum">
+              <a:rPr lang="en-US" altLang="en-US"/>
+            </a:fld>
+            <a:endParaRPr lang="en-US" altLang="en-US"/>
+          </a:p>
+        </p:txBody>
+      </p:sp>
+    </p:spTree>
+  </p:cSld>
+  <p:clrMapOvr>
+    <a:masterClrMapping/>
+  </p:clrMapOvr>
+</p:sldLayout>
+</file>
+
 <file path=ppt/slideLayouts/slideLayout2.xml><?xml version="1.0" encoding="utf-8"?>
 <p:sldLayout xmlns:a="http://schemas.openxmlformats.org/drawingml/2006/main" xmlns:r="http://schemas.openxmlformats.org/officeDocument/2006/relationships" xmlns:p="http://schemas.openxmlformats.org/presentationml/2006/main" type="obj" preserve="1">
   <p:cSld name="Title and Content">
@@ -2471,7 +2637,7 @@
     <p:bg>
       <p:bgPr>
         <a:blipFill dpi="0" rotWithShape="0">
-          <a:blip r:embed="rId12"/>
+          <a:blip r:embed="rId13"/>
           <a:srcRect/>
           <a:stretch>
             <a:fillRect/>
@@ -2866,6 +3032,7 @@
     <p:sldLayoutId id="2147483657" r:id="rId9"/>
     <p:sldLayoutId id="2147483658" r:id="rId10"/>
     <p:sldLayoutId id="2147483659" r:id="rId11"/>
+    <p:sldLayoutId id="2147483660" r:id="rId12"/>
   </p:sldLayoutIdLst>
   <p:txStyles>
     <p:titleStyle>
@@ -3915,6 +4082,370 @@
         <p:cNvGrpSpPr/>
         <p:nvPr/>
       </p:nvGrpSpPr>
+      <p:grpSpPr/>
+      <p:sp>
+        <p:nvSpPr>
+          <p:cNvPr id="4" name="Title 3"/>
+          <p:cNvSpPr>
+            <a:spLocks noGrp="1"/>
+          </p:cNvSpPr>
+          <p:nvPr>
+            <p:ph type="title"/>
+          </p:nvPr>
+        </p:nvSpPr>
+        <p:spPr/>
+        <p:txBody>
+          <a:bodyPr/>
+          <a:p>
+            <a:r>
+              <a:rPr lang="en-US">
+                <a:sym typeface="+mn-ea"/>
+              </a:rPr>
+              <a:t>STORED </a:t>
+            </a:r>
+            <a:r>
+              <a:rPr lang="en-US" smtClean="0">
+                <a:sym typeface="+mn-ea"/>
+              </a:rPr>
+              <a:t>OBJECTS &amp; LOGIC</a:t>
+            </a:r>
+            <a:endParaRPr lang="en-US"/>
+          </a:p>
+        </p:txBody>
+      </p:sp>
+      <p:sp>
+        <p:nvSpPr>
+          <p:cNvPr id="5" name="Content Placeholder 4"/>
+          <p:cNvSpPr>
+            <a:spLocks noGrp="1"/>
+          </p:cNvSpPr>
+          <p:nvPr>
+            <p:ph idx="1"/>
+          </p:nvPr>
+        </p:nvSpPr>
+        <p:spPr/>
+        <p:txBody>
+          <a:bodyPr/>
+          <a:p>
+            <a:r>
+              <a:rPr lang="vi-VN" b="1">
+                <a:sym typeface="+mn-ea"/>
+              </a:rPr>
+              <a:t>Giao dịch (Transactions) - Xử lý Backend Java:</a:t>
+            </a:r>
+            <a:endParaRPr lang="vi-VN" b="1">
+              <a:sym typeface="+mn-ea"/>
+            </a:endParaRPr>
+          </a:p>
+          <a:p>
+            <a:pPr marL="0" indent="0">
+              <a:buNone/>
+            </a:pPr>
+            <a:r>
+              <a:rPr lang="en-US" altLang="en-US" sz="2600" b="1"/>
+              <a:t>Transaction Hủy </a:t>
+            </a:r>
+            <a:r>
+              <a:rPr lang="" altLang="en-US" sz="2600" b="1"/>
+              <a:t>đă</a:t>
+            </a:r>
+            <a:r>
+              <a:rPr lang="en-US" altLang="en-US" sz="2600" b="1"/>
+              <a:t>ng k</a:t>
+            </a:r>
+            <a:r>
+              <a:rPr lang="" altLang="en-US" sz="2600" b="1"/>
+              <a:t>ý</a:t>
+            </a:r>
+            <a:r>
+              <a:rPr lang="en-US" altLang="en-US" sz="2600" b="1"/>
+              <a:t> học phần</a:t>
+            </a:r>
+            <a:r>
+              <a:rPr lang="en-US" altLang="en-US" sz="2600"/>
+              <a:t>:</a:t>
+            </a:r>
+            <a:endParaRPr lang="en-US" altLang="en-US" sz="2600"/>
+          </a:p>
+          <a:p>
+            <a:pPr marL="0" lvl="1" indent="457200">
+              <a:buNone/>
+            </a:pPr>
+            <a:r>
+              <a:rPr lang="en-US" altLang="en-US">
+                <a:sym typeface="+mn-ea"/>
+              </a:rPr>
+              <a:t>Thực hiện các bước sau:</a:t>
+            </a:r>
+            <a:endParaRPr lang="en-US" altLang="en-US" sz="2600"/>
+          </a:p>
+          <a:p>
+            <a:pPr marL="1143000" lvl="3" indent="-457200">
+              <a:buFont typeface="Arial" panose="020B0604020202020204" pitchFamily="34" charset="0"/>
+              <a:buChar char="•"/>
+            </a:pPr>
+            <a:r>
+              <a:rPr lang="en-US" altLang="en-US" sz="2600"/>
+              <a:t>Xóa </a:t>
+            </a:r>
+            <a:r>
+              <a:rPr lang="" altLang="en-US" sz="2600"/>
+              <a:t>đă</a:t>
+            </a:r>
+            <a:r>
+              <a:rPr lang="en-US" altLang="en-US" sz="2600"/>
+              <a:t>ng k</a:t>
+            </a:r>
+            <a:r>
+              <a:rPr lang="" altLang="en-US" sz="2600"/>
+              <a:t>ý</a:t>
+            </a:r>
+            <a:r>
+              <a:rPr lang="en-US" altLang="en-US" sz="2600"/>
+              <a:t> trong bảng DIEM</a:t>
+            </a:r>
+            <a:endParaRPr lang="en-US" altLang="en-US" sz="2600"/>
+          </a:p>
+          <a:p>
+            <a:pPr marL="1143000" lvl="3" indent="-457200">
+              <a:buFont typeface="Arial" panose="020B0604020202020204" pitchFamily="34" charset="0"/>
+              <a:buChar char="•"/>
+            </a:pPr>
+            <a:r>
+              <a:rPr lang="en-US" altLang="en-US" sz="2600"/>
+              <a:t>(Tùy chọn) Cập nhật lại học phí</a:t>
+            </a:r>
+            <a:endParaRPr lang="en-US" altLang="en-US" sz="2600"/>
+          </a:p>
+          <a:p>
+            <a:pPr marL="685800" lvl="3" indent="0">
+              <a:buNone/>
+            </a:pPr>
+            <a:r>
+              <a:rPr lang="en-US" altLang="en-US" sz="2600"/>
+              <a:t>Nếu có lỗi, hệ thống sẽ ROLLBACK </a:t>
+            </a:r>
+            <a:r>
+              <a:rPr lang="" altLang="en-US" sz="2600"/>
+              <a:t>đ</a:t>
+            </a:r>
+            <a:r>
+              <a:rPr lang="en-US" altLang="en-US" sz="2600"/>
+              <a:t>ể </a:t>
+            </a:r>
+            <a:r>
+              <a:rPr lang="" altLang="en-US" sz="2600"/>
+              <a:t>đ</a:t>
+            </a:r>
+            <a:r>
+              <a:rPr lang="en-US" altLang="en-US" sz="2600"/>
+              <a:t>ảm bảo dữ liệu nhất quá</a:t>
+            </a:r>
+            <a:endParaRPr lang="en-US" altLang="en-US" sz="2600"/>
+          </a:p>
+        </p:txBody>
+      </p:sp>
+    </p:spTree>
+  </p:cSld>
+  <p:clrMapOvr>
+    <a:masterClrMapping/>
+  </p:clrMapOvr>
+</p:sld>
+</file>
+
+<file path=ppt/slides/slide11.xml><?xml version="1.0" encoding="utf-8"?>
+<p:sld xmlns:a="http://schemas.openxmlformats.org/drawingml/2006/main" xmlns:r="http://schemas.openxmlformats.org/officeDocument/2006/relationships" xmlns:p="http://schemas.openxmlformats.org/presentationml/2006/main">
+  <p:cSld>
+    <p:spTree>
+      <p:nvGrpSpPr>
+        <p:cNvPr id="1" name=""/>
+        <p:cNvGrpSpPr/>
+        <p:nvPr/>
+      </p:nvGrpSpPr>
+      <p:grpSpPr/>
+      <p:sp>
+        <p:nvSpPr>
+          <p:cNvPr id="4" name="Title 3"/>
+          <p:cNvSpPr>
+            <a:spLocks noGrp="1"/>
+          </p:cNvSpPr>
+          <p:nvPr>
+            <p:ph type="title"/>
+          </p:nvPr>
+        </p:nvSpPr>
+        <p:spPr/>
+        <p:txBody>
+          <a:bodyPr/>
+          <a:p>
+            <a:r>
+              <a:rPr lang="en-US">
+                <a:sym typeface="+mn-ea"/>
+              </a:rPr>
+              <a:t>STORED </a:t>
+            </a:r>
+            <a:r>
+              <a:rPr lang="en-US" smtClean="0">
+                <a:sym typeface="+mn-ea"/>
+              </a:rPr>
+              <a:t>OBJECTS &amp; LOGIC</a:t>
+            </a:r>
+            <a:endParaRPr lang="en-US"/>
+          </a:p>
+        </p:txBody>
+      </p:sp>
+      <p:sp>
+        <p:nvSpPr>
+          <p:cNvPr id="5" name="Content Placeholder 4"/>
+          <p:cNvSpPr>
+            <a:spLocks noGrp="1"/>
+          </p:cNvSpPr>
+          <p:nvPr>
+            <p:ph idx="1"/>
+          </p:nvPr>
+        </p:nvSpPr>
+        <p:spPr/>
+        <p:txBody>
+          <a:bodyPr/>
+          <a:p>
+            <a:pPr lvl="1">
+              <a:buFont typeface="Arial" panose="020B0604020202020204" pitchFamily="34" charset="0"/>
+              <a:buChar char="•"/>
+            </a:pPr>
+            <a:r>
+              <a:rPr lang="vi-VN" sz="2900" b="1">
+                <a:sym typeface="+mn-ea"/>
+              </a:rPr>
+              <a:t>Giao </a:t>
+            </a:r>
+            <a:r>
+              <a:rPr lang="vi-VN" b="1">
+                <a:sym typeface="+mn-ea"/>
+              </a:rPr>
+              <a:t>dịch (Transactions) - Xử lý Backend Java:</a:t>
+            </a:r>
+            <a:endParaRPr lang="en-US" altLang="en-US" b="1"/>
+          </a:p>
+          <a:p>
+            <a:pPr marL="457200" lvl="1" indent="0">
+              <a:buNone/>
+            </a:pPr>
+            <a:r>
+              <a:rPr lang="en-US" altLang="en-US" b="1"/>
+              <a:t>Transaction </a:t>
+            </a:r>
+            <a:r>
+              <a:rPr lang="" altLang="en-US" b="1"/>
+              <a:t>Đ</a:t>
+            </a:r>
+            <a:r>
+              <a:rPr lang="en-US" altLang="en-US" b="1"/>
+              <a:t>óng tiền học phí:</a:t>
+            </a:r>
+            <a:endParaRPr lang="en-US" altLang="en-US" b="1"/>
+          </a:p>
+          <a:p>
+            <a:pPr marL="457200" lvl="1" indent="457200">
+              <a:buNone/>
+            </a:pPr>
+            <a:r>
+              <a:rPr lang="en-US" altLang="en-US"/>
+              <a:t>Thực hiện các b</a:t>
+            </a:r>
+            <a:r>
+              <a:rPr lang="" altLang="en-US"/>
+              <a:t>ư</a:t>
+            </a:r>
+            <a:r>
+              <a:rPr lang="en-US" altLang="en-US"/>
+              <a:t>ớc sau:</a:t>
+            </a:r>
+            <a:endParaRPr lang="en-US" altLang="en-US"/>
+          </a:p>
+          <a:p>
+            <a:pPr lvl="2"/>
+            <a:r>
+              <a:rPr lang="en-US" altLang="en-US"/>
+              <a:t>Ghi nhận thông tin thanh toán vào bảng PHIEU_THU</a:t>
+            </a:r>
+            <a:endParaRPr lang="en-US" altLang="en-US"/>
+          </a:p>
+          <a:p>
+            <a:pPr lvl="2"/>
+            <a:r>
+              <a:rPr lang="en-US" altLang="en-US"/>
+              <a:t>Cập nhật số tiền </a:t>
+            </a:r>
+            <a:r>
+              <a:rPr lang="" altLang="en-US"/>
+              <a:t>đ</a:t>
+            </a:r>
+            <a:r>
+              <a:rPr lang="en-US" altLang="en-US"/>
+              <a:t>ã </a:t>
+            </a:r>
+            <a:r>
+              <a:rPr lang="" altLang="en-US"/>
+              <a:t>đ</a:t>
+            </a:r>
+            <a:r>
+              <a:rPr lang="en-US" altLang="en-US"/>
+              <a:t>óng (DaDong) trong bảng HOC_PHI</a:t>
+            </a:r>
+            <a:endParaRPr lang="en-US" altLang="en-US"/>
+          </a:p>
+          <a:p>
+            <a:pPr lvl="2"/>
+            <a:r>
+              <a:rPr lang="en-US" altLang="en-US"/>
+              <a:t>Cập nhật trạng thái học phí (TrangThai) dựa trên số tiền </a:t>
+            </a:r>
+            <a:r>
+              <a:rPr lang="" altLang="en-US"/>
+              <a:t>đ</a:t>
+            </a:r>
+            <a:r>
+              <a:rPr lang="en-US" altLang="en-US"/>
+              <a:t>ã </a:t>
+            </a:r>
+            <a:r>
+              <a:rPr lang="" altLang="en-US"/>
+              <a:t>đ</a:t>
+            </a:r>
+            <a:r>
+              <a:rPr lang="en-US" altLang="en-US"/>
+              <a:t>óng và tổng tiền</a:t>
+            </a:r>
+            <a:endParaRPr lang="en-US" altLang="en-US"/>
+          </a:p>
+          <a:p>
+            <a:pPr marL="914400" lvl="2" indent="0">
+              <a:buNone/>
+            </a:pPr>
+            <a:r>
+              <a:rPr lang="en-US" altLang="en-US" sz="2600"/>
+              <a:t>Nếu có lỗi hệ thống sẽ ROLLBACK để đảm bảo dữ liệu chính xác</a:t>
+            </a:r>
+            <a:endParaRPr lang="en-US" altLang="en-US" sz="2600"/>
+          </a:p>
+        </p:txBody>
+      </p:sp>
+    </p:spTree>
+  </p:cSld>
+  <p:clrMapOvr>
+    <a:masterClrMapping/>
+  </p:clrMapOvr>
+</p:sld>
+</file>
+
+<file path=ppt/slides/slide12.xml><?xml version="1.0" encoding="utf-8"?>
+<p:sld xmlns:a="http://schemas.openxmlformats.org/drawingml/2006/main" xmlns:r="http://schemas.openxmlformats.org/officeDocument/2006/relationships" xmlns:p="http://schemas.openxmlformats.org/presentationml/2006/main">
+  <p:cSld>
+    <p:spTree>
+      <p:nvGrpSpPr>
+        <p:cNvPr id="1" name=""/>
+        <p:cNvGrpSpPr/>
+        <p:nvPr/>
+      </p:nvGrpSpPr>
       <p:grpSpPr>
         <a:xfrm>
           <a:off x="0" y="0"/>
@@ -4105,7 +4636,7 @@
 </p:sld>
 </file>
 
-<file path=ppt/slides/slide11.xml><?xml version="1.0" encoding="utf-8"?>
+<file path=ppt/slides/slide13.xml><?xml version="1.0" encoding="utf-8"?>
 <p:sld xmlns:a="http://schemas.openxmlformats.org/drawingml/2006/main" xmlns:r="http://schemas.openxmlformats.org/officeDocument/2006/relationships" xmlns:p="http://schemas.openxmlformats.org/presentationml/2006/main">
   <p:cSld>
     <p:spTree>
@@ -4297,7 +4828,7 @@
 </p:sld>
 </file>
 
-<file path=ppt/slides/slide12.xml><?xml version="1.0" encoding="utf-8"?>
+<file path=ppt/slides/slide14.xml><?xml version="1.0" encoding="utf-8"?>
 <p:sld xmlns:a="http://schemas.openxmlformats.org/drawingml/2006/main" xmlns:r="http://schemas.openxmlformats.org/officeDocument/2006/relationships" xmlns:p="http://schemas.openxmlformats.org/presentationml/2006/main">
   <p:cSld>
     <p:spTree>
@@ -4472,7 +5003,7 @@
 </p:sld>
 </file>
 
-<file path=ppt/slides/slide13.xml><?xml version="1.0" encoding="utf-8"?>
+<file path=ppt/slides/slide15.xml><?xml version="1.0" encoding="utf-8"?>
 <p:sld xmlns:a="http://schemas.openxmlformats.org/drawingml/2006/main" xmlns:r="http://schemas.openxmlformats.org/officeDocument/2006/relationships" xmlns:p="http://schemas.openxmlformats.org/presentationml/2006/main">
   <p:cSld>
     <p:spTree>
@@ -4624,7 +5155,7 @@
 </p:sld>
 </file>
 
-<file path=ppt/slides/slide14.xml><?xml version="1.0" encoding="utf-8"?>
+<file path=ppt/slides/slide16.xml><?xml version="1.0" encoding="utf-8"?>
 <p:sld xmlns:a="http://schemas.openxmlformats.org/drawingml/2006/main" xmlns:r="http://schemas.openxmlformats.org/officeDocument/2006/relationships" xmlns:p="http://schemas.openxmlformats.org/presentationml/2006/main">
   <p:cSld>
     <p:spTree>
@@ -4776,7 +5307,7 @@
 </p:sld>
 </file>
 
-<file path=ppt/slides/slide15.xml><?xml version="1.0" encoding="utf-8"?>
+<file path=ppt/slides/slide17.xml><?xml version="1.0" encoding="utf-8"?>
 <p:sld xmlns:a="http://schemas.openxmlformats.org/drawingml/2006/main" xmlns:r="http://schemas.openxmlformats.org/officeDocument/2006/relationships" xmlns:p="http://schemas.openxmlformats.org/presentationml/2006/main">
   <p:cSld>
     <p:spTree>
@@ -4928,7 +5459,7 @@
 </p:sld>
 </file>
 
-<file path=ppt/slides/slide16.xml><?xml version="1.0" encoding="utf-8"?>
+<file path=ppt/slides/slide18.xml><?xml version="1.0" encoding="utf-8"?>
 <p:sld xmlns:a="http://schemas.openxmlformats.org/drawingml/2006/main" xmlns:r="http://schemas.openxmlformats.org/officeDocument/2006/relationships" xmlns:p="http://schemas.openxmlformats.org/presentationml/2006/main">
   <p:cSld>
     <p:spTree>
@@ -5080,7 +5611,7 @@
 </p:sld>
 </file>
 
-<file path=ppt/slides/slide17.xml><?xml version="1.0" encoding="utf-8"?>
+<file path=ppt/slides/slide19.xml><?xml version="1.0" encoding="utf-8"?>
 <p:sld xmlns:a="http://schemas.openxmlformats.org/drawingml/2006/main" xmlns:r="http://schemas.openxmlformats.org/officeDocument/2006/relationships" xmlns:p="http://schemas.openxmlformats.org/presentationml/2006/main">
   <p:cSld>
     <p:spTree>
@@ -5232,7 +5763,7 @@
 </p:sld>
 </file>
 
-<file path=ppt/slides/slide18.xml><?xml version="1.0" encoding="utf-8"?>
+<file path=ppt/slides/slide2.xml><?xml version="1.0" encoding="utf-8"?>
 <p:sld xmlns:a="http://schemas.openxmlformats.org/drawingml/2006/main" xmlns:r="http://schemas.openxmlformats.org/officeDocument/2006/relationships" xmlns:p="http://schemas.openxmlformats.org/presentationml/2006/main">
   <p:cSld>
     <p:spTree>
@@ -5264,6 +5795,14 @@
           <a:bodyPr/>
           <a:lstStyle/>
           <a:p>
+            <a:r>
+              <a:rPr lang="en-US"/>
+              <a:t>THÔNG TIN </a:t>
+            </a:r>
+            <a:r>
+              <a:rPr lang="en-US" smtClean="0"/>
+              <a:t>CHUNG</a:t>
+            </a:r>
             <a:endParaRPr lang="en-US" altLang="en-US"/>
           </a:p>
         </p:txBody>
@@ -5384,7 +5923,7 @@
 </p:sld>
 </file>
 
-<file path=ppt/slides/slide19.xml><?xml version="1.0" encoding="utf-8"?>
+<file path=ppt/slides/slide20.xml><?xml version="1.0" encoding="utf-8"?>
 <p:sld xmlns:a="http://schemas.openxmlformats.org/drawingml/2006/main" xmlns:r="http://schemas.openxmlformats.org/officeDocument/2006/relationships" xmlns:p="http://schemas.openxmlformats.org/presentationml/2006/main">
   <p:cSld>
     <p:spTree>
@@ -5536,7 +6075,7 @@
 </p:sld>
 </file>
 
-<file path=ppt/slides/slide2.xml><?xml version="1.0" encoding="utf-8"?>
+<file path=ppt/slides/slide21.xml><?xml version="1.0" encoding="utf-8"?>
 <p:sld xmlns:a="http://schemas.openxmlformats.org/drawingml/2006/main" xmlns:r="http://schemas.openxmlformats.org/officeDocument/2006/relationships" xmlns:p="http://schemas.openxmlformats.org/presentationml/2006/main">
   <p:cSld>
     <p:spTree>
@@ -5568,14 +6107,6 @@
           <a:bodyPr/>
           <a:lstStyle/>
           <a:p>
-            <a:r>
-              <a:rPr lang="en-US"/>
-              <a:t>THÔNG TIN </a:t>
-            </a:r>
-            <a:r>
-              <a:rPr lang="en-US" smtClean="0"/>
-              <a:t>CHUNG</a:t>
-            </a:r>
             <a:endParaRPr lang="en-US" altLang="en-US"/>
           </a:p>
         </p:txBody>
@@ -5696,7 +6227,7 @@
 </p:sld>
 </file>
 
-<file path=ppt/slides/slide20.xml><?xml version="1.0" encoding="utf-8"?>
+<file path=ppt/slides/slide22.xml><?xml version="1.0" encoding="utf-8"?>
 <p:sld xmlns:a="http://schemas.openxmlformats.org/drawingml/2006/main" xmlns:r="http://schemas.openxmlformats.org/officeDocument/2006/relationships" xmlns:p="http://schemas.openxmlformats.org/presentationml/2006/main">
   <p:cSld>
     <p:spTree>
@@ -5848,7 +6379,7 @@
 </p:sld>
 </file>
 
-<file path=ppt/slides/slide21.xml><?xml version="1.0" encoding="utf-8"?>
+<file path=ppt/slides/slide23.xml><?xml version="1.0" encoding="utf-8"?>
 <p:sld xmlns:a="http://schemas.openxmlformats.org/drawingml/2006/main" xmlns:r="http://schemas.openxmlformats.org/officeDocument/2006/relationships" xmlns:p="http://schemas.openxmlformats.org/presentationml/2006/main" showMasterSp="0">
   <p:cSld>
     <p:bg>
@@ -5990,7 +6521,7 @@
 </p:sld>
 </file>
 
-<file path=ppt/slides/slide22.xml><?xml version="1.0" encoding="utf-8"?>
+<file path=ppt/slides/slide24.xml><?xml version="1.0" encoding="utf-8"?>
 <p:sld xmlns:a="http://schemas.openxmlformats.org/drawingml/2006/main" xmlns:r="http://schemas.openxmlformats.org/officeDocument/2006/relationships" xmlns:p="http://schemas.openxmlformats.org/presentationml/2006/main">
   <p:cSld>
     <p:spTree>
@@ -6596,7 +7127,15 @@
             </a:r>
             <a:r>
               <a:rPr lang="vi-VN" sz="2400"/>
-              <a:t>Quản lý danh mục Môn học, số tín chỉ.</a:t>
+              <a:t>Quản lý danh mục Môn học, số tín chỉ</a:t>
+            </a:r>
+            <a:r>
+              <a:rPr lang="en-US" altLang="vi-VN" sz="2400"/>
+              <a:t> và lớp học phần</a:t>
+            </a:r>
+            <a:r>
+              <a:rPr lang="vi-VN" sz="2400"/>
+              <a:t>.</a:t>
             </a:r>
             <a:endParaRPr lang="vi-VN" sz="2400"/>
           </a:p>
@@ -7530,7 +8069,7 @@
             </a:r>
             <a:r>
               <a:rPr lang="en-US"/>
-              <a:t> </a:t>
+              <a:t> trực tiếp / </a:t>
             </a:r>
             <a:r>
               <a:rPr lang="en-US" err="1"/>
@@ -8827,7 +9366,7 @@
                           <a:ea typeface="+mn-ea"/>
                           <a:cs typeface="+mn-cs"/>
                         </a:rPr>
-                        <a:t>Transaction (Đăng ký, Đóng tiền), Stored Function (GPA, Công nợ), Procedure tài chính.</a:t>
+                        <a:t>Transaction (Đăng ký,Hủy đăng ký, Đóng học phí), Stored Function (GPA, Công nợ,...), Procedure tài chính.</a:t>
                       </a:r>
                       <a:endParaRPr lang="en-US" sz="1800" b="0" kern="1200" smtClean="0">
                         <a:solidFill>
@@ -9097,62 +9636,121 @@
             <a:endParaRPr lang="vi-VN"/>
           </a:p>
           <a:p>
-            <a:pPr lvl="1"/>
-            <a:r>
-              <a:rPr lang="vi-VN" b="1" smtClean="0"/>
+            <a:pPr marL="457200" lvl="1" indent="0">
+              <a:buNone/>
+            </a:pPr>
+            <a:r>
+              <a:rPr lang="en-US" altLang="en-US"/>
               <a:t>Transaction </a:t>
             </a:r>
             <a:r>
-              <a:rPr lang="vi-VN" b="1"/>
-              <a:t>Đăng ký học </a:t>
-            </a:r>
-            <a:r>
-              <a:rPr lang="vi-VN" b="1"/>
-              <a:t>phần</a:t>
-            </a:r>
-            <a:r>
-              <a:rPr lang="vi-VN" b="1" smtClean="0"/>
-              <a:t>:</a:t>
-            </a:r>
-            <a:r>
-              <a:rPr lang="vi-VN" smtClean="0"/>
-              <a:t> </a:t>
-            </a:r>
-            <a:r>
-              <a:rPr lang="vi-VN"/>
-              <a:t>Thực hiện kiểm tra sĩ số lớp -&gt; INSERT bảng DIEM -&gt; Cập nhật tiền nợ. Nếu một bước lỗi, hệ thống sẽ `Rollback` để tránh dữ liệu ảo.</a:t>
-            </a:r>
-            <a:endParaRPr lang="vi-VN"/>
-          </a:p>
-          <a:p>
-            <a:pPr lvl="1"/>
-            <a:r>
-              <a:rPr lang="vi-VN" b="1" smtClean="0"/>
-              <a:t>Transaction </a:t>
-            </a:r>
-            <a:r>
-              <a:rPr lang="vi-VN" b="1"/>
-              <a:t>Đóng tiền học </a:t>
-            </a:r>
-            <a:r>
-              <a:rPr lang="vi-VN" b="1"/>
-              <a:t>phí</a:t>
-            </a:r>
-            <a:r>
-              <a:rPr lang="vi-VN" b="1" smtClean="0"/>
-              <a:t>:</a:t>
-            </a:r>
-            <a:r>
-              <a:rPr lang="vi-VN" smtClean="0"/>
-              <a:t> </a:t>
-            </a:r>
-            <a:r>
-              <a:rPr lang="vi-VN"/>
-              <a:t>Ghi dữ liệu vào bảng `PHIEU_THU` -&gt; Cập nhật số tiền `DaDong` trong bảng `HOC_PHI`. Đảm bảo tính nhất quán của số dư.</a:t>
-            </a:r>
-            <a:endParaRPr lang="vi-VN"/>
-          </a:p>
-          <a:p>
+              <a:rPr lang="" altLang="en-US"/>
+              <a:t>Đă</a:t>
+            </a:r>
+            <a:r>
+              <a:rPr lang="en-US" altLang="en-US"/>
+              <a:t>ng k</a:t>
+            </a:r>
+            <a:r>
+              <a:rPr lang="" altLang="en-US"/>
+              <a:t>ý</a:t>
+            </a:r>
+            <a:r>
+              <a:rPr lang="en-US" altLang="en-US"/>
+              <a:t> học phần:</a:t>
+            </a:r>
+            <a:endParaRPr lang="en-US" altLang="en-US"/>
+          </a:p>
+          <a:p>
+            <a:pPr marL="457200" lvl="2" indent="457200">
+              <a:buNone/>
+            </a:pPr>
+            <a:r>
+              <a:rPr lang="en-US" altLang="en-US" sz="2600">
+                <a:sym typeface="+mn-ea"/>
+              </a:rPr>
+              <a:t>Thực </a:t>
+            </a:r>
+            <a:r>
+              <a:rPr lang="en-US" altLang="en-US">
+                <a:sym typeface="+mn-ea"/>
+              </a:rPr>
+              <a:t>hiện các bước sau:</a:t>
+            </a:r>
+            <a:endParaRPr lang="en-US" altLang="en-US"/>
+          </a:p>
+          <a:p>
+            <a:pPr lvl="2"/>
+            <a:r>
+              <a:rPr lang="en-US" altLang="en-US"/>
+              <a:t>Kiểm tra s</a:t>
+            </a:r>
+            <a:r>
+              <a:rPr lang="" altLang="en-US"/>
+              <a:t>ĩ</a:t>
+            </a:r>
+            <a:r>
+              <a:rPr lang="en-US" altLang="en-US"/>
+              <a:t> số lớp học phần</a:t>
+            </a:r>
+            <a:endParaRPr lang="en-US" altLang="en-US"/>
+          </a:p>
+          <a:p>
+            <a:pPr lvl="2"/>
+            <a:r>
+              <a:rPr lang="en-US" altLang="en-US"/>
+              <a:t>Thêm </a:t>
+            </a:r>
+            <a:r>
+              <a:rPr lang="" altLang="en-US"/>
+              <a:t>đă</a:t>
+            </a:r>
+            <a:r>
+              <a:rPr lang="en-US" altLang="en-US"/>
+              <a:t>ng k</a:t>
+            </a:r>
+            <a:r>
+              <a:rPr lang="" altLang="en-US"/>
+              <a:t>ý</a:t>
+            </a:r>
+            <a:r>
+              <a:rPr lang="en-US" altLang="en-US"/>
+              <a:t> vào bảng DIEM</a:t>
+            </a:r>
+            <a:endParaRPr lang="en-US" altLang="en-US"/>
+          </a:p>
+          <a:p>
+            <a:pPr lvl="2"/>
+            <a:r>
+              <a:rPr lang="en-US" altLang="en-US"/>
+              <a:t>Cập nhật học phí (nếu có)</a:t>
+            </a:r>
+            <a:endParaRPr lang="en-US" altLang="en-US"/>
+          </a:p>
+          <a:p>
+            <a:pPr marL="457200" lvl="1" indent="457200">
+              <a:buNone/>
+            </a:pPr>
+            <a:r>
+              <a:rPr lang="en-US" altLang="en-US"/>
+              <a:t>Nếu có lỗi, hệ thống sẽ ROLLBACK </a:t>
+            </a:r>
+            <a:r>
+              <a:rPr lang="" altLang="en-US"/>
+              <a:t>đ</a:t>
+            </a:r>
+            <a:r>
+              <a:rPr lang="en-US" altLang="en-US"/>
+              <a:t>ể </a:t>
+            </a:r>
+            <a:r>
+              <a:rPr lang="" altLang="en-US"/>
+              <a:t>đ</a:t>
+            </a:r>
+            <a:r>
+              <a:rPr lang="en-US" altLang="en-US"/>
+              <a:t>ảm bảo dữ liệu nhất quán.</a:t>
+            </a:r>
             <a:endParaRPr lang="en-US" altLang="en-US"/>
           </a:p>
         </p:txBody>

</xml_diff>

<commit_message>
chỉnh sửa hiển thị đăng ký học phần
</commit_message>
<xml_diff>
--- a/nguyenb2306564-vib2306600.pptx
+++ b/nguyenb2306564-vib2306600.pptx
@@ -4146,7 +4146,7 @@
               <a:t>Transaction Hủy </a:t>
             </a:r>
             <a:r>
-              <a:rPr lang="" altLang="en-US" sz="2600" b="1"/>
+              <a:rPr lang="en-US" altLang="en-US" sz="2600" b="1"/>
               <a:t>đă</a:t>
             </a:r>
             <a:r>
@@ -4154,7 +4154,7 @@
               <a:t>ng k</a:t>
             </a:r>
             <a:r>
-              <a:rPr lang="" altLang="en-US" sz="2600" b="1"/>
+              <a:rPr lang="en-US" altLang="en-US" sz="2600" b="1"/>
               <a:t>ý</a:t>
             </a:r>
             <a:r>
@@ -4189,7 +4189,7 @@
               <a:t>Xóa </a:t>
             </a:r>
             <a:r>
-              <a:rPr lang="" altLang="en-US" sz="2600"/>
+              <a:rPr lang="en-US" altLang="en-US" sz="2600"/>
               <a:t>đă</a:t>
             </a:r>
             <a:r>
@@ -4197,7 +4197,7 @@
               <a:t>ng k</a:t>
             </a:r>
             <a:r>
-              <a:rPr lang="" altLang="en-US" sz="2600"/>
+              <a:rPr lang="en-US" altLang="en-US" sz="2600"/>
               <a:t>ý</a:t>
             </a:r>
             <a:r>
@@ -4226,7 +4226,7 @@
               <a:t>Nếu có lỗi, hệ thống sẽ ROLLBACK </a:t>
             </a:r>
             <a:r>
-              <a:rPr lang="" altLang="en-US" sz="2600"/>
+              <a:rPr lang="en-US" altLang="en-US" sz="2600"/>
               <a:t>đ</a:t>
             </a:r>
             <a:r>
@@ -4234,7 +4234,7 @@
               <a:t>ể </a:t>
             </a:r>
             <a:r>
-              <a:rPr lang="" altLang="en-US" sz="2600"/>
+              <a:rPr lang="en-US" altLang="en-US" sz="2600"/>
               <a:t>đ</a:t>
             </a:r>
             <a:r>
@@ -4334,7 +4334,7 @@
               <a:t>Transaction </a:t>
             </a:r>
             <a:r>
-              <a:rPr lang="" altLang="en-US" b="1"/>
+              <a:rPr lang="en-US" altLang="en-US" b="1"/>
               <a:t>Đ</a:t>
             </a:r>
             <a:r>
@@ -4352,7 +4352,7 @@
               <a:t>Thực hiện các b</a:t>
             </a:r>
             <a:r>
-              <a:rPr lang="" altLang="en-US"/>
+              <a:rPr lang="en-US" altLang="en-US"/>
               <a:t>ư</a:t>
             </a:r>
             <a:r>
@@ -4376,7 +4376,7 @@
               <a:t>Cập nhật số tiền </a:t>
             </a:r>
             <a:r>
-              <a:rPr lang="" altLang="en-US"/>
+              <a:rPr lang="en-US" altLang="en-US"/>
               <a:t>đ</a:t>
             </a:r>
             <a:r>
@@ -4384,7 +4384,7 @@
               <a:t>ã </a:t>
             </a:r>
             <a:r>
-              <a:rPr lang="" altLang="en-US"/>
+              <a:rPr lang="en-US" altLang="en-US"/>
               <a:t>đ</a:t>
             </a:r>
             <a:r>
@@ -4400,7 +4400,7 @@
               <a:t>Cập nhật trạng thái học phí (TrangThai) dựa trên số tiền </a:t>
             </a:r>
             <a:r>
-              <a:rPr lang="" altLang="en-US"/>
+              <a:rPr lang="en-US" altLang="en-US"/>
               <a:t>đ</a:t>
             </a:r>
             <a:r>
@@ -4408,7 +4408,7 @@
               <a:t>ã </a:t>
             </a:r>
             <a:r>
-              <a:rPr lang="" altLang="en-US"/>
+              <a:rPr lang="en-US" altLang="en-US"/>
               <a:t>đ</a:t>
             </a:r>
             <a:r>
@@ -9644,7 +9644,7 @@
               <a:t>Transaction </a:t>
             </a:r>
             <a:r>
-              <a:rPr lang="" altLang="en-US"/>
+              <a:rPr lang="en-US" altLang="en-US"/>
               <a:t>Đă</a:t>
             </a:r>
             <a:r>
@@ -9652,7 +9652,7 @@
               <a:t>ng k</a:t>
             </a:r>
             <a:r>
-              <a:rPr lang="" altLang="en-US"/>
+              <a:rPr lang="en-US" altLang="en-US"/>
               <a:t>ý</a:t>
             </a:r>
             <a:r>
@@ -9686,7 +9686,7 @@
               <a:t>Kiểm tra s</a:t>
             </a:r>
             <a:r>
-              <a:rPr lang="" altLang="en-US"/>
+              <a:rPr lang="en-US" altLang="en-US"/>
               <a:t>ĩ</a:t>
             </a:r>
             <a:r>
@@ -9702,7 +9702,7 @@
               <a:t>Thêm </a:t>
             </a:r>
             <a:r>
-              <a:rPr lang="" altLang="en-US"/>
+              <a:rPr lang="en-US" altLang="en-US"/>
               <a:t>đă</a:t>
             </a:r>
             <a:r>
@@ -9710,7 +9710,7 @@
               <a:t>ng k</a:t>
             </a:r>
             <a:r>
-              <a:rPr lang="" altLang="en-US"/>
+              <a:rPr lang="en-US" altLang="en-US"/>
               <a:t>ý</a:t>
             </a:r>
             <a:r>
@@ -9736,7 +9736,7 @@
               <a:t>Nếu có lỗi, hệ thống sẽ ROLLBACK </a:t>
             </a:r>
             <a:r>
-              <a:rPr lang="" altLang="en-US"/>
+              <a:rPr lang="en-US" altLang="en-US"/>
               <a:t>đ</a:t>
             </a:r>
             <a:r>
@@ -9744,7 +9744,7 @@
               <a:t>ể </a:t>
             </a:r>
             <a:r>
-              <a:rPr lang="" altLang="en-US"/>
+              <a:rPr lang="en-US" altLang="en-US"/>
               <a:t>đ</a:t>
             </a:r>
             <a:r>

</xml_diff>